<commit_message>
fix: card_grid multi-row layout — 7 definisi 4+3 grid, no overflow
</commit_message>
<xml_diff>
--- a/Perwal_Bekasi_51_2024_Pajak_Reklame.pptx
+++ b/Perwal_Bekasi_51_2024_Pajak_Reklame.pptx
@@ -4409,7 +4409,7 @@
         <p:spPr>
           <a:xfrm>
             <a:off x="548640" y="1051560"/>
-            <a:ext cx="5303520" cy="5166360"/>
+            <a:ext cx="5410047" cy="5166360"/>
           </a:xfrm>
           <a:prstGeom prst="roundRect">
             <a:avLst>
@@ -4499,7 +4499,7 @@
         <p:spPr>
           <a:xfrm>
             <a:off x="731520" y="1188720"/>
-            <a:ext cx="4983480" cy="274320"/>
+            <a:ext cx="5090007" cy="274320"/>
           </a:xfrm>
           <a:prstGeom prst="rect">
             <a:avLst/>
@@ -4539,7 +4539,7 @@
         <p:spPr>
           <a:xfrm>
             <a:off x="731520" y="1481328"/>
-            <a:ext cx="4983480" cy="201168"/>
+            <a:ext cx="5090007" cy="201168"/>
           </a:xfrm>
           <a:prstGeom prst="rect">
             <a:avLst/>
@@ -4579,7 +4579,7 @@
         <p:spPr>
           <a:xfrm>
             <a:off x="731520" y="1700784"/>
-            <a:ext cx="4983480" cy="201168"/>
+            <a:ext cx="5090007" cy="201168"/>
           </a:xfrm>
           <a:prstGeom prst="rect">
             <a:avLst/>
@@ -4619,7 +4619,7 @@
         <p:spPr>
           <a:xfrm>
             <a:off x="731520" y="1920240"/>
-            <a:ext cx="4983480" cy="201168"/>
+            <a:ext cx="5090007" cy="201168"/>
           </a:xfrm>
           <a:prstGeom prst="rect">
             <a:avLst/>
@@ -4659,7 +4659,7 @@
         <p:spPr>
           <a:xfrm>
             <a:off x="731520" y="2139696"/>
-            <a:ext cx="4983480" cy="201168"/>
+            <a:ext cx="5090007" cy="201168"/>
           </a:xfrm>
           <a:prstGeom prst="rect">
             <a:avLst/>
@@ -4699,7 +4699,7 @@
         <p:spPr>
           <a:xfrm>
             <a:off x="731520" y="2359152"/>
-            <a:ext cx="4983480" cy="201168"/>
+            <a:ext cx="5090007" cy="201168"/>
           </a:xfrm>
           <a:prstGeom prst="rect">
             <a:avLst/>
@@ -4739,7 +4739,7 @@
         <p:spPr>
           <a:xfrm>
             <a:off x="731520" y="2578608"/>
-            <a:ext cx="4983480" cy="201168"/>
+            <a:ext cx="5090007" cy="201168"/>
           </a:xfrm>
           <a:prstGeom prst="rect">
             <a:avLst/>
@@ -4779,7 +4779,7 @@
         <p:spPr>
           <a:xfrm>
             <a:off x="731520" y="2798064"/>
-            <a:ext cx="4983480" cy="201168"/>
+            <a:ext cx="5090007" cy="201168"/>
           </a:xfrm>
           <a:prstGeom prst="rect">
             <a:avLst/>
@@ -4818,8 +4818,8 @@
         </p:nvSpPr>
         <p:spPr>
           <a:xfrm>
-            <a:off x="6172200" y="1051560"/>
-            <a:ext cx="5303520" cy="5166360"/>
+            <a:off x="6233007" y="1051560"/>
+            <a:ext cx="5410047" cy="5166360"/>
           </a:xfrm>
           <a:prstGeom prst="roundRect">
             <a:avLst>
@@ -4865,7 +4865,7 @@
         </p:nvSpPr>
         <p:spPr>
           <a:xfrm>
-            <a:off x="6172200" y="1051560"/>
+            <a:off x="6233007" y="1051560"/>
             <a:ext cx="45720" cy="5166360"/>
           </a:xfrm>
           <a:prstGeom prst="rect">
@@ -4908,8 +4908,8 @@
         </p:nvSpPr>
         <p:spPr>
           <a:xfrm>
-            <a:off x="6355080" y="1188720"/>
-            <a:ext cx="4983480" cy="274320"/>
+            <a:off x="6415887" y="1188720"/>
+            <a:ext cx="5090007" cy="274320"/>
           </a:xfrm>
           <a:prstGeom prst="rect">
             <a:avLst/>
@@ -4948,8 +4948,8 @@
         </p:nvSpPr>
         <p:spPr>
           <a:xfrm>
-            <a:off x="6355080" y="1481328"/>
-            <a:ext cx="4983480" cy="201168"/>
+            <a:off x="6415887" y="1481328"/>
+            <a:ext cx="5090007" cy="201168"/>
           </a:xfrm>
           <a:prstGeom prst="rect">
             <a:avLst/>
@@ -4988,8 +4988,8 @@
         </p:nvSpPr>
         <p:spPr>
           <a:xfrm>
-            <a:off x="6355080" y="1700784"/>
-            <a:ext cx="4983480" cy="201168"/>
+            <a:off x="6415887" y="1700784"/>
+            <a:ext cx="5090007" cy="201168"/>
           </a:xfrm>
           <a:prstGeom prst="rect">
             <a:avLst/>
@@ -5028,8 +5028,8 @@
         </p:nvSpPr>
         <p:spPr>
           <a:xfrm>
-            <a:off x="6355080" y="1920240"/>
-            <a:ext cx="4983480" cy="201168"/>
+            <a:off x="6415887" y="1920240"/>
+            <a:ext cx="5090007" cy="201168"/>
           </a:xfrm>
           <a:prstGeom prst="rect">
             <a:avLst/>
@@ -5068,8 +5068,8 @@
         </p:nvSpPr>
         <p:spPr>
           <a:xfrm>
-            <a:off x="6355080" y="2139696"/>
-            <a:ext cx="4983480" cy="201168"/>
+            <a:off x="6415887" y="2139696"/>
+            <a:ext cx="5090007" cy="201168"/>
           </a:xfrm>
           <a:prstGeom prst="rect">
             <a:avLst/>
@@ -5108,8 +5108,8 @@
         </p:nvSpPr>
         <p:spPr>
           <a:xfrm>
-            <a:off x="6355080" y="2359152"/>
-            <a:ext cx="4983480" cy="201168"/>
+            <a:off x="6415887" y="2359152"/>
+            <a:ext cx="5090007" cy="201168"/>
           </a:xfrm>
           <a:prstGeom prst="rect">
             <a:avLst/>
@@ -5148,8 +5148,8 @@
         </p:nvSpPr>
         <p:spPr>
           <a:xfrm>
-            <a:off x="6355080" y="2578608"/>
-            <a:ext cx="4983480" cy="201168"/>
+            <a:off x="6415887" y="2578608"/>
+            <a:ext cx="5090007" cy="201168"/>
           </a:xfrm>
           <a:prstGeom prst="rect">
             <a:avLst/>
@@ -5188,8 +5188,8 @@
         </p:nvSpPr>
         <p:spPr>
           <a:xfrm>
-            <a:off x="6355080" y="2798064"/>
-            <a:ext cx="4983480" cy="201168"/>
+            <a:off x="6415887" y="2798064"/>
+            <a:ext cx="5090007" cy="201168"/>
           </a:xfrm>
           <a:prstGeom prst="rect">
             <a:avLst/>
@@ -8173,8 +8173,8 @@
         </p:nvSpPr>
         <p:spPr>
           <a:xfrm>
-            <a:off x="495147" y="1051560"/>
-            <a:ext cx="2560320" cy="2011680"/>
+            <a:off x="548640" y="1051560"/>
+            <a:ext cx="2567863" cy="2011680"/>
           </a:xfrm>
           <a:prstGeom prst="roundRect">
             <a:avLst>
@@ -8220,8 +8220,8 @@
         </p:nvSpPr>
         <p:spPr>
           <a:xfrm>
-            <a:off x="495147" y="1051560"/>
-            <a:ext cx="2560320" cy="45720"/>
+            <a:off x="548640" y="1051560"/>
+            <a:ext cx="2567863" cy="45720"/>
           </a:xfrm>
           <a:prstGeom prst="rect">
             <a:avLst/>
@@ -8263,8 +8263,8 @@
         </p:nvSpPr>
         <p:spPr>
           <a:xfrm>
-            <a:off x="495147" y="1280160"/>
-            <a:ext cx="2560320" cy="640080"/>
+            <a:off x="548640" y="1280160"/>
+            <a:ext cx="2567863" cy="640080"/>
           </a:xfrm>
           <a:prstGeom prst="rect">
             <a:avLst/>
@@ -8303,8 +8303,8 @@
         </p:nvSpPr>
         <p:spPr>
           <a:xfrm>
-            <a:off x="586587" y="1965960"/>
-            <a:ext cx="2377440" cy="640080"/>
+            <a:off x="640080" y="1965960"/>
+            <a:ext cx="2384983" cy="640080"/>
           </a:xfrm>
           <a:prstGeom prst="rect">
             <a:avLst/>
@@ -8347,8 +8347,8 @@
         </p:nvSpPr>
         <p:spPr>
           <a:xfrm>
-            <a:off x="3375507" y="1051560"/>
-            <a:ext cx="2560320" cy="2011680"/>
+            <a:off x="3390823" y="1051560"/>
+            <a:ext cx="2567863" cy="2011680"/>
           </a:xfrm>
           <a:prstGeom prst="roundRect">
             <a:avLst>
@@ -8394,8 +8394,8 @@
         </p:nvSpPr>
         <p:spPr>
           <a:xfrm>
-            <a:off x="3375507" y="1051560"/>
-            <a:ext cx="2560320" cy="45720"/>
+            <a:off x="3390823" y="1051560"/>
+            <a:ext cx="2567863" cy="45720"/>
           </a:xfrm>
           <a:prstGeom prst="rect">
             <a:avLst/>
@@ -8437,8 +8437,8 @@
         </p:nvSpPr>
         <p:spPr>
           <a:xfrm>
-            <a:off x="3375507" y="1280160"/>
-            <a:ext cx="2560320" cy="640080"/>
+            <a:off x="3390823" y="1280160"/>
+            <a:ext cx="2567863" cy="640080"/>
           </a:xfrm>
           <a:prstGeom prst="rect">
             <a:avLst/>
@@ -8477,8 +8477,8 @@
         </p:nvSpPr>
         <p:spPr>
           <a:xfrm>
-            <a:off x="3466947" y="1965960"/>
-            <a:ext cx="2377440" cy="640080"/>
+            <a:off x="3482263" y="1965960"/>
+            <a:ext cx="2384983" cy="640080"/>
           </a:xfrm>
           <a:prstGeom prst="rect">
             <a:avLst/>
@@ -8521,8 +8521,8 @@
         </p:nvSpPr>
         <p:spPr>
           <a:xfrm>
-            <a:off x="6255867" y="1051560"/>
-            <a:ext cx="2560320" cy="2011680"/>
+            <a:off x="6233007" y="1051560"/>
+            <a:ext cx="2567863" cy="2011680"/>
           </a:xfrm>
           <a:prstGeom prst="roundRect">
             <a:avLst>
@@ -8568,8 +8568,8 @@
         </p:nvSpPr>
         <p:spPr>
           <a:xfrm>
-            <a:off x="6255867" y="1051560"/>
-            <a:ext cx="2560320" cy="45720"/>
+            <a:off x="6233007" y="1051560"/>
+            <a:ext cx="2567863" cy="45720"/>
           </a:xfrm>
           <a:prstGeom prst="rect">
             <a:avLst/>
@@ -8611,8 +8611,8 @@
         </p:nvSpPr>
         <p:spPr>
           <a:xfrm>
-            <a:off x="6255867" y="1280160"/>
-            <a:ext cx="2560320" cy="640080"/>
+            <a:off x="6233007" y="1280160"/>
+            <a:ext cx="2567863" cy="640080"/>
           </a:xfrm>
           <a:prstGeom prst="rect">
             <a:avLst/>
@@ -8651,8 +8651,8 @@
         </p:nvSpPr>
         <p:spPr>
           <a:xfrm>
-            <a:off x="6347307" y="1965960"/>
-            <a:ext cx="2377440" cy="640080"/>
+            <a:off x="6324447" y="1965960"/>
+            <a:ext cx="2384983" cy="640080"/>
           </a:xfrm>
           <a:prstGeom prst="rect">
             <a:avLst/>
@@ -8695,8 +8695,8 @@
         </p:nvSpPr>
         <p:spPr>
           <a:xfrm>
-            <a:off x="9136227" y="1051560"/>
-            <a:ext cx="2560320" cy="2011680"/>
+            <a:off x="9075191" y="1051560"/>
+            <a:ext cx="2567863" cy="2011680"/>
           </a:xfrm>
           <a:prstGeom prst="roundRect">
             <a:avLst>
@@ -8742,8 +8742,8 @@
         </p:nvSpPr>
         <p:spPr>
           <a:xfrm>
-            <a:off x="9136227" y="1051560"/>
-            <a:ext cx="2560320" cy="45720"/>
+            <a:off x="9075191" y="1051560"/>
+            <a:ext cx="2567863" cy="45720"/>
           </a:xfrm>
           <a:prstGeom prst="rect">
             <a:avLst/>
@@ -8785,8 +8785,8 @@
         </p:nvSpPr>
         <p:spPr>
           <a:xfrm>
-            <a:off x="9136227" y="1280160"/>
-            <a:ext cx="2560320" cy="640080"/>
+            <a:off x="9075191" y="1280160"/>
+            <a:ext cx="2567863" cy="640080"/>
           </a:xfrm>
           <a:prstGeom prst="rect">
             <a:avLst/>
@@ -8825,8 +8825,8 @@
         </p:nvSpPr>
         <p:spPr>
           <a:xfrm>
-            <a:off x="9227667" y="1965960"/>
-            <a:ext cx="2377440" cy="640080"/>
+            <a:off x="9166631" y="1965960"/>
+            <a:ext cx="2384983" cy="640080"/>
           </a:xfrm>
           <a:prstGeom prst="rect">
             <a:avLst/>
@@ -11971,8 +11971,8 @@
         </p:nvSpPr>
         <p:spPr>
           <a:xfrm>
-            <a:off x="472287" y="1051560"/>
-            <a:ext cx="2606040" cy="5166360"/>
+            <a:off x="548640" y="1051560"/>
+            <a:ext cx="2567863" cy="5257800"/>
           </a:xfrm>
           <a:prstGeom prst="roundRect">
             <a:avLst>
@@ -12018,8 +12018,8 @@
         </p:nvSpPr>
         <p:spPr>
           <a:xfrm>
-            <a:off x="472287" y="1051560"/>
-            <a:ext cx="45720" cy="5166360"/>
+            <a:off x="548640" y="1051560"/>
+            <a:ext cx="45720" cy="5257800"/>
           </a:xfrm>
           <a:prstGeom prst="rect">
             <a:avLst/>
@@ -12061,7 +12061,7 @@
         </p:nvSpPr>
         <p:spPr>
           <a:xfrm>
-            <a:off x="609447" y="1188720"/>
+            <a:off x="685800" y="1188720"/>
             <a:ext cx="384048" cy="384048"/>
           </a:xfrm>
           <a:prstGeom prst="ellipse">
@@ -12104,7 +12104,7 @@
         </p:nvSpPr>
         <p:spPr>
           <a:xfrm>
-            <a:off x="609447" y="1188720"/>
+            <a:off x="685800" y="1188720"/>
             <a:ext cx="384048" cy="384048"/>
           </a:xfrm>
           <a:prstGeom prst="rect">
@@ -12144,8 +12144,8 @@
         </p:nvSpPr>
         <p:spPr>
           <a:xfrm>
-            <a:off x="609447" y="1691640"/>
-            <a:ext cx="2331720" cy="320040"/>
+            <a:off x="685800" y="1691640"/>
+            <a:ext cx="2293543" cy="274320"/>
           </a:xfrm>
           <a:prstGeom prst="rect">
             <a:avLst/>
@@ -12163,7 +12163,7 @@
               <a:spcAft>
                 <a:spcPts val="0"/>
               </a:spcAft>
-              <a:defRPr sz="1400" b="1">
+              <a:defRPr sz="1300" b="1">
                 <a:solidFill>
                   <a:srgbClr val="2563EB"/>
                 </a:solidFill>
@@ -12184,8 +12184,8 @@
         </p:nvSpPr>
         <p:spPr>
           <a:xfrm>
-            <a:off x="609447" y="2075688"/>
-            <a:ext cx="2331720" cy="228600"/>
+            <a:off x="685800" y="2011680"/>
+            <a:ext cx="2293543" cy="201168"/>
           </a:xfrm>
           <a:prstGeom prst="rect">
             <a:avLst/>
@@ -12203,7 +12203,7 @@
               <a:spcAft>
                 <a:spcPts val="0"/>
               </a:spcAft>
-              <a:defRPr sz="1000" b="0">
+              <a:defRPr sz="900" b="0">
                 <a:solidFill>
                   <a:srgbClr val="1A1A2E"/>
                 </a:solidFill>
@@ -12224,8 +12224,8 @@
         </p:nvSpPr>
         <p:spPr>
           <a:xfrm>
-            <a:off x="609447" y="2295144"/>
-            <a:ext cx="2331720" cy="228600"/>
+            <a:off x="685800" y="2212848"/>
+            <a:ext cx="2293543" cy="201168"/>
           </a:xfrm>
           <a:prstGeom prst="rect">
             <a:avLst/>
@@ -12243,7 +12243,7 @@
               <a:spcAft>
                 <a:spcPts val="0"/>
               </a:spcAft>
-              <a:defRPr sz="1000" b="0">
+              <a:defRPr sz="900" b="0">
                 <a:solidFill>
                   <a:srgbClr val="1A1A2E"/>
                 </a:solidFill>
@@ -12264,8 +12264,8 @@
         </p:nvSpPr>
         <p:spPr>
           <a:xfrm>
-            <a:off x="3352647" y="1051560"/>
-            <a:ext cx="2606040" cy="5166360"/>
+            <a:off x="3390823" y="1051560"/>
+            <a:ext cx="2567863" cy="5257800"/>
           </a:xfrm>
           <a:prstGeom prst="roundRect">
             <a:avLst>
@@ -12311,8 +12311,8 @@
         </p:nvSpPr>
         <p:spPr>
           <a:xfrm>
-            <a:off x="3352647" y="1051560"/>
-            <a:ext cx="45720" cy="5166360"/>
+            <a:off x="3390823" y="1051560"/>
+            <a:ext cx="45720" cy="5257800"/>
           </a:xfrm>
           <a:prstGeom prst="rect">
             <a:avLst/>
@@ -12354,7 +12354,7 @@
         </p:nvSpPr>
         <p:spPr>
           <a:xfrm>
-            <a:off x="3489807" y="1188720"/>
+            <a:off x="3527983" y="1188720"/>
             <a:ext cx="384048" cy="384048"/>
           </a:xfrm>
           <a:prstGeom prst="ellipse">
@@ -12397,7 +12397,7 @@
         </p:nvSpPr>
         <p:spPr>
           <a:xfrm>
-            <a:off x="3489807" y="1188720"/>
+            <a:off x="3527983" y="1188720"/>
             <a:ext cx="384048" cy="384048"/>
           </a:xfrm>
           <a:prstGeom prst="rect">
@@ -12437,8 +12437,8 @@
         </p:nvSpPr>
         <p:spPr>
           <a:xfrm>
-            <a:off x="3489807" y="1691640"/>
-            <a:ext cx="2331720" cy="320040"/>
+            <a:off x="3527983" y="1691640"/>
+            <a:ext cx="2293543" cy="274320"/>
           </a:xfrm>
           <a:prstGeom prst="rect">
             <a:avLst/>
@@ -12456,7 +12456,7 @@
               <a:spcAft>
                 <a:spcPts val="0"/>
               </a:spcAft>
-              <a:defRPr sz="1400" b="1">
+              <a:defRPr sz="1300" b="1">
                 <a:solidFill>
                   <a:srgbClr val="0D9488"/>
                 </a:solidFill>
@@ -12477,8 +12477,8 @@
         </p:nvSpPr>
         <p:spPr>
           <a:xfrm>
-            <a:off x="3489807" y="2075688"/>
-            <a:ext cx="2331720" cy="228600"/>
+            <a:off x="3527983" y="2011680"/>
+            <a:ext cx="2293543" cy="201168"/>
           </a:xfrm>
           <a:prstGeom prst="rect">
             <a:avLst/>
@@ -12496,7 +12496,7 @@
               <a:spcAft>
                 <a:spcPts val="0"/>
               </a:spcAft>
-              <a:defRPr sz="1000" b="0">
+              <a:defRPr sz="900" b="0">
                 <a:solidFill>
                   <a:srgbClr val="1A1A2E"/>
                 </a:solidFill>
@@ -12518,7 +12518,7 @@
         <p:spPr>
           <a:xfrm>
             <a:off x="6233007" y="1051560"/>
-            <a:ext cx="2606040" cy="5166360"/>
+            <a:ext cx="2567863" cy="5257800"/>
           </a:xfrm>
           <a:prstGeom prst="roundRect">
             <a:avLst>
@@ -12565,7 +12565,7 @@
         <p:spPr>
           <a:xfrm>
             <a:off x="6233007" y="1051560"/>
-            <a:ext cx="45720" cy="5166360"/>
+            <a:ext cx="45720" cy="5257800"/>
           </a:xfrm>
           <a:prstGeom prst="rect">
             <a:avLst/>
@@ -12691,7 +12691,7 @@
         <p:spPr>
           <a:xfrm>
             <a:off x="6370167" y="1691640"/>
-            <a:ext cx="2331720" cy="320040"/>
+            <a:ext cx="2293543" cy="274320"/>
           </a:xfrm>
           <a:prstGeom prst="rect">
             <a:avLst/>
@@ -12709,7 +12709,7 @@
               <a:spcAft>
                 <a:spcPts val="0"/>
               </a:spcAft>
-              <a:defRPr sz="1400" b="1">
+              <a:defRPr sz="1300" b="1">
                 <a:solidFill>
                   <a:srgbClr val="B8860B"/>
                 </a:solidFill>
@@ -12730,8 +12730,8 @@
         </p:nvSpPr>
         <p:spPr>
           <a:xfrm>
-            <a:off x="6370167" y="2075688"/>
-            <a:ext cx="2331720" cy="228600"/>
+            <a:off x="6370167" y="2011680"/>
+            <a:ext cx="2293543" cy="201168"/>
           </a:xfrm>
           <a:prstGeom prst="rect">
             <a:avLst/>
@@ -12749,7 +12749,7 @@
               <a:spcAft>
                 <a:spcPts val="0"/>
               </a:spcAft>
-              <a:defRPr sz="1000" b="0">
+              <a:defRPr sz="900" b="0">
                 <a:solidFill>
                   <a:srgbClr val="1A1A2E"/>
                 </a:solidFill>
@@ -12770,8 +12770,8 @@
         </p:nvSpPr>
         <p:spPr>
           <a:xfrm>
-            <a:off x="6370167" y="2295144"/>
-            <a:ext cx="2331720" cy="228600"/>
+            <a:off x="6370167" y="2212848"/>
+            <a:ext cx="2293543" cy="201168"/>
           </a:xfrm>
           <a:prstGeom prst="rect">
             <a:avLst/>
@@ -12789,7 +12789,7 @@
               <a:spcAft>
                 <a:spcPts val="0"/>
               </a:spcAft>
-              <a:defRPr sz="1000" b="0">
+              <a:defRPr sz="900" b="0">
                 <a:solidFill>
                   <a:srgbClr val="1A1A2E"/>
                 </a:solidFill>
@@ -12810,8 +12810,8 @@
         </p:nvSpPr>
         <p:spPr>
           <a:xfrm>
-            <a:off x="9113367" y="1051560"/>
-            <a:ext cx="2606040" cy="5166360"/>
+            <a:off x="9075191" y="1051560"/>
+            <a:ext cx="2567863" cy="5257800"/>
           </a:xfrm>
           <a:prstGeom prst="roundRect">
             <a:avLst>
@@ -12857,8 +12857,8 @@
         </p:nvSpPr>
         <p:spPr>
           <a:xfrm>
-            <a:off x="9113367" y="1051560"/>
-            <a:ext cx="45720" cy="5166360"/>
+            <a:off x="9075191" y="1051560"/>
+            <a:ext cx="45720" cy="5257800"/>
           </a:xfrm>
           <a:prstGeom prst="rect">
             <a:avLst/>
@@ -12900,7 +12900,7 @@
         </p:nvSpPr>
         <p:spPr>
           <a:xfrm>
-            <a:off x="9250527" y="1188720"/>
+            <a:off x="9212351" y="1188720"/>
             <a:ext cx="384048" cy="384048"/>
           </a:xfrm>
           <a:prstGeom prst="ellipse">
@@ -12943,7 +12943,7 @@
         </p:nvSpPr>
         <p:spPr>
           <a:xfrm>
-            <a:off x="9250527" y="1188720"/>
+            <a:off x="9212351" y="1188720"/>
             <a:ext cx="384048" cy="384048"/>
           </a:xfrm>
           <a:prstGeom prst="rect">
@@ -12983,8 +12983,8 @@
         </p:nvSpPr>
         <p:spPr>
           <a:xfrm>
-            <a:off x="9250527" y="1691640"/>
-            <a:ext cx="2331720" cy="320040"/>
+            <a:off x="9212351" y="1691640"/>
+            <a:ext cx="2293543" cy="274320"/>
           </a:xfrm>
           <a:prstGeom prst="rect">
             <a:avLst/>
@@ -13002,7 +13002,7 @@
               <a:spcAft>
                 <a:spcPts val="0"/>
               </a:spcAft>
-              <a:defRPr sz="1400" b="1">
+              <a:defRPr sz="1300" b="1">
                 <a:solidFill>
                   <a:srgbClr val="DC2626"/>
                 </a:solidFill>
@@ -13023,8 +13023,8 @@
         </p:nvSpPr>
         <p:spPr>
           <a:xfrm>
-            <a:off x="9250527" y="2075688"/>
-            <a:ext cx="2331720" cy="228600"/>
+            <a:off x="9212351" y="2011680"/>
+            <a:ext cx="2293543" cy="201168"/>
           </a:xfrm>
           <a:prstGeom prst="rect">
             <a:avLst/>
@@ -13042,7 +13042,7 @@
               <a:spcAft>
                 <a:spcPts val="0"/>
               </a:spcAft>
-              <a:defRPr sz="1000" b="0">
+              <a:defRPr sz="900" b="0">
                 <a:solidFill>
                   <a:srgbClr val="1A1A2E"/>
                 </a:solidFill>
@@ -13063,8 +13063,8 @@
         </p:nvSpPr>
         <p:spPr>
           <a:xfrm>
-            <a:off x="9250527" y="2295144"/>
-            <a:ext cx="2331720" cy="228600"/>
+            <a:off x="9212351" y="2212848"/>
+            <a:ext cx="2293543" cy="201168"/>
           </a:xfrm>
           <a:prstGeom prst="rect">
             <a:avLst/>
@@ -13082,7 +13082,7 @@
               <a:spcAft>
                 <a:spcPts val="0"/>
               </a:spcAft>
-              <a:defRPr sz="1000" b="0">
+              <a:defRPr sz="900" b="0">
                 <a:solidFill>
                   <a:srgbClr val="1A1A2E"/>
                 </a:solidFill>
@@ -15359,8 +15359,8 @@
         </p:nvSpPr>
         <p:spPr>
           <a:xfrm>
-            <a:off x="472287" y="1051560"/>
-            <a:ext cx="2606040" cy="5166360"/>
+            <a:off x="548640" y="1051560"/>
+            <a:ext cx="2567863" cy="5257800"/>
           </a:xfrm>
           <a:prstGeom prst="roundRect">
             <a:avLst>
@@ -15406,8 +15406,8 @@
         </p:nvSpPr>
         <p:spPr>
           <a:xfrm>
-            <a:off x="472287" y="1051560"/>
-            <a:ext cx="45720" cy="5166360"/>
+            <a:off x="548640" y="1051560"/>
+            <a:ext cx="45720" cy="5257800"/>
           </a:xfrm>
           <a:prstGeom prst="rect">
             <a:avLst/>
@@ -15449,7 +15449,7 @@
         </p:nvSpPr>
         <p:spPr>
           <a:xfrm>
-            <a:off x="609447" y="1188720"/>
+            <a:off x="685800" y="1188720"/>
             <a:ext cx="384048" cy="384048"/>
           </a:xfrm>
           <a:prstGeom prst="ellipse">
@@ -15492,7 +15492,7 @@
         </p:nvSpPr>
         <p:spPr>
           <a:xfrm>
-            <a:off x="609447" y="1188720"/>
+            <a:off x="685800" y="1188720"/>
             <a:ext cx="384048" cy="384048"/>
           </a:xfrm>
           <a:prstGeom prst="rect">
@@ -15532,8 +15532,8 @@
         </p:nvSpPr>
         <p:spPr>
           <a:xfrm>
-            <a:off x="609447" y="1691640"/>
-            <a:ext cx="2331720" cy="320040"/>
+            <a:off x="685800" y="1691640"/>
+            <a:ext cx="2293543" cy="274320"/>
           </a:xfrm>
           <a:prstGeom prst="rect">
             <a:avLst/>
@@ -15551,7 +15551,7 @@
               <a:spcAft>
                 <a:spcPts val="0"/>
               </a:spcAft>
-              <a:defRPr sz="1400" b="1">
+              <a:defRPr sz="1300" b="1">
                 <a:solidFill>
                   <a:srgbClr val="2563EB"/>
                 </a:solidFill>
@@ -15572,8 +15572,8 @@
         </p:nvSpPr>
         <p:spPr>
           <a:xfrm>
-            <a:off x="609447" y="2075688"/>
-            <a:ext cx="2331720" cy="228600"/>
+            <a:off x="685800" y="2011680"/>
+            <a:ext cx="2293543" cy="201168"/>
           </a:xfrm>
           <a:prstGeom prst="rect">
             <a:avLst/>
@@ -15591,7 +15591,7 @@
               <a:spcAft>
                 <a:spcPts val="0"/>
               </a:spcAft>
-              <a:defRPr sz="1000" b="0">
+              <a:defRPr sz="900" b="0">
                 <a:solidFill>
                   <a:srgbClr val="1A1A2E"/>
                 </a:solidFill>
@@ -15612,8 +15612,8 @@
         </p:nvSpPr>
         <p:spPr>
           <a:xfrm>
-            <a:off x="609447" y="2295144"/>
-            <a:ext cx="2331720" cy="228600"/>
+            <a:off x="685800" y="2212848"/>
+            <a:ext cx="2293543" cy="201168"/>
           </a:xfrm>
           <a:prstGeom prst="rect">
             <a:avLst/>
@@ -15631,7 +15631,7 @@
               <a:spcAft>
                 <a:spcPts val="0"/>
               </a:spcAft>
-              <a:defRPr sz="1000" b="0">
+              <a:defRPr sz="900" b="0">
                 <a:solidFill>
                   <a:srgbClr val="1A1A2E"/>
                 </a:solidFill>
@@ -15652,8 +15652,8 @@
         </p:nvSpPr>
         <p:spPr>
           <a:xfrm>
-            <a:off x="3352647" y="1051560"/>
-            <a:ext cx="2606040" cy="5166360"/>
+            <a:off x="3390823" y="1051560"/>
+            <a:ext cx="2567863" cy="5257800"/>
           </a:xfrm>
           <a:prstGeom prst="roundRect">
             <a:avLst>
@@ -15699,8 +15699,8 @@
         </p:nvSpPr>
         <p:spPr>
           <a:xfrm>
-            <a:off x="3352647" y="1051560"/>
-            <a:ext cx="45720" cy="5166360"/>
+            <a:off x="3390823" y="1051560"/>
+            <a:ext cx="45720" cy="5257800"/>
           </a:xfrm>
           <a:prstGeom prst="rect">
             <a:avLst/>
@@ -15742,7 +15742,7 @@
         </p:nvSpPr>
         <p:spPr>
           <a:xfrm>
-            <a:off x="3489807" y="1188720"/>
+            <a:off x="3527983" y="1188720"/>
             <a:ext cx="384048" cy="384048"/>
           </a:xfrm>
           <a:prstGeom prst="ellipse">
@@ -15785,7 +15785,7 @@
         </p:nvSpPr>
         <p:spPr>
           <a:xfrm>
-            <a:off x="3489807" y="1188720"/>
+            <a:off x="3527983" y="1188720"/>
             <a:ext cx="384048" cy="384048"/>
           </a:xfrm>
           <a:prstGeom prst="rect">
@@ -15825,8 +15825,8 @@
         </p:nvSpPr>
         <p:spPr>
           <a:xfrm>
-            <a:off x="3489807" y="1691640"/>
-            <a:ext cx="2331720" cy="320040"/>
+            <a:off x="3527983" y="1691640"/>
+            <a:ext cx="2293543" cy="274320"/>
           </a:xfrm>
           <a:prstGeom prst="rect">
             <a:avLst/>
@@ -15844,7 +15844,7 @@
               <a:spcAft>
                 <a:spcPts val="0"/>
               </a:spcAft>
-              <a:defRPr sz="1400" b="1">
+              <a:defRPr sz="1300" b="1">
                 <a:solidFill>
                   <a:srgbClr val="0D9488"/>
                 </a:solidFill>
@@ -15865,8 +15865,8 @@
         </p:nvSpPr>
         <p:spPr>
           <a:xfrm>
-            <a:off x="3489807" y="2075688"/>
-            <a:ext cx="2331720" cy="228600"/>
+            <a:off x="3527983" y="2011680"/>
+            <a:ext cx="2293543" cy="201168"/>
           </a:xfrm>
           <a:prstGeom prst="rect">
             <a:avLst/>
@@ -15884,7 +15884,7 @@
               <a:spcAft>
                 <a:spcPts val="0"/>
               </a:spcAft>
-              <a:defRPr sz="1000" b="0">
+              <a:defRPr sz="900" b="0">
                 <a:solidFill>
                   <a:srgbClr val="1A1A2E"/>
                 </a:solidFill>
@@ -15905,8 +15905,8 @@
         </p:nvSpPr>
         <p:spPr>
           <a:xfrm>
-            <a:off x="3489807" y="2295144"/>
-            <a:ext cx="2331720" cy="228600"/>
+            <a:off x="3527983" y="2212848"/>
+            <a:ext cx="2293543" cy="201168"/>
           </a:xfrm>
           <a:prstGeom prst="rect">
             <a:avLst/>
@@ -15924,7 +15924,7 @@
               <a:spcAft>
                 <a:spcPts val="0"/>
               </a:spcAft>
-              <a:defRPr sz="1000" b="0">
+              <a:defRPr sz="900" b="0">
                 <a:solidFill>
                   <a:srgbClr val="1A1A2E"/>
                 </a:solidFill>
@@ -15946,7 +15946,7 @@
         <p:spPr>
           <a:xfrm>
             <a:off x="6233007" y="1051560"/>
-            <a:ext cx="2606040" cy="5166360"/>
+            <a:ext cx="2567863" cy="5257800"/>
           </a:xfrm>
           <a:prstGeom prst="roundRect">
             <a:avLst>
@@ -15993,7 +15993,7 @@
         <p:spPr>
           <a:xfrm>
             <a:off x="6233007" y="1051560"/>
-            <a:ext cx="45720" cy="5166360"/>
+            <a:ext cx="45720" cy="5257800"/>
           </a:xfrm>
           <a:prstGeom prst="rect">
             <a:avLst/>
@@ -16119,7 +16119,7 @@
         <p:spPr>
           <a:xfrm>
             <a:off x="6370167" y="1691640"/>
-            <a:ext cx="2331720" cy="320040"/>
+            <a:ext cx="2293543" cy="274320"/>
           </a:xfrm>
           <a:prstGeom prst="rect">
             <a:avLst/>
@@ -16137,7 +16137,7 @@
               <a:spcAft>
                 <a:spcPts val="0"/>
               </a:spcAft>
-              <a:defRPr sz="1400" b="1">
+              <a:defRPr sz="1300" b="1">
                 <a:solidFill>
                   <a:srgbClr val="B8860B"/>
                 </a:solidFill>
@@ -16158,8 +16158,8 @@
         </p:nvSpPr>
         <p:spPr>
           <a:xfrm>
-            <a:off x="6370167" y="2075688"/>
-            <a:ext cx="2331720" cy="228600"/>
+            <a:off x="6370167" y="2011680"/>
+            <a:ext cx="2293543" cy="201168"/>
           </a:xfrm>
           <a:prstGeom prst="rect">
             <a:avLst/>
@@ -16177,7 +16177,7 @@
               <a:spcAft>
                 <a:spcPts val="0"/>
               </a:spcAft>
-              <a:defRPr sz="1000" b="0">
+              <a:defRPr sz="900" b="0">
                 <a:solidFill>
                   <a:srgbClr val="1A1A2E"/>
                 </a:solidFill>
@@ -16198,8 +16198,8 @@
         </p:nvSpPr>
         <p:spPr>
           <a:xfrm>
-            <a:off x="9113367" y="1051560"/>
-            <a:ext cx="2606040" cy="5166360"/>
+            <a:off x="9075191" y="1051560"/>
+            <a:ext cx="2567863" cy="5257800"/>
           </a:xfrm>
           <a:prstGeom prst="roundRect">
             <a:avLst>
@@ -16245,8 +16245,8 @@
         </p:nvSpPr>
         <p:spPr>
           <a:xfrm>
-            <a:off x="9113367" y="1051560"/>
-            <a:ext cx="45720" cy="5166360"/>
+            <a:off x="9075191" y="1051560"/>
+            <a:ext cx="45720" cy="5257800"/>
           </a:xfrm>
           <a:prstGeom prst="rect">
             <a:avLst/>
@@ -16288,7 +16288,7 @@
         </p:nvSpPr>
         <p:spPr>
           <a:xfrm>
-            <a:off x="9250527" y="1188720"/>
+            <a:off x="9212351" y="1188720"/>
             <a:ext cx="384048" cy="384048"/>
           </a:xfrm>
           <a:prstGeom prst="ellipse">
@@ -16331,7 +16331,7 @@
         </p:nvSpPr>
         <p:spPr>
           <a:xfrm>
-            <a:off x="9250527" y="1188720"/>
+            <a:off x="9212351" y="1188720"/>
             <a:ext cx="384048" cy="384048"/>
           </a:xfrm>
           <a:prstGeom prst="rect">
@@ -16371,8 +16371,8 @@
         </p:nvSpPr>
         <p:spPr>
           <a:xfrm>
-            <a:off x="9250527" y="1691640"/>
-            <a:ext cx="2331720" cy="320040"/>
+            <a:off x="9212351" y="1691640"/>
+            <a:ext cx="2293543" cy="274320"/>
           </a:xfrm>
           <a:prstGeom prst="rect">
             <a:avLst/>
@@ -16390,7 +16390,7 @@
               <a:spcAft>
                 <a:spcPts val="0"/>
               </a:spcAft>
-              <a:defRPr sz="1400" b="1">
+              <a:defRPr sz="1300" b="1">
                 <a:solidFill>
                   <a:srgbClr val="DC2626"/>
                 </a:solidFill>
@@ -16411,8 +16411,8 @@
         </p:nvSpPr>
         <p:spPr>
           <a:xfrm>
-            <a:off x="9250527" y="2075688"/>
-            <a:ext cx="2331720" cy="228600"/>
+            <a:off x="9212351" y="2011680"/>
+            <a:ext cx="2293543" cy="201168"/>
           </a:xfrm>
           <a:prstGeom prst="rect">
             <a:avLst/>
@@ -16430,7 +16430,7 @@
               <a:spcAft>
                 <a:spcPts val="0"/>
               </a:spcAft>
-              <a:defRPr sz="1000" b="0">
+              <a:defRPr sz="900" b="0">
                 <a:solidFill>
                   <a:srgbClr val="1A1A2E"/>
                 </a:solidFill>
@@ -17257,8 +17257,8 @@
         </p:nvSpPr>
         <p:spPr>
           <a:xfrm>
-            <a:off x="655167" y="1188720"/>
-            <a:ext cx="2377440" cy="1828800"/>
+            <a:off x="548640" y="1188720"/>
+            <a:ext cx="2533573" cy="1828800"/>
           </a:xfrm>
           <a:prstGeom prst="roundRect">
             <a:avLst>
@@ -17304,8 +17304,8 @@
         </p:nvSpPr>
         <p:spPr>
           <a:xfrm>
-            <a:off x="655167" y="1188720"/>
-            <a:ext cx="2377440" cy="45720"/>
+            <a:off x="548640" y="1188720"/>
+            <a:ext cx="2533573" cy="45720"/>
           </a:xfrm>
           <a:prstGeom prst="rect">
             <a:avLst/>
@@ -17347,7 +17347,7 @@
         </p:nvSpPr>
         <p:spPr>
           <a:xfrm>
-            <a:off x="1615287" y="1325880"/>
+            <a:off x="1586826" y="1325880"/>
             <a:ext cx="457200" cy="457200"/>
           </a:xfrm>
           <a:prstGeom prst="ellipse">
@@ -17390,7 +17390,7 @@
         </p:nvSpPr>
         <p:spPr>
           <a:xfrm>
-            <a:off x="1615287" y="1325880"/>
+            <a:off x="1586826" y="1325880"/>
             <a:ext cx="457200" cy="457200"/>
           </a:xfrm>
           <a:prstGeom prst="rect">
@@ -17430,8 +17430,8 @@
         </p:nvSpPr>
         <p:spPr>
           <a:xfrm>
-            <a:off x="746607" y="1874520"/>
-            <a:ext cx="2194560" cy="320040"/>
+            <a:off x="640080" y="1874520"/>
+            <a:ext cx="2350693" cy="320040"/>
           </a:xfrm>
           <a:prstGeom prst="rect">
             <a:avLst/>
@@ -17470,8 +17470,8 @@
         </p:nvSpPr>
         <p:spPr>
           <a:xfrm>
-            <a:off x="746607" y="2194560"/>
-            <a:ext cx="2194560" cy="640080"/>
+            <a:off x="640080" y="2194560"/>
+            <a:ext cx="2350693" cy="640080"/>
           </a:xfrm>
           <a:prstGeom prst="rect">
             <a:avLst/>
@@ -17514,8 +17514,8 @@
         </p:nvSpPr>
         <p:spPr>
           <a:xfrm>
-            <a:off x="3032607" y="1828800"/>
-            <a:ext cx="457200" cy="457200"/>
+            <a:off x="3082213" y="1828800"/>
+            <a:ext cx="320040" cy="457200"/>
           </a:xfrm>
           <a:prstGeom prst="rect">
             <a:avLst/>
@@ -17554,8 +17554,8 @@
         </p:nvSpPr>
         <p:spPr>
           <a:xfrm>
-            <a:off x="3489807" y="1188720"/>
-            <a:ext cx="2377440" cy="1828800"/>
+            <a:off x="3402253" y="1188720"/>
+            <a:ext cx="2533573" cy="1828800"/>
           </a:xfrm>
           <a:prstGeom prst="roundRect">
             <a:avLst>
@@ -17601,8 +17601,8 @@
         </p:nvSpPr>
         <p:spPr>
           <a:xfrm>
-            <a:off x="3489807" y="1188720"/>
-            <a:ext cx="2377440" cy="45720"/>
+            <a:off x="3402253" y="1188720"/>
+            <a:ext cx="2533573" cy="45720"/>
           </a:xfrm>
           <a:prstGeom prst="rect">
             <a:avLst/>
@@ -17644,7 +17644,7 @@
         </p:nvSpPr>
         <p:spPr>
           <a:xfrm>
-            <a:off x="4449927" y="1325880"/>
+            <a:off x="4440440" y="1325880"/>
             <a:ext cx="457200" cy="457200"/>
           </a:xfrm>
           <a:prstGeom prst="ellipse">
@@ -17687,7 +17687,7 @@
         </p:nvSpPr>
         <p:spPr>
           <a:xfrm>
-            <a:off x="4449927" y="1325880"/>
+            <a:off x="4440440" y="1325880"/>
             <a:ext cx="457200" cy="457200"/>
           </a:xfrm>
           <a:prstGeom prst="rect">
@@ -17727,8 +17727,8 @@
         </p:nvSpPr>
         <p:spPr>
           <a:xfrm>
-            <a:off x="3581247" y="1874520"/>
-            <a:ext cx="2194560" cy="320040"/>
+            <a:off x="3493693" y="1874520"/>
+            <a:ext cx="2350693" cy="320040"/>
           </a:xfrm>
           <a:prstGeom prst="rect">
             <a:avLst/>
@@ -17767,8 +17767,8 @@
         </p:nvSpPr>
         <p:spPr>
           <a:xfrm>
-            <a:off x="3581247" y="2194560"/>
-            <a:ext cx="2194560" cy="640080"/>
+            <a:off x="3493693" y="2194560"/>
+            <a:ext cx="2350693" cy="640080"/>
           </a:xfrm>
           <a:prstGeom prst="rect">
             <a:avLst/>
@@ -17811,8 +17811,8 @@
         </p:nvSpPr>
         <p:spPr>
           <a:xfrm>
-            <a:off x="5867247" y="1828800"/>
-            <a:ext cx="457200" cy="457200"/>
+            <a:off x="5935827" y="1828800"/>
+            <a:ext cx="320040" cy="457200"/>
           </a:xfrm>
           <a:prstGeom prst="rect">
             <a:avLst/>
@@ -17851,8 +17851,8 @@
         </p:nvSpPr>
         <p:spPr>
           <a:xfrm>
-            <a:off x="6324447" y="1188720"/>
-            <a:ext cx="2377440" cy="1828800"/>
+            <a:off x="6255867" y="1188720"/>
+            <a:ext cx="2533573" cy="1828800"/>
           </a:xfrm>
           <a:prstGeom prst="roundRect">
             <a:avLst>
@@ -17898,8 +17898,8 @@
         </p:nvSpPr>
         <p:spPr>
           <a:xfrm>
-            <a:off x="6324447" y="1188720"/>
-            <a:ext cx="2377440" cy="45720"/>
+            <a:off x="6255867" y="1188720"/>
+            <a:ext cx="2533573" cy="45720"/>
           </a:xfrm>
           <a:prstGeom prst="rect">
             <a:avLst/>
@@ -17941,7 +17941,7 @@
         </p:nvSpPr>
         <p:spPr>
           <a:xfrm>
-            <a:off x="7284567" y="1325880"/>
+            <a:off x="7294054" y="1325880"/>
             <a:ext cx="457200" cy="457200"/>
           </a:xfrm>
           <a:prstGeom prst="ellipse">
@@ -17984,7 +17984,7 @@
         </p:nvSpPr>
         <p:spPr>
           <a:xfrm>
-            <a:off x="7284567" y="1325880"/>
+            <a:off x="7294054" y="1325880"/>
             <a:ext cx="457200" cy="457200"/>
           </a:xfrm>
           <a:prstGeom prst="rect">
@@ -18024,8 +18024,8 @@
         </p:nvSpPr>
         <p:spPr>
           <a:xfrm>
-            <a:off x="6415887" y="1874520"/>
-            <a:ext cx="2194560" cy="320040"/>
+            <a:off x="6347307" y="1874520"/>
+            <a:ext cx="2350693" cy="320040"/>
           </a:xfrm>
           <a:prstGeom prst="rect">
             <a:avLst/>
@@ -18064,8 +18064,8 @@
         </p:nvSpPr>
         <p:spPr>
           <a:xfrm>
-            <a:off x="6415887" y="2194560"/>
-            <a:ext cx="2194560" cy="640080"/>
+            <a:off x="6347307" y="2194560"/>
+            <a:ext cx="2350693" cy="640080"/>
           </a:xfrm>
           <a:prstGeom prst="rect">
             <a:avLst/>
@@ -18108,8 +18108,8 @@
         </p:nvSpPr>
         <p:spPr>
           <a:xfrm>
-            <a:off x="8701887" y="1828800"/>
-            <a:ext cx="457200" cy="457200"/>
+            <a:off x="8789441" y="1828800"/>
+            <a:ext cx="320040" cy="457200"/>
           </a:xfrm>
           <a:prstGeom prst="rect">
             <a:avLst/>
@@ -18148,8 +18148,8 @@
         </p:nvSpPr>
         <p:spPr>
           <a:xfrm>
-            <a:off x="9159087" y="1188720"/>
-            <a:ext cx="2377440" cy="1828800"/>
+            <a:off x="9109481" y="1188720"/>
+            <a:ext cx="2533573" cy="1828800"/>
           </a:xfrm>
           <a:prstGeom prst="roundRect">
             <a:avLst>
@@ -18195,8 +18195,8 @@
         </p:nvSpPr>
         <p:spPr>
           <a:xfrm>
-            <a:off x="9159087" y="1188720"/>
-            <a:ext cx="2377440" cy="45720"/>
+            <a:off x="9109481" y="1188720"/>
+            <a:ext cx="2533573" cy="45720"/>
           </a:xfrm>
           <a:prstGeom prst="rect">
             <a:avLst/>
@@ -18238,7 +18238,7 @@
         </p:nvSpPr>
         <p:spPr>
           <a:xfrm>
-            <a:off x="10119207" y="1325880"/>
+            <a:off x="10147668" y="1325880"/>
             <a:ext cx="457200" cy="457200"/>
           </a:xfrm>
           <a:prstGeom prst="ellipse">
@@ -18281,7 +18281,7 @@
         </p:nvSpPr>
         <p:spPr>
           <a:xfrm>
-            <a:off x="10119207" y="1325880"/>
+            <a:off x="10147668" y="1325880"/>
             <a:ext cx="457200" cy="457200"/>
           </a:xfrm>
           <a:prstGeom prst="rect">
@@ -18321,8 +18321,8 @@
         </p:nvSpPr>
         <p:spPr>
           <a:xfrm>
-            <a:off x="9250527" y="1874520"/>
-            <a:ext cx="2194560" cy="320040"/>
+            <a:off x="9200921" y="1874520"/>
+            <a:ext cx="2350693" cy="320040"/>
           </a:xfrm>
           <a:prstGeom prst="rect">
             <a:avLst/>
@@ -18361,8 +18361,8 @@
         </p:nvSpPr>
         <p:spPr>
           <a:xfrm>
-            <a:off x="9250527" y="2194560"/>
-            <a:ext cx="2194560" cy="640080"/>
+            <a:off x="9200921" y="2194560"/>
+            <a:ext cx="2350693" cy="640080"/>
           </a:xfrm>
           <a:prstGeom prst="rect">
             <a:avLst/>
@@ -19311,7 +19311,7 @@
         <p:spPr>
           <a:xfrm>
             <a:off x="548640" y="1051560"/>
-            <a:ext cx="5303520" cy="5166360"/>
+            <a:ext cx="5410047" cy="5166360"/>
           </a:xfrm>
           <a:prstGeom prst="roundRect">
             <a:avLst>
@@ -19401,7 +19401,7 @@
         <p:spPr>
           <a:xfrm>
             <a:off x="731520" y="1188720"/>
-            <a:ext cx="4983480" cy="274320"/>
+            <a:ext cx="5090007" cy="274320"/>
           </a:xfrm>
           <a:prstGeom prst="rect">
             <a:avLst/>
@@ -19441,7 +19441,7 @@
         <p:spPr>
           <a:xfrm>
             <a:off x="731520" y="1481328"/>
-            <a:ext cx="4983480" cy="201168"/>
+            <a:ext cx="5090007" cy="201168"/>
           </a:xfrm>
           <a:prstGeom prst="rect">
             <a:avLst/>
@@ -19481,7 +19481,7 @@
         <p:spPr>
           <a:xfrm>
             <a:off x="731520" y="1700784"/>
-            <a:ext cx="4983480" cy="201168"/>
+            <a:ext cx="5090007" cy="201168"/>
           </a:xfrm>
           <a:prstGeom prst="rect">
             <a:avLst/>
@@ -19521,7 +19521,7 @@
         <p:spPr>
           <a:xfrm>
             <a:off x="731520" y="1920240"/>
-            <a:ext cx="4983480" cy="201168"/>
+            <a:ext cx="5090007" cy="201168"/>
           </a:xfrm>
           <a:prstGeom prst="rect">
             <a:avLst/>
@@ -19561,7 +19561,7 @@
         <p:spPr>
           <a:xfrm>
             <a:off x="731520" y="2139696"/>
-            <a:ext cx="4983480" cy="201168"/>
+            <a:ext cx="5090007" cy="201168"/>
           </a:xfrm>
           <a:prstGeom prst="rect">
             <a:avLst/>
@@ -19601,7 +19601,7 @@
         <p:spPr>
           <a:xfrm>
             <a:off x="731520" y="2359152"/>
-            <a:ext cx="4983480" cy="201168"/>
+            <a:ext cx="5090007" cy="201168"/>
           </a:xfrm>
           <a:prstGeom prst="rect">
             <a:avLst/>
@@ -19641,7 +19641,7 @@
         <p:spPr>
           <a:xfrm>
             <a:off x="731520" y="2578608"/>
-            <a:ext cx="4983480" cy="201168"/>
+            <a:ext cx="5090007" cy="201168"/>
           </a:xfrm>
           <a:prstGeom prst="rect">
             <a:avLst/>
@@ -19681,7 +19681,7 @@
         <p:spPr>
           <a:xfrm>
             <a:off x="731520" y="2798064"/>
-            <a:ext cx="4983480" cy="201168"/>
+            <a:ext cx="5090007" cy="201168"/>
           </a:xfrm>
           <a:prstGeom prst="rect">
             <a:avLst/>
@@ -19721,7 +19721,7 @@
         <p:spPr>
           <a:xfrm>
             <a:off x="731520" y="3017520"/>
-            <a:ext cx="4983480" cy="201168"/>
+            <a:ext cx="5090007" cy="201168"/>
           </a:xfrm>
           <a:prstGeom prst="rect">
             <a:avLst/>
@@ -19761,7 +19761,7 @@
         <p:spPr>
           <a:xfrm>
             <a:off x="731520" y="3236976"/>
-            <a:ext cx="4983480" cy="201168"/>
+            <a:ext cx="5090007" cy="201168"/>
           </a:xfrm>
           <a:prstGeom prst="rect">
             <a:avLst/>
@@ -19800,8 +19800,8 @@
         </p:nvSpPr>
         <p:spPr>
           <a:xfrm>
-            <a:off x="6172200" y="1051560"/>
-            <a:ext cx="5303520" cy="5166360"/>
+            <a:off x="6233007" y="1051560"/>
+            <a:ext cx="5410047" cy="5166360"/>
           </a:xfrm>
           <a:prstGeom prst="roundRect">
             <a:avLst>
@@ -19847,7 +19847,7 @@
         </p:nvSpPr>
         <p:spPr>
           <a:xfrm>
-            <a:off x="6172200" y="1051560"/>
+            <a:off x="6233007" y="1051560"/>
             <a:ext cx="45720" cy="5166360"/>
           </a:xfrm>
           <a:prstGeom prst="rect">
@@ -19890,8 +19890,8 @@
         </p:nvSpPr>
         <p:spPr>
           <a:xfrm>
-            <a:off x="6355080" y="1188720"/>
-            <a:ext cx="4983480" cy="274320"/>
+            <a:off x="6415887" y="1188720"/>
+            <a:ext cx="5090007" cy="274320"/>
           </a:xfrm>
           <a:prstGeom prst="rect">
             <a:avLst/>
@@ -19930,8 +19930,8 @@
         </p:nvSpPr>
         <p:spPr>
           <a:xfrm>
-            <a:off x="6355080" y="1481328"/>
-            <a:ext cx="4983480" cy="201168"/>
+            <a:off x="6415887" y="1481328"/>
+            <a:ext cx="5090007" cy="201168"/>
           </a:xfrm>
           <a:prstGeom prst="rect">
             <a:avLst/>
@@ -19970,8 +19970,8 @@
         </p:nvSpPr>
         <p:spPr>
           <a:xfrm>
-            <a:off x="6355080" y="1700784"/>
-            <a:ext cx="4983480" cy="201168"/>
+            <a:off x="6415887" y="1700784"/>
+            <a:ext cx="5090007" cy="201168"/>
           </a:xfrm>
           <a:prstGeom prst="rect">
             <a:avLst/>
@@ -20010,8 +20010,8 @@
         </p:nvSpPr>
         <p:spPr>
           <a:xfrm>
-            <a:off x="6355080" y="1920240"/>
-            <a:ext cx="4983480" cy="201168"/>
+            <a:off x="6415887" y="1920240"/>
+            <a:ext cx="5090007" cy="201168"/>
           </a:xfrm>
           <a:prstGeom prst="rect">
             <a:avLst/>
@@ -20050,8 +20050,8 @@
         </p:nvSpPr>
         <p:spPr>
           <a:xfrm>
-            <a:off x="6355080" y="2139696"/>
-            <a:ext cx="4983480" cy="201168"/>
+            <a:off x="6415887" y="2139696"/>
+            <a:ext cx="5090007" cy="201168"/>
           </a:xfrm>
           <a:prstGeom prst="rect">
             <a:avLst/>
@@ -20090,8 +20090,8 @@
         </p:nvSpPr>
         <p:spPr>
           <a:xfrm>
-            <a:off x="6355080" y="2359152"/>
-            <a:ext cx="4983480" cy="201168"/>
+            <a:off x="6415887" y="2359152"/>
+            <a:ext cx="5090007" cy="201168"/>
           </a:xfrm>
           <a:prstGeom prst="rect">
             <a:avLst/>
@@ -20130,8 +20130,8 @@
         </p:nvSpPr>
         <p:spPr>
           <a:xfrm>
-            <a:off x="6355080" y="2578608"/>
-            <a:ext cx="4983480" cy="201168"/>
+            <a:off x="6415887" y="2578608"/>
+            <a:ext cx="5090007" cy="201168"/>
           </a:xfrm>
           <a:prstGeom prst="rect">
             <a:avLst/>
@@ -20529,7 +20529,7 @@
         <p:spPr>
           <a:xfrm>
             <a:off x="548640" y="1051560"/>
-            <a:ext cx="5303520" cy="5166360"/>
+            <a:ext cx="5410047" cy="5166360"/>
           </a:xfrm>
           <a:prstGeom prst="roundRect">
             <a:avLst>
@@ -20619,7 +20619,7 @@
         <p:spPr>
           <a:xfrm>
             <a:off x="731520" y="1188720"/>
-            <a:ext cx="4983480" cy="274320"/>
+            <a:ext cx="5090007" cy="274320"/>
           </a:xfrm>
           <a:prstGeom prst="rect">
             <a:avLst/>
@@ -20659,7 +20659,7 @@
         <p:spPr>
           <a:xfrm>
             <a:off x="731520" y="1481328"/>
-            <a:ext cx="4983480" cy="201168"/>
+            <a:ext cx="5090007" cy="201168"/>
           </a:xfrm>
           <a:prstGeom prst="rect">
             <a:avLst/>
@@ -20699,7 +20699,7 @@
         <p:spPr>
           <a:xfrm>
             <a:off x="731520" y="1700784"/>
-            <a:ext cx="4983480" cy="201168"/>
+            <a:ext cx="5090007" cy="201168"/>
           </a:xfrm>
           <a:prstGeom prst="rect">
             <a:avLst/>
@@ -20739,7 +20739,7 @@
         <p:spPr>
           <a:xfrm>
             <a:off x="731520" y="1920240"/>
-            <a:ext cx="4983480" cy="201168"/>
+            <a:ext cx="5090007" cy="201168"/>
           </a:xfrm>
           <a:prstGeom prst="rect">
             <a:avLst/>
@@ -20779,7 +20779,7 @@
         <p:spPr>
           <a:xfrm>
             <a:off x="731520" y="2139696"/>
-            <a:ext cx="4983480" cy="201168"/>
+            <a:ext cx="5090007" cy="201168"/>
           </a:xfrm>
           <a:prstGeom prst="rect">
             <a:avLst/>
@@ -20819,7 +20819,7 @@
         <p:spPr>
           <a:xfrm>
             <a:off x="731520" y="2359152"/>
-            <a:ext cx="4983480" cy="201168"/>
+            <a:ext cx="5090007" cy="201168"/>
           </a:xfrm>
           <a:prstGeom prst="rect">
             <a:avLst/>
@@ -20859,7 +20859,7 @@
         <p:spPr>
           <a:xfrm>
             <a:off x="731520" y="2578608"/>
-            <a:ext cx="4983480" cy="201168"/>
+            <a:ext cx="5090007" cy="201168"/>
           </a:xfrm>
           <a:prstGeom prst="rect">
             <a:avLst/>
@@ -20899,7 +20899,7 @@
         <p:spPr>
           <a:xfrm>
             <a:off x="731520" y="2798064"/>
-            <a:ext cx="4983480" cy="201168"/>
+            <a:ext cx="5090007" cy="201168"/>
           </a:xfrm>
           <a:prstGeom prst="rect">
             <a:avLst/>
@@ -20938,8 +20938,8 @@
         </p:nvSpPr>
         <p:spPr>
           <a:xfrm>
-            <a:off x="6172200" y="1051560"/>
-            <a:ext cx="5303520" cy="5166360"/>
+            <a:off x="6233007" y="1051560"/>
+            <a:ext cx="5410047" cy="5166360"/>
           </a:xfrm>
           <a:prstGeom prst="roundRect">
             <a:avLst>
@@ -20985,7 +20985,7 @@
         </p:nvSpPr>
         <p:spPr>
           <a:xfrm>
-            <a:off x="6172200" y="1051560"/>
+            <a:off x="6233007" y="1051560"/>
             <a:ext cx="45720" cy="5166360"/>
           </a:xfrm>
           <a:prstGeom prst="rect">
@@ -21028,8 +21028,8 @@
         </p:nvSpPr>
         <p:spPr>
           <a:xfrm>
-            <a:off x="6355080" y="1188720"/>
-            <a:ext cx="4983480" cy="274320"/>
+            <a:off x="6415887" y="1188720"/>
+            <a:ext cx="5090007" cy="274320"/>
           </a:xfrm>
           <a:prstGeom prst="rect">
             <a:avLst/>
@@ -21068,8 +21068,8 @@
         </p:nvSpPr>
         <p:spPr>
           <a:xfrm>
-            <a:off x="6355080" y="1481328"/>
-            <a:ext cx="4983480" cy="201168"/>
+            <a:off x="6415887" y="1481328"/>
+            <a:ext cx="5090007" cy="201168"/>
           </a:xfrm>
           <a:prstGeom prst="rect">
             <a:avLst/>
@@ -21108,8 +21108,8 @@
         </p:nvSpPr>
         <p:spPr>
           <a:xfrm>
-            <a:off x="6355080" y="1700784"/>
-            <a:ext cx="4983480" cy="201168"/>
+            <a:off x="6415887" y="1700784"/>
+            <a:ext cx="5090007" cy="201168"/>
           </a:xfrm>
           <a:prstGeom prst="rect">
             <a:avLst/>
@@ -21148,8 +21148,8 @@
         </p:nvSpPr>
         <p:spPr>
           <a:xfrm>
-            <a:off x="6355080" y="1920240"/>
-            <a:ext cx="4983480" cy="201168"/>
+            <a:off x="6415887" y="1920240"/>
+            <a:ext cx="5090007" cy="201168"/>
           </a:xfrm>
           <a:prstGeom prst="rect">
             <a:avLst/>
@@ -21188,8 +21188,8 @@
         </p:nvSpPr>
         <p:spPr>
           <a:xfrm>
-            <a:off x="6355080" y="2139696"/>
-            <a:ext cx="4983480" cy="201168"/>
+            <a:off x="6415887" y="2139696"/>
+            <a:ext cx="5090007" cy="201168"/>
           </a:xfrm>
           <a:prstGeom prst="rect">
             <a:avLst/>
@@ -21228,8 +21228,8 @@
         </p:nvSpPr>
         <p:spPr>
           <a:xfrm>
-            <a:off x="6355080" y="2359152"/>
-            <a:ext cx="4983480" cy="201168"/>
+            <a:off x="6415887" y="2359152"/>
+            <a:ext cx="5090007" cy="201168"/>
           </a:xfrm>
           <a:prstGeom prst="rect">
             <a:avLst/>
@@ -21268,8 +21268,8 @@
         </p:nvSpPr>
         <p:spPr>
           <a:xfrm>
-            <a:off x="6355080" y="2578608"/>
-            <a:ext cx="4983480" cy="201168"/>
+            <a:off x="6415887" y="2578608"/>
+            <a:ext cx="5090007" cy="201168"/>
           </a:xfrm>
           <a:prstGeom prst="rect">
             <a:avLst/>
@@ -21308,8 +21308,8 @@
         </p:nvSpPr>
         <p:spPr>
           <a:xfrm>
-            <a:off x="6355080" y="2798064"/>
-            <a:ext cx="4983480" cy="201168"/>
+            <a:off x="6415887" y="2798064"/>
+            <a:ext cx="5090007" cy="201168"/>
           </a:xfrm>
           <a:prstGeom prst="rect">
             <a:avLst/>
@@ -22154,8 +22154,8 @@
         </p:nvSpPr>
         <p:spPr>
           <a:xfrm>
-            <a:off x="540867" y="1051560"/>
-            <a:ext cx="3520440" cy="5166360"/>
+            <a:off x="548640" y="1051560"/>
+            <a:ext cx="3515258" cy="5257800"/>
           </a:xfrm>
           <a:prstGeom prst="roundRect">
             <a:avLst>
@@ -22201,8 +22201,8 @@
         </p:nvSpPr>
         <p:spPr>
           <a:xfrm>
-            <a:off x="540867" y="1051560"/>
-            <a:ext cx="45720" cy="5166360"/>
+            <a:off x="548640" y="1051560"/>
+            <a:ext cx="45720" cy="5257800"/>
           </a:xfrm>
           <a:prstGeom prst="rect">
             <a:avLst/>
@@ -22244,7 +22244,7 @@
         </p:nvSpPr>
         <p:spPr>
           <a:xfrm>
-            <a:off x="678027" y="1188720"/>
+            <a:off x="685800" y="1188720"/>
             <a:ext cx="384048" cy="384048"/>
           </a:xfrm>
           <a:prstGeom prst="ellipse">
@@ -22287,7 +22287,7 @@
         </p:nvSpPr>
         <p:spPr>
           <a:xfrm>
-            <a:off x="678027" y="1188720"/>
+            <a:off x="685800" y="1188720"/>
             <a:ext cx="384048" cy="384048"/>
           </a:xfrm>
           <a:prstGeom prst="rect">
@@ -22327,8 +22327,8 @@
         </p:nvSpPr>
         <p:spPr>
           <a:xfrm>
-            <a:off x="678027" y="1691640"/>
-            <a:ext cx="3246120" cy="320040"/>
+            <a:off x="685800" y="1691640"/>
+            <a:ext cx="3240938" cy="274320"/>
           </a:xfrm>
           <a:prstGeom prst="rect">
             <a:avLst/>
@@ -22346,7 +22346,7 @@
               <a:spcAft>
                 <a:spcPts val="0"/>
               </a:spcAft>
-              <a:defRPr sz="1400" b="1">
+              <a:defRPr sz="1300" b="1">
                 <a:solidFill>
                   <a:srgbClr val="2563EB"/>
                 </a:solidFill>
@@ -22367,8 +22367,8 @@
         </p:nvSpPr>
         <p:spPr>
           <a:xfrm>
-            <a:off x="678027" y="2075688"/>
-            <a:ext cx="3246120" cy="228600"/>
+            <a:off x="685800" y="2011680"/>
+            <a:ext cx="3240938" cy="201168"/>
           </a:xfrm>
           <a:prstGeom prst="rect">
             <a:avLst/>
@@ -22386,7 +22386,7 @@
               <a:spcAft>
                 <a:spcPts val="0"/>
               </a:spcAft>
-              <a:defRPr sz="1000" b="0">
+              <a:defRPr sz="900" b="0">
                 <a:solidFill>
                   <a:srgbClr val="1A1A2E"/>
                 </a:solidFill>
@@ -22407,8 +22407,8 @@
         </p:nvSpPr>
         <p:spPr>
           <a:xfrm>
-            <a:off x="678027" y="2295144"/>
-            <a:ext cx="3246120" cy="228600"/>
+            <a:off x="685800" y="2212848"/>
+            <a:ext cx="3240938" cy="201168"/>
           </a:xfrm>
           <a:prstGeom prst="rect">
             <a:avLst/>
@@ -22426,7 +22426,7 @@
               <a:spcAft>
                 <a:spcPts val="0"/>
               </a:spcAft>
-              <a:defRPr sz="1000" b="0">
+              <a:defRPr sz="900" b="0">
                 <a:solidFill>
                   <a:srgbClr val="1A1A2E"/>
                 </a:solidFill>
@@ -22447,8 +22447,8 @@
         </p:nvSpPr>
         <p:spPr>
           <a:xfrm>
-            <a:off x="678027" y="2514600"/>
-            <a:ext cx="3246120" cy="228600"/>
+            <a:off x="685800" y="2414016"/>
+            <a:ext cx="3240938" cy="201168"/>
           </a:xfrm>
           <a:prstGeom prst="rect">
             <a:avLst/>
@@ -22466,7 +22466,7 @@
               <a:spcAft>
                 <a:spcPts val="0"/>
               </a:spcAft>
-              <a:defRPr sz="1000" b="0">
+              <a:defRPr sz="900" b="0">
                 <a:solidFill>
                   <a:srgbClr val="1A1A2E"/>
                 </a:solidFill>
@@ -22487,8 +22487,8 @@
         </p:nvSpPr>
         <p:spPr>
           <a:xfrm>
-            <a:off x="678027" y="2734056"/>
-            <a:ext cx="3246120" cy="228600"/>
+            <a:off x="685800" y="2615184"/>
+            <a:ext cx="3240938" cy="201168"/>
           </a:xfrm>
           <a:prstGeom prst="rect">
             <a:avLst/>
@@ -22506,7 +22506,7 @@
               <a:spcAft>
                 <a:spcPts val="0"/>
               </a:spcAft>
-              <a:defRPr sz="1000" b="0">
+              <a:defRPr sz="900" b="0">
                 <a:solidFill>
                   <a:srgbClr val="1A1A2E"/>
                 </a:solidFill>
@@ -22527,8 +22527,8 @@
         </p:nvSpPr>
         <p:spPr>
           <a:xfrm>
-            <a:off x="678027" y="2953512"/>
-            <a:ext cx="3246120" cy="228600"/>
+            <a:off x="685800" y="2816352"/>
+            <a:ext cx="3240938" cy="201168"/>
           </a:xfrm>
           <a:prstGeom prst="rect">
             <a:avLst/>
@@ -22546,7 +22546,7 @@
               <a:spcAft>
                 <a:spcPts val="0"/>
               </a:spcAft>
-              <a:defRPr sz="1000" b="0">
+              <a:defRPr sz="900" b="0">
                 <a:solidFill>
                   <a:srgbClr val="1A1A2E"/>
                 </a:solidFill>
@@ -22567,8 +22567,8 @@
         </p:nvSpPr>
         <p:spPr>
           <a:xfrm>
-            <a:off x="4335627" y="1051560"/>
-            <a:ext cx="3520440" cy="5166360"/>
+            <a:off x="4338218" y="1051560"/>
+            <a:ext cx="3515258" cy="5257800"/>
           </a:xfrm>
           <a:prstGeom prst="roundRect">
             <a:avLst>
@@ -22614,8 +22614,8 @@
         </p:nvSpPr>
         <p:spPr>
           <a:xfrm>
-            <a:off x="4335627" y="1051560"/>
-            <a:ext cx="45720" cy="5166360"/>
+            <a:off x="4338218" y="1051560"/>
+            <a:ext cx="45720" cy="5257800"/>
           </a:xfrm>
           <a:prstGeom prst="rect">
             <a:avLst/>
@@ -22657,7 +22657,7 @@
         </p:nvSpPr>
         <p:spPr>
           <a:xfrm>
-            <a:off x="4472787" y="1188720"/>
+            <a:off x="4475378" y="1188720"/>
             <a:ext cx="384048" cy="384048"/>
           </a:xfrm>
           <a:prstGeom prst="ellipse">
@@ -22700,7 +22700,7 @@
         </p:nvSpPr>
         <p:spPr>
           <a:xfrm>
-            <a:off x="4472787" y="1188720"/>
+            <a:off x="4475378" y="1188720"/>
             <a:ext cx="384048" cy="384048"/>
           </a:xfrm>
           <a:prstGeom prst="rect">
@@ -22740,8 +22740,8 @@
         </p:nvSpPr>
         <p:spPr>
           <a:xfrm>
-            <a:off x="4472787" y="1691640"/>
-            <a:ext cx="3246120" cy="320040"/>
+            <a:off x="4475378" y="1691640"/>
+            <a:ext cx="3240938" cy="274320"/>
           </a:xfrm>
           <a:prstGeom prst="rect">
             <a:avLst/>
@@ -22759,7 +22759,7 @@
               <a:spcAft>
                 <a:spcPts val="0"/>
               </a:spcAft>
-              <a:defRPr sz="1400" b="1">
+              <a:defRPr sz="1300" b="1">
                 <a:solidFill>
                   <a:srgbClr val="0D9488"/>
                 </a:solidFill>
@@ -22780,8 +22780,8 @@
         </p:nvSpPr>
         <p:spPr>
           <a:xfrm>
-            <a:off x="4472787" y="2075688"/>
-            <a:ext cx="3246120" cy="228600"/>
+            <a:off x="4475378" y="2011680"/>
+            <a:ext cx="3240938" cy="201168"/>
           </a:xfrm>
           <a:prstGeom prst="rect">
             <a:avLst/>
@@ -22799,7 +22799,7 @@
               <a:spcAft>
                 <a:spcPts val="0"/>
               </a:spcAft>
-              <a:defRPr sz="1000" b="0">
+              <a:defRPr sz="900" b="0">
                 <a:solidFill>
                   <a:srgbClr val="1A1A2E"/>
                 </a:solidFill>
@@ -22820,8 +22820,8 @@
         </p:nvSpPr>
         <p:spPr>
           <a:xfrm>
-            <a:off x="4472787" y="2295144"/>
-            <a:ext cx="3246120" cy="228600"/>
+            <a:off x="4475378" y="2212848"/>
+            <a:ext cx="3240938" cy="201168"/>
           </a:xfrm>
           <a:prstGeom prst="rect">
             <a:avLst/>
@@ -22839,7 +22839,7 @@
               <a:spcAft>
                 <a:spcPts val="0"/>
               </a:spcAft>
-              <a:defRPr sz="1000" b="0">
+              <a:defRPr sz="900" b="0">
                 <a:solidFill>
                   <a:srgbClr val="1A1A2E"/>
                 </a:solidFill>
@@ -22860,8 +22860,8 @@
         </p:nvSpPr>
         <p:spPr>
           <a:xfrm>
-            <a:off x="4472787" y="2514600"/>
-            <a:ext cx="3246120" cy="228600"/>
+            <a:off x="4475378" y="2414016"/>
+            <a:ext cx="3240938" cy="201168"/>
           </a:xfrm>
           <a:prstGeom prst="rect">
             <a:avLst/>
@@ -22879,7 +22879,7 @@
               <a:spcAft>
                 <a:spcPts val="0"/>
               </a:spcAft>
-              <a:defRPr sz="1000" b="0">
+              <a:defRPr sz="900" b="0">
                 <a:solidFill>
                   <a:srgbClr val="1A1A2E"/>
                 </a:solidFill>
@@ -22900,8 +22900,8 @@
         </p:nvSpPr>
         <p:spPr>
           <a:xfrm>
-            <a:off x="8130387" y="1051560"/>
-            <a:ext cx="3520440" cy="5166360"/>
+            <a:off x="8127796" y="1051560"/>
+            <a:ext cx="3515258" cy="5257800"/>
           </a:xfrm>
           <a:prstGeom prst="roundRect">
             <a:avLst>
@@ -22947,8 +22947,8 @@
         </p:nvSpPr>
         <p:spPr>
           <a:xfrm>
-            <a:off x="8130387" y="1051560"/>
-            <a:ext cx="45720" cy="5166360"/>
+            <a:off x="8127796" y="1051560"/>
+            <a:ext cx="45720" cy="5257800"/>
           </a:xfrm>
           <a:prstGeom prst="rect">
             <a:avLst/>
@@ -22990,7 +22990,7 @@
         </p:nvSpPr>
         <p:spPr>
           <a:xfrm>
-            <a:off x="8267547" y="1188720"/>
+            <a:off x="8264956" y="1188720"/>
             <a:ext cx="384048" cy="384048"/>
           </a:xfrm>
           <a:prstGeom prst="ellipse">
@@ -23033,7 +23033,7 @@
         </p:nvSpPr>
         <p:spPr>
           <a:xfrm>
-            <a:off x="8267547" y="1188720"/>
+            <a:off x="8264956" y="1188720"/>
             <a:ext cx="384048" cy="384048"/>
           </a:xfrm>
           <a:prstGeom prst="rect">
@@ -23073,8 +23073,8 @@
         </p:nvSpPr>
         <p:spPr>
           <a:xfrm>
-            <a:off x="8267547" y="1691640"/>
-            <a:ext cx="3246120" cy="320040"/>
+            <a:off x="8264956" y="1691640"/>
+            <a:ext cx="3240938" cy="274320"/>
           </a:xfrm>
           <a:prstGeom prst="rect">
             <a:avLst/>
@@ -23092,7 +23092,7 @@
               <a:spcAft>
                 <a:spcPts val="0"/>
               </a:spcAft>
-              <a:defRPr sz="1400" b="1">
+              <a:defRPr sz="1300" b="1">
                 <a:solidFill>
                   <a:srgbClr val="B8860B"/>
                 </a:solidFill>
@@ -23113,8 +23113,8 @@
         </p:nvSpPr>
         <p:spPr>
           <a:xfrm>
-            <a:off x="8267547" y="2075688"/>
-            <a:ext cx="3246120" cy="228600"/>
+            <a:off x="8264956" y="2011680"/>
+            <a:ext cx="3240938" cy="201168"/>
           </a:xfrm>
           <a:prstGeom prst="rect">
             <a:avLst/>
@@ -23132,7 +23132,7 @@
               <a:spcAft>
                 <a:spcPts val="0"/>
               </a:spcAft>
-              <a:defRPr sz="1000" b="0">
+              <a:defRPr sz="900" b="0">
                 <a:solidFill>
                   <a:srgbClr val="1A1A2E"/>
                 </a:solidFill>
@@ -23153,8 +23153,8 @@
         </p:nvSpPr>
         <p:spPr>
           <a:xfrm>
-            <a:off x="8267547" y="2295144"/>
-            <a:ext cx="3246120" cy="228600"/>
+            <a:off x="8264956" y="2212848"/>
+            <a:ext cx="3240938" cy="201168"/>
           </a:xfrm>
           <a:prstGeom prst="rect">
             <a:avLst/>
@@ -23172,7 +23172,7 @@
               <a:spcAft>
                 <a:spcPts val="0"/>
               </a:spcAft>
-              <a:defRPr sz="1000" b="0">
+              <a:defRPr sz="900" b="0">
                 <a:solidFill>
                   <a:srgbClr val="1A1A2E"/>
                 </a:solidFill>
@@ -23193,8 +23193,8 @@
         </p:nvSpPr>
         <p:spPr>
           <a:xfrm>
-            <a:off x="8267547" y="2514600"/>
-            <a:ext cx="3246120" cy="228600"/>
+            <a:off x="8264956" y="2414016"/>
+            <a:ext cx="3240938" cy="201168"/>
           </a:xfrm>
           <a:prstGeom prst="rect">
             <a:avLst/>
@@ -23212,7 +23212,7 @@
               <a:spcAft>
                 <a:spcPts val="0"/>
               </a:spcAft>
-              <a:defRPr sz="1000" b="0">
+              <a:defRPr sz="900" b="0">
                 <a:solidFill>
                   <a:srgbClr val="1A1A2E"/>
                 </a:solidFill>
@@ -23233,8 +23233,8 @@
         </p:nvSpPr>
         <p:spPr>
           <a:xfrm>
-            <a:off x="8267547" y="2734056"/>
-            <a:ext cx="3246120" cy="228600"/>
+            <a:off x="8264956" y="2615184"/>
+            <a:ext cx="3240938" cy="201168"/>
           </a:xfrm>
           <a:prstGeom prst="rect">
             <a:avLst/>
@@ -23252,7 +23252,7 @@
               <a:spcAft>
                 <a:spcPts val="0"/>
               </a:spcAft>
-              <a:defRPr sz="1000" b="0">
+              <a:defRPr sz="900" b="0">
                 <a:solidFill>
                   <a:srgbClr val="1A1A2E"/>
                 </a:solidFill>
@@ -23631,8 +23631,8 @@
         </p:nvSpPr>
         <p:spPr>
           <a:xfrm>
-            <a:off x="655167" y="1188720"/>
-            <a:ext cx="2377440" cy="1828800"/>
+            <a:off x="548640" y="1188720"/>
+            <a:ext cx="2533573" cy="1828800"/>
           </a:xfrm>
           <a:prstGeom prst="roundRect">
             <a:avLst>
@@ -23678,8 +23678,8 @@
         </p:nvSpPr>
         <p:spPr>
           <a:xfrm>
-            <a:off x="655167" y="1188720"/>
-            <a:ext cx="2377440" cy="45720"/>
+            <a:off x="548640" y="1188720"/>
+            <a:ext cx="2533573" cy="45720"/>
           </a:xfrm>
           <a:prstGeom prst="rect">
             <a:avLst/>
@@ -23721,7 +23721,7 @@
         </p:nvSpPr>
         <p:spPr>
           <a:xfrm>
-            <a:off x="1615287" y="1325880"/>
+            <a:off x="1586826" y="1325880"/>
             <a:ext cx="457200" cy="457200"/>
           </a:xfrm>
           <a:prstGeom prst="ellipse">
@@ -23764,7 +23764,7 @@
         </p:nvSpPr>
         <p:spPr>
           <a:xfrm>
-            <a:off x="1615287" y="1325880"/>
+            <a:off x="1586826" y="1325880"/>
             <a:ext cx="457200" cy="457200"/>
           </a:xfrm>
           <a:prstGeom prst="rect">
@@ -23804,8 +23804,8 @@
         </p:nvSpPr>
         <p:spPr>
           <a:xfrm>
-            <a:off x="746607" y="1874520"/>
-            <a:ext cx="2194560" cy="320040"/>
+            <a:off x="640080" y="1874520"/>
+            <a:ext cx="2350693" cy="320040"/>
           </a:xfrm>
           <a:prstGeom prst="rect">
             <a:avLst/>
@@ -23844,8 +23844,8 @@
         </p:nvSpPr>
         <p:spPr>
           <a:xfrm>
-            <a:off x="746607" y="2194560"/>
-            <a:ext cx="2194560" cy="640080"/>
+            <a:off x="640080" y="2194560"/>
+            <a:ext cx="2350693" cy="640080"/>
           </a:xfrm>
           <a:prstGeom prst="rect">
             <a:avLst/>
@@ -23884,8 +23884,8 @@
         </p:nvSpPr>
         <p:spPr>
           <a:xfrm>
-            <a:off x="3032607" y="1828800"/>
-            <a:ext cx="457200" cy="457200"/>
+            <a:off x="3082213" y="1828800"/>
+            <a:ext cx="320040" cy="457200"/>
           </a:xfrm>
           <a:prstGeom prst="rect">
             <a:avLst/>
@@ -23924,8 +23924,8 @@
         </p:nvSpPr>
         <p:spPr>
           <a:xfrm>
-            <a:off x="3489807" y="1188720"/>
-            <a:ext cx="2377440" cy="1828800"/>
+            <a:off x="3402253" y="1188720"/>
+            <a:ext cx="2533573" cy="1828800"/>
           </a:xfrm>
           <a:prstGeom prst="roundRect">
             <a:avLst>
@@ -23971,8 +23971,8 @@
         </p:nvSpPr>
         <p:spPr>
           <a:xfrm>
-            <a:off x="3489807" y="1188720"/>
-            <a:ext cx="2377440" cy="45720"/>
+            <a:off x="3402253" y="1188720"/>
+            <a:ext cx="2533573" cy="45720"/>
           </a:xfrm>
           <a:prstGeom prst="rect">
             <a:avLst/>
@@ -24014,7 +24014,7 @@
         </p:nvSpPr>
         <p:spPr>
           <a:xfrm>
-            <a:off x="4449927" y="1325880"/>
+            <a:off x="4440440" y="1325880"/>
             <a:ext cx="457200" cy="457200"/>
           </a:xfrm>
           <a:prstGeom prst="ellipse">
@@ -24057,7 +24057,7 @@
         </p:nvSpPr>
         <p:spPr>
           <a:xfrm>
-            <a:off x="4449927" y="1325880"/>
+            <a:off x="4440440" y="1325880"/>
             <a:ext cx="457200" cy="457200"/>
           </a:xfrm>
           <a:prstGeom prst="rect">
@@ -24097,8 +24097,8 @@
         </p:nvSpPr>
         <p:spPr>
           <a:xfrm>
-            <a:off x="3581247" y="1874520"/>
-            <a:ext cx="2194560" cy="320040"/>
+            <a:off x="3493693" y="1874520"/>
+            <a:ext cx="2350693" cy="320040"/>
           </a:xfrm>
           <a:prstGeom prst="rect">
             <a:avLst/>
@@ -24137,8 +24137,8 @@
         </p:nvSpPr>
         <p:spPr>
           <a:xfrm>
-            <a:off x="3581247" y="2194560"/>
-            <a:ext cx="2194560" cy="640080"/>
+            <a:off x="3493693" y="2194560"/>
+            <a:ext cx="2350693" cy="640080"/>
           </a:xfrm>
           <a:prstGeom prst="rect">
             <a:avLst/>
@@ -24177,8 +24177,8 @@
         </p:nvSpPr>
         <p:spPr>
           <a:xfrm>
-            <a:off x="5867247" y="1828800"/>
-            <a:ext cx="457200" cy="457200"/>
+            <a:off x="5935827" y="1828800"/>
+            <a:ext cx="320040" cy="457200"/>
           </a:xfrm>
           <a:prstGeom prst="rect">
             <a:avLst/>
@@ -24217,8 +24217,8 @@
         </p:nvSpPr>
         <p:spPr>
           <a:xfrm>
-            <a:off x="6324447" y="1188720"/>
-            <a:ext cx="2377440" cy="1828800"/>
+            <a:off x="6255867" y="1188720"/>
+            <a:ext cx="2533573" cy="1828800"/>
           </a:xfrm>
           <a:prstGeom prst="roundRect">
             <a:avLst>
@@ -24264,8 +24264,8 @@
         </p:nvSpPr>
         <p:spPr>
           <a:xfrm>
-            <a:off x="6324447" y="1188720"/>
-            <a:ext cx="2377440" cy="45720"/>
+            <a:off x="6255867" y="1188720"/>
+            <a:ext cx="2533573" cy="45720"/>
           </a:xfrm>
           <a:prstGeom prst="rect">
             <a:avLst/>
@@ -24307,7 +24307,7 @@
         </p:nvSpPr>
         <p:spPr>
           <a:xfrm>
-            <a:off x="7284567" y="1325880"/>
+            <a:off x="7294054" y="1325880"/>
             <a:ext cx="457200" cy="457200"/>
           </a:xfrm>
           <a:prstGeom prst="ellipse">
@@ -24350,7 +24350,7 @@
         </p:nvSpPr>
         <p:spPr>
           <a:xfrm>
-            <a:off x="7284567" y="1325880"/>
+            <a:off x="7294054" y="1325880"/>
             <a:ext cx="457200" cy="457200"/>
           </a:xfrm>
           <a:prstGeom prst="rect">
@@ -24390,8 +24390,8 @@
         </p:nvSpPr>
         <p:spPr>
           <a:xfrm>
-            <a:off x="6415887" y="1874520"/>
-            <a:ext cx="2194560" cy="320040"/>
+            <a:off x="6347307" y="1874520"/>
+            <a:ext cx="2350693" cy="320040"/>
           </a:xfrm>
           <a:prstGeom prst="rect">
             <a:avLst/>
@@ -24430,8 +24430,8 @@
         </p:nvSpPr>
         <p:spPr>
           <a:xfrm>
-            <a:off x="6415887" y="2194560"/>
-            <a:ext cx="2194560" cy="640080"/>
+            <a:off x="6347307" y="2194560"/>
+            <a:ext cx="2350693" cy="640080"/>
           </a:xfrm>
           <a:prstGeom prst="rect">
             <a:avLst/>
@@ -24470,8 +24470,8 @@
         </p:nvSpPr>
         <p:spPr>
           <a:xfrm>
-            <a:off x="8701887" y="1828800"/>
-            <a:ext cx="457200" cy="457200"/>
+            <a:off x="8789441" y="1828800"/>
+            <a:ext cx="320040" cy="457200"/>
           </a:xfrm>
           <a:prstGeom prst="rect">
             <a:avLst/>
@@ -24510,8 +24510,8 @@
         </p:nvSpPr>
         <p:spPr>
           <a:xfrm>
-            <a:off x="9159087" y="1188720"/>
-            <a:ext cx="2377440" cy="1828800"/>
+            <a:off x="9109481" y="1188720"/>
+            <a:ext cx="2533573" cy="1828800"/>
           </a:xfrm>
           <a:prstGeom prst="roundRect">
             <a:avLst>
@@ -24557,8 +24557,8 @@
         </p:nvSpPr>
         <p:spPr>
           <a:xfrm>
-            <a:off x="9159087" y="1188720"/>
-            <a:ext cx="2377440" cy="45720"/>
+            <a:off x="9109481" y="1188720"/>
+            <a:ext cx="2533573" cy="45720"/>
           </a:xfrm>
           <a:prstGeom prst="rect">
             <a:avLst/>
@@ -24600,7 +24600,7 @@
         </p:nvSpPr>
         <p:spPr>
           <a:xfrm>
-            <a:off x="10119207" y="1325880"/>
+            <a:off x="10147668" y="1325880"/>
             <a:ext cx="457200" cy="457200"/>
           </a:xfrm>
           <a:prstGeom prst="ellipse">
@@ -24643,7 +24643,7 @@
         </p:nvSpPr>
         <p:spPr>
           <a:xfrm>
-            <a:off x="10119207" y="1325880"/>
+            <a:off x="10147668" y="1325880"/>
             <a:ext cx="457200" cy="457200"/>
           </a:xfrm>
           <a:prstGeom prst="rect">
@@ -24683,8 +24683,8 @@
         </p:nvSpPr>
         <p:spPr>
           <a:xfrm>
-            <a:off x="9250527" y="1874520"/>
-            <a:ext cx="2194560" cy="320040"/>
+            <a:off x="9200921" y="1874520"/>
+            <a:ext cx="2350693" cy="320040"/>
           </a:xfrm>
           <a:prstGeom prst="rect">
             <a:avLst/>
@@ -24723,8 +24723,8 @@
         </p:nvSpPr>
         <p:spPr>
           <a:xfrm>
-            <a:off x="9250527" y="2194560"/>
-            <a:ext cx="2194560" cy="640080"/>
+            <a:off x="9200921" y="2194560"/>
+            <a:ext cx="2350693" cy="640080"/>
           </a:xfrm>
           <a:prstGeom prst="rect">
             <a:avLst/>
@@ -26116,8 +26116,8 @@
         </p:nvSpPr>
         <p:spPr>
           <a:xfrm>
-            <a:off x="540867" y="1051560"/>
-            <a:ext cx="3520440" cy="5166360"/>
+            <a:off x="548640" y="1051560"/>
+            <a:ext cx="3515258" cy="5257800"/>
           </a:xfrm>
           <a:prstGeom prst="roundRect">
             <a:avLst>
@@ -26163,8 +26163,8 @@
         </p:nvSpPr>
         <p:spPr>
           <a:xfrm>
-            <a:off x="540867" y="1051560"/>
-            <a:ext cx="45720" cy="5166360"/>
+            <a:off x="548640" y="1051560"/>
+            <a:ext cx="45720" cy="5257800"/>
           </a:xfrm>
           <a:prstGeom prst="rect">
             <a:avLst/>
@@ -26206,7 +26206,7 @@
         </p:nvSpPr>
         <p:spPr>
           <a:xfrm>
-            <a:off x="678027" y="1188720"/>
+            <a:off x="685800" y="1188720"/>
             <a:ext cx="384048" cy="384048"/>
           </a:xfrm>
           <a:prstGeom prst="ellipse">
@@ -26249,7 +26249,7 @@
         </p:nvSpPr>
         <p:spPr>
           <a:xfrm>
-            <a:off x="678027" y="1188720"/>
+            <a:off x="685800" y="1188720"/>
             <a:ext cx="384048" cy="384048"/>
           </a:xfrm>
           <a:prstGeom prst="rect">
@@ -26289,8 +26289,8 @@
         </p:nvSpPr>
         <p:spPr>
           <a:xfrm>
-            <a:off x="678027" y="1691640"/>
-            <a:ext cx="3246120" cy="320040"/>
+            <a:off x="685800" y="1691640"/>
+            <a:ext cx="3240938" cy="274320"/>
           </a:xfrm>
           <a:prstGeom prst="rect">
             <a:avLst/>
@@ -26308,7 +26308,7 @@
               <a:spcAft>
                 <a:spcPts val="0"/>
               </a:spcAft>
-              <a:defRPr sz="1400" b="1">
+              <a:defRPr sz="1300" b="1">
                 <a:solidFill>
                   <a:srgbClr val="2563EB"/>
                 </a:solidFill>
@@ -26329,8 +26329,8 @@
         </p:nvSpPr>
         <p:spPr>
           <a:xfrm>
-            <a:off x="678027" y="2075688"/>
-            <a:ext cx="3246120" cy="228600"/>
+            <a:off x="685800" y="2011680"/>
+            <a:ext cx="3240938" cy="201168"/>
           </a:xfrm>
           <a:prstGeom prst="rect">
             <a:avLst/>
@@ -26348,7 +26348,7 @@
               <a:spcAft>
                 <a:spcPts val="0"/>
               </a:spcAft>
-              <a:defRPr sz="1000" b="0">
+              <a:defRPr sz="900" b="0">
                 <a:solidFill>
                   <a:srgbClr val="1A1A2E"/>
                 </a:solidFill>
@@ -26369,8 +26369,8 @@
         </p:nvSpPr>
         <p:spPr>
           <a:xfrm>
-            <a:off x="678027" y="2295144"/>
-            <a:ext cx="3246120" cy="228600"/>
+            <a:off x="685800" y="2212848"/>
+            <a:ext cx="3240938" cy="201168"/>
           </a:xfrm>
           <a:prstGeom prst="rect">
             <a:avLst/>
@@ -26388,7 +26388,7 @@
               <a:spcAft>
                 <a:spcPts val="0"/>
               </a:spcAft>
-              <a:defRPr sz="1000" b="0">
+              <a:defRPr sz="900" b="0">
                 <a:solidFill>
                   <a:srgbClr val="1A1A2E"/>
                 </a:solidFill>
@@ -26409,8 +26409,8 @@
         </p:nvSpPr>
         <p:spPr>
           <a:xfrm>
-            <a:off x="678027" y="2514600"/>
-            <a:ext cx="3246120" cy="228600"/>
+            <a:off x="685800" y="2414016"/>
+            <a:ext cx="3240938" cy="201168"/>
           </a:xfrm>
           <a:prstGeom prst="rect">
             <a:avLst/>
@@ -26428,7 +26428,7 @@
               <a:spcAft>
                 <a:spcPts val="0"/>
               </a:spcAft>
-              <a:defRPr sz="1000" b="0">
+              <a:defRPr sz="900" b="0">
                 <a:solidFill>
                   <a:srgbClr val="1A1A2E"/>
                 </a:solidFill>
@@ -26449,8 +26449,8 @@
         </p:nvSpPr>
         <p:spPr>
           <a:xfrm>
-            <a:off x="678027" y="2734056"/>
-            <a:ext cx="3246120" cy="228600"/>
+            <a:off x="685800" y="2615184"/>
+            <a:ext cx="3240938" cy="201168"/>
           </a:xfrm>
           <a:prstGeom prst="rect">
             <a:avLst/>
@@ -26468,7 +26468,7 @@
               <a:spcAft>
                 <a:spcPts val="0"/>
               </a:spcAft>
-              <a:defRPr sz="1000" b="0">
+              <a:defRPr sz="900" b="0">
                 <a:solidFill>
                   <a:srgbClr val="1A1A2E"/>
                 </a:solidFill>
@@ -26489,8 +26489,8 @@
         </p:nvSpPr>
         <p:spPr>
           <a:xfrm>
-            <a:off x="678027" y="2953512"/>
-            <a:ext cx="3246120" cy="228600"/>
+            <a:off x="685800" y="2816352"/>
+            <a:ext cx="3240938" cy="201168"/>
           </a:xfrm>
           <a:prstGeom prst="rect">
             <a:avLst/>
@@ -26508,7 +26508,7 @@
               <a:spcAft>
                 <a:spcPts val="0"/>
               </a:spcAft>
-              <a:defRPr sz="1000" b="0">
+              <a:defRPr sz="900" b="0">
                 <a:solidFill>
                   <a:srgbClr val="1A1A2E"/>
                 </a:solidFill>
@@ -26529,8 +26529,8 @@
         </p:nvSpPr>
         <p:spPr>
           <a:xfrm>
-            <a:off x="4335627" y="1051560"/>
-            <a:ext cx="3520440" cy="5166360"/>
+            <a:off x="4338218" y="1051560"/>
+            <a:ext cx="3515258" cy="5257800"/>
           </a:xfrm>
           <a:prstGeom prst="roundRect">
             <a:avLst>
@@ -26576,8 +26576,8 @@
         </p:nvSpPr>
         <p:spPr>
           <a:xfrm>
-            <a:off x="4335627" y="1051560"/>
-            <a:ext cx="45720" cy="5166360"/>
+            <a:off x="4338218" y="1051560"/>
+            <a:ext cx="45720" cy="5257800"/>
           </a:xfrm>
           <a:prstGeom prst="rect">
             <a:avLst/>
@@ -26619,7 +26619,7 @@
         </p:nvSpPr>
         <p:spPr>
           <a:xfrm>
-            <a:off x="4472787" y="1188720"/>
+            <a:off x="4475378" y="1188720"/>
             <a:ext cx="384048" cy="384048"/>
           </a:xfrm>
           <a:prstGeom prst="ellipse">
@@ -26662,7 +26662,7 @@
         </p:nvSpPr>
         <p:spPr>
           <a:xfrm>
-            <a:off x="4472787" y="1188720"/>
+            <a:off x="4475378" y="1188720"/>
             <a:ext cx="384048" cy="384048"/>
           </a:xfrm>
           <a:prstGeom prst="rect">
@@ -26702,8 +26702,8 @@
         </p:nvSpPr>
         <p:spPr>
           <a:xfrm>
-            <a:off x="4472787" y="1691640"/>
-            <a:ext cx="3246120" cy="320040"/>
+            <a:off x="4475378" y="1691640"/>
+            <a:ext cx="3240938" cy="274320"/>
           </a:xfrm>
           <a:prstGeom prst="rect">
             <a:avLst/>
@@ -26721,7 +26721,7 @@
               <a:spcAft>
                 <a:spcPts val="0"/>
               </a:spcAft>
-              <a:defRPr sz="1400" b="1">
+              <a:defRPr sz="1300" b="1">
                 <a:solidFill>
                   <a:srgbClr val="0D9488"/>
                 </a:solidFill>
@@ -26742,8 +26742,8 @@
         </p:nvSpPr>
         <p:spPr>
           <a:xfrm>
-            <a:off x="4472787" y="2075688"/>
-            <a:ext cx="3246120" cy="228600"/>
+            <a:off x="4475378" y="2011680"/>
+            <a:ext cx="3240938" cy="201168"/>
           </a:xfrm>
           <a:prstGeom prst="rect">
             <a:avLst/>
@@ -26761,7 +26761,7 @@
               <a:spcAft>
                 <a:spcPts val="0"/>
               </a:spcAft>
-              <a:defRPr sz="1000" b="0">
+              <a:defRPr sz="900" b="0">
                 <a:solidFill>
                   <a:srgbClr val="1A1A2E"/>
                 </a:solidFill>
@@ -26782,8 +26782,8 @@
         </p:nvSpPr>
         <p:spPr>
           <a:xfrm>
-            <a:off x="4472787" y="2295144"/>
-            <a:ext cx="3246120" cy="228600"/>
+            <a:off x="4475378" y="2212848"/>
+            <a:ext cx="3240938" cy="201168"/>
           </a:xfrm>
           <a:prstGeom prst="rect">
             <a:avLst/>
@@ -26801,7 +26801,7 @@
               <a:spcAft>
                 <a:spcPts val="0"/>
               </a:spcAft>
-              <a:defRPr sz="1000" b="0">
+              <a:defRPr sz="900" b="0">
                 <a:solidFill>
                   <a:srgbClr val="1A1A2E"/>
                 </a:solidFill>
@@ -26822,8 +26822,8 @@
         </p:nvSpPr>
         <p:spPr>
           <a:xfrm>
-            <a:off x="4472787" y="2514600"/>
-            <a:ext cx="3246120" cy="228600"/>
+            <a:off x="4475378" y="2414016"/>
+            <a:ext cx="3240938" cy="201168"/>
           </a:xfrm>
           <a:prstGeom prst="rect">
             <a:avLst/>
@@ -26841,7 +26841,7 @@
               <a:spcAft>
                 <a:spcPts val="0"/>
               </a:spcAft>
-              <a:defRPr sz="1000" b="0">
+              <a:defRPr sz="900" b="0">
                 <a:solidFill>
                   <a:srgbClr val="1A1A2E"/>
                 </a:solidFill>
@@ -26862,8 +26862,8 @@
         </p:nvSpPr>
         <p:spPr>
           <a:xfrm>
-            <a:off x="4472787" y="2734056"/>
-            <a:ext cx="3246120" cy="228600"/>
+            <a:off x="4475378" y="2615184"/>
+            <a:ext cx="3240938" cy="201168"/>
           </a:xfrm>
           <a:prstGeom prst="rect">
             <a:avLst/>
@@ -26881,7 +26881,7 @@
               <a:spcAft>
                 <a:spcPts val="0"/>
               </a:spcAft>
-              <a:defRPr sz="1000" b="0">
+              <a:defRPr sz="900" b="0">
                 <a:solidFill>
                   <a:srgbClr val="1A1A2E"/>
                 </a:solidFill>
@@ -26902,8 +26902,8 @@
         </p:nvSpPr>
         <p:spPr>
           <a:xfrm>
-            <a:off x="8130387" y="1051560"/>
-            <a:ext cx="3520440" cy="5166360"/>
+            <a:off x="8127796" y="1051560"/>
+            <a:ext cx="3515258" cy="5257800"/>
           </a:xfrm>
           <a:prstGeom prst="roundRect">
             <a:avLst>
@@ -26949,8 +26949,8 @@
         </p:nvSpPr>
         <p:spPr>
           <a:xfrm>
-            <a:off x="8130387" y="1051560"/>
-            <a:ext cx="45720" cy="5166360"/>
+            <a:off x="8127796" y="1051560"/>
+            <a:ext cx="45720" cy="5257800"/>
           </a:xfrm>
           <a:prstGeom prst="rect">
             <a:avLst/>
@@ -26992,7 +26992,7 @@
         </p:nvSpPr>
         <p:spPr>
           <a:xfrm>
-            <a:off x="8267547" y="1188720"/>
+            <a:off x="8264956" y="1188720"/>
             <a:ext cx="384048" cy="384048"/>
           </a:xfrm>
           <a:prstGeom prst="ellipse">
@@ -27035,7 +27035,7 @@
         </p:nvSpPr>
         <p:spPr>
           <a:xfrm>
-            <a:off x="8267547" y="1188720"/>
+            <a:off x="8264956" y="1188720"/>
             <a:ext cx="384048" cy="384048"/>
           </a:xfrm>
           <a:prstGeom prst="rect">
@@ -27075,8 +27075,8 @@
         </p:nvSpPr>
         <p:spPr>
           <a:xfrm>
-            <a:off x="8267547" y="1691640"/>
-            <a:ext cx="3246120" cy="320040"/>
+            <a:off x="8264956" y="1691640"/>
+            <a:ext cx="3240938" cy="274320"/>
           </a:xfrm>
           <a:prstGeom prst="rect">
             <a:avLst/>
@@ -27094,7 +27094,7 @@
               <a:spcAft>
                 <a:spcPts val="0"/>
               </a:spcAft>
-              <a:defRPr sz="1400" b="1">
+              <a:defRPr sz="1300" b="1">
                 <a:solidFill>
                   <a:srgbClr val="B8860B"/>
                 </a:solidFill>
@@ -27115,8 +27115,8 @@
         </p:nvSpPr>
         <p:spPr>
           <a:xfrm>
-            <a:off x="8267547" y="2075688"/>
-            <a:ext cx="3246120" cy="228600"/>
+            <a:off x="8264956" y="2011680"/>
+            <a:ext cx="3240938" cy="201168"/>
           </a:xfrm>
           <a:prstGeom prst="rect">
             <a:avLst/>
@@ -27134,7 +27134,7 @@
               <a:spcAft>
                 <a:spcPts val="0"/>
               </a:spcAft>
-              <a:defRPr sz="1000" b="0">
+              <a:defRPr sz="900" b="0">
                 <a:solidFill>
                   <a:srgbClr val="1A1A2E"/>
                 </a:solidFill>
@@ -27155,8 +27155,8 @@
         </p:nvSpPr>
         <p:spPr>
           <a:xfrm>
-            <a:off x="8267547" y="2295144"/>
-            <a:ext cx="3246120" cy="228600"/>
+            <a:off x="8264956" y="2212848"/>
+            <a:ext cx="3240938" cy="201168"/>
           </a:xfrm>
           <a:prstGeom prst="rect">
             <a:avLst/>
@@ -27174,7 +27174,7 @@
               <a:spcAft>
                 <a:spcPts val="0"/>
               </a:spcAft>
-              <a:defRPr sz="1000" b="0">
+              <a:defRPr sz="900" b="0">
                 <a:solidFill>
                   <a:srgbClr val="1A1A2E"/>
                 </a:solidFill>
@@ -27195,8 +27195,8 @@
         </p:nvSpPr>
         <p:spPr>
           <a:xfrm>
-            <a:off x="8267547" y="2514600"/>
-            <a:ext cx="3246120" cy="228600"/>
+            <a:off x="8264956" y="2414016"/>
+            <a:ext cx="3240938" cy="201168"/>
           </a:xfrm>
           <a:prstGeom prst="rect">
             <a:avLst/>
@@ -27214,7 +27214,7 @@
               <a:spcAft>
                 <a:spcPts val="0"/>
               </a:spcAft>
-              <a:defRPr sz="1000" b="0">
+              <a:defRPr sz="900" b="0">
                 <a:solidFill>
                   <a:srgbClr val="1A1A2E"/>
                 </a:solidFill>
@@ -27235,8 +27235,8 @@
         </p:nvSpPr>
         <p:spPr>
           <a:xfrm>
-            <a:off x="8267547" y="2734056"/>
-            <a:ext cx="3246120" cy="228600"/>
+            <a:off x="8264956" y="2615184"/>
+            <a:ext cx="3240938" cy="201168"/>
           </a:xfrm>
           <a:prstGeom prst="rect">
             <a:avLst/>
@@ -27254,7 +27254,7 @@
               <a:spcAft>
                 <a:spcPts val="0"/>
               </a:spcAft>
-              <a:defRPr sz="1000" b="0">
+              <a:defRPr sz="900" b="0">
                 <a:solidFill>
                   <a:srgbClr val="1A1A2E"/>
                 </a:solidFill>
@@ -27275,8 +27275,8 @@
         </p:nvSpPr>
         <p:spPr>
           <a:xfrm>
-            <a:off x="8267547" y="2953512"/>
-            <a:ext cx="3246120" cy="228600"/>
+            <a:off x="8264956" y="2816352"/>
+            <a:ext cx="3240938" cy="201168"/>
           </a:xfrm>
           <a:prstGeom prst="rect">
             <a:avLst/>
@@ -27294,7 +27294,7 @@
               <a:spcAft>
                 <a:spcPts val="0"/>
               </a:spcAft>
-              <a:defRPr sz="1000" b="0">
+              <a:defRPr sz="900" b="0">
                 <a:solidFill>
                   <a:srgbClr val="1A1A2E"/>
                 </a:solidFill>
@@ -28122,7 +28122,7 @@
         <p:spPr>
           <a:xfrm>
             <a:off x="548640" y="1051560"/>
-            <a:ext cx="5303520" cy="5166360"/>
+            <a:ext cx="5410047" cy="5166360"/>
           </a:xfrm>
           <a:prstGeom prst="roundRect">
             <a:avLst>
@@ -28212,7 +28212,7 @@
         <p:spPr>
           <a:xfrm>
             <a:off x="731520" y="1188720"/>
-            <a:ext cx="4983480" cy="274320"/>
+            <a:ext cx="5090007" cy="274320"/>
           </a:xfrm>
           <a:prstGeom prst="rect">
             <a:avLst/>
@@ -28252,7 +28252,7 @@
         <p:spPr>
           <a:xfrm>
             <a:off x="731520" y="1481328"/>
-            <a:ext cx="4983480" cy="201168"/>
+            <a:ext cx="5090007" cy="201168"/>
           </a:xfrm>
           <a:prstGeom prst="rect">
             <a:avLst/>
@@ -28292,7 +28292,7 @@
         <p:spPr>
           <a:xfrm>
             <a:off x="731520" y="1700784"/>
-            <a:ext cx="4983480" cy="201168"/>
+            <a:ext cx="5090007" cy="201168"/>
           </a:xfrm>
           <a:prstGeom prst="rect">
             <a:avLst/>
@@ -28332,7 +28332,7 @@
         <p:spPr>
           <a:xfrm>
             <a:off x="731520" y="1920240"/>
-            <a:ext cx="4983480" cy="201168"/>
+            <a:ext cx="5090007" cy="201168"/>
           </a:xfrm>
           <a:prstGeom prst="rect">
             <a:avLst/>
@@ -28372,7 +28372,7 @@
         <p:spPr>
           <a:xfrm>
             <a:off x="731520" y="2139696"/>
-            <a:ext cx="4983480" cy="201168"/>
+            <a:ext cx="5090007" cy="201168"/>
           </a:xfrm>
           <a:prstGeom prst="rect">
             <a:avLst/>
@@ -28411,8 +28411,8 @@
         </p:nvSpPr>
         <p:spPr>
           <a:xfrm>
-            <a:off x="6172200" y="1051560"/>
-            <a:ext cx="5303520" cy="5166360"/>
+            <a:off x="6233007" y="1051560"/>
+            <a:ext cx="5410047" cy="5166360"/>
           </a:xfrm>
           <a:prstGeom prst="roundRect">
             <a:avLst>
@@ -28458,7 +28458,7 @@
         </p:nvSpPr>
         <p:spPr>
           <a:xfrm>
-            <a:off x="6172200" y="1051560"/>
+            <a:off x="6233007" y="1051560"/>
             <a:ext cx="45720" cy="5166360"/>
           </a:xfrm>
           <a:prstGeom prst="rect">
@@ -28501,8 +28501,8 @@
         </p:nvSpPr>
         <p:spPr>
           <a:xfrm>
-            <a:off x="6355080" y="1188720"/>
-            <a:ext cx="4983480" cy="274320"/>
+            <a:off x="6415887" y="1188720"/>
+            <a:ext cx="5090007" cy="274320"/>
           </a:xfrm>
           <a:prstGeom prst="rect">
             <a:avLst/>
@@ -28541,8 +28541,8 @@
         </p:nvSpPr>
         <p:spPr>
           <a:xfrm>
-            <a:off x="6355080" y="1481328"/>
-            <a:ext cx="4983480" cy="201168"/>
+            <a:off x="6415887" y="1481328"/>
+            <a:ext cx="5090007" cy="201168"/>
           </a:xfrm>
           <a:prstGeom prst="rect">
             <a:avLst/>
@@ -28581,8 +28581,8 @@
         </p:nvSpPr>
         <p:spPr>
           <a:xfrm>
-            <a:off x="6355080" y="1700784"/>
-            <a:ext cx="4983480" cy="201168"/>
+            <a:off x="6415887" y="1700784"/>
+            <a:ext cx="5090007" cy="201168"/>
           </a:xfrm>
           <a:prstGeom prst="rect">
             <a:avLst/>
@@ -28621,8 +28621,8 @@
         </p:nvSpPr>
         <p:spPr>
           <a:xfrm>
-            <a:off x="6355080" y="1920240"/>
-            <a:ext cx="4983480" cy="201168"/>
+            <a:off x="6415887" y="1920240"/>
+            <a:ext cx="5090007" cy="201168"/>
           </a:xfrm>
           <a:prstGeom prst="rect">
             <a:avLst/>
@@ -28661,8 +28661,8 @@
         </p:nvSpPr>
         <p:spPr>
           <a:xfrm>
-            <a:off x="6355080" y="2139696"/>
-            <a:ext cx="4983480" cy="201168"/>
+            <a:off x="6415887" y="2139696"/>
+            <a:ext cx="5090007" cy="201168"/>
           </a:xfrm>
           <a:prstGeom prst="rect">
             <a:avLst/>
@@ -28701,8 +28701,8 @@
         </p:nvSpPr>
         <p:spPr>
           <a:xfrm>
-            <a:off x="6355080" y="2359152"/>
-            <a:ext cx="4983480" cy="201168"/>
+            <a:off x="6415887" y="2359152"/>
+            <a:ext cx="5090007" cy="201168"/>
           </a:xfrm>
           <a:prstGeom prst="rect">
             <a:avLst/>
@@ -28741,8 +28741,8 @@
         </p:nvSpPr>
         <p:spPr>
           <a:xfrm>
-            <a:off x="6355080" y="2578608"/>
-            <a:ext cx="4983480" cy="201168"/>
+            <a:off x="6415887" y="2578608"/>
+            <a:ext cx="5090007" cy="201168"/>
           </a:xfrm>
           <a:prstGeom prst="rect">
             <a:avLst/>
@@ -28781,8 +28781,8 @@
         </p:nvSpPr>
         <p:spPr>
           <a:xfrm>
-            <a:off x="6355080" y="2798064"/>
-            <a:ext cx="4983480" cy="201168"/>
+            <a:off x="6415887" y="2798064"/>
+            <a:ext cx="5090007" cy="201168"/>
           </a:xfrm>
           <a:prstGeom prst="rect">
             <a:avLst/>
@@ -29584,8 +29584,8 @@
         </p:nvSpPr>
         <p:spPr>
           <a:xfrm>
-            <a:off x="-3848252" y="1051560"/>
-            <a:ext cx="2606040" cy="5166360"/>
+            <a:off x="548640" y="1051560"/>
+            <a:ext cx="2567863" cy="2514600"/>
           </a:xfrm>
           <a:prstGeom prst="roundRect">
             <a:avLst>
@@ -29631,8 +29631,8 @@
         </p:nvSpPr>
         <p:spPr>
           <a:xfrm>
-            <a:off x="-3848252" y="1051560"/>
-            <a:ext cx="45720" cy="5166360"/>
+            <a:off x="548640" y="1051560"/>
+            <a:ext cx="45720" cy="2514600"/>
           </a:xfrm>
           <a:prstGeom prst="rect">
             <a:avLst/>
@@ -29674,7 +29674,7 @@
         </p:nvSpPr>
         <p:spPr>
           <a:xfrm>
-            <a:off x="-3711092" y="1188720"/>
+            <a:off x="685800" y="1188720"/>
             <a:ext cx="384048" cy="384048"/>
           </a:xfrm>
           <a:prstGeom prst="ellipse">
@@ -29717,7 +29717,7 @@
         </p:nvSpPr>
         <p:spPr>
           <a:xfrm>
-            <a:off x="-3711092" y="1188720"/>
+            <a:off x="685800" y="1188720"/>
             <a:ext cx="384048" cy="384048"/>
           </a:xfrm>
           <a:prstGeom prst="rect">
@@ -29757,8 +29757,8 @@
         </p:nvSpPr>
         <p:spPr>
           <a:xfrm>
-            <a:off x="-3711092" y="1691640"/>
-            <a:ext cx="2331720" cy="320040"/>
+            <a:off x="685800" y="1691640"/>
+            <a:ext cx="2293543" cy="274320"/>
           </a:xfrm>
           <a:prstGeom prst="rect">
             <a:avLst/>
@@ -29776,7 +29776,7 @@
               <a:spcAft>
                 <a:spcPts val="0"/>
               </a:spcAft>
-              <a:defRPr sz="1400" b="1">
+              <a:defRPr sz="1300" b="1">
                 <a:solidFill>
                   <a:srgbClr val="2563EB"/>
                 </a:solidFill>
@@ -29797,8 +29797,8 @@
         </p:nvSpPr>
         <p:spPr>
           <a:xfrm>
-            <a:off x="-3711092" y="2075688"/>
-            <a:ext cx="2331720" cy="228600"/>
+            <a:off x="685800" y="2011680"/>
+            <a:ext cx="2293543" cy="201168"/>
           </a:xfrm>
           <a:prstGeom prst="rect">
             <a:avLst/>
@@ -29816,7 +29816,7 @@
               <a:spcAft>
                 <a:spcPts val="0"/>
               </a:spcAft>
-              <a:defRPr sz="1000" b="0">
+              <a:defRPr sz="900" b="0">
                 <a:solidFill>
                   <a:srgbClr val="1A1A2E"/>
                 </a:solidFill>
@@ -29837,8 +29837,8 @@
         </p:nvSpPr>
         <p:spPr>
           <a:xfrm>
-            <a:off x="-967892" y="1051560"/>
-            <a:ext cx="2606040" cy="5166360"/>
+            <a:off x="3390823" y="1051560"/>
+            <a:ext cx="2567863" cy="2514600"/>
           </a:xfrm>
           <a:prstGeom prst="roundRect">
             <a:avLst>
@@ -29884,8 +29884,8 @@
         </p:nvSpPr>
         <p:spPr>
           <a:xfrm>
-            <a:off x="-967892" y="1051560"/>
-            <a:ext cx="45720" cy="5166360"/>
+            <a:off x="3390823" y="1051560"/>
+            <a:ext cx="45720" cy="2514600"/>
           </a:xfrm>
           <a:prstGeom prst="rect">
             <a:avLst/>
@@ -29927,7 +29927,7 @@
         </p:nvSpPr>
         <p:spPr>
           <a:xfrm>
-            <a:off x="-830732" y="1188720"/>
+            <a:off x="3527983" y="1188720"/>
             <a:ext cx="384048" cy="384048"/>
           </a:xfrm>
           <a:prstGeom prst="ellipse">
@@ -29970,7 +29970,7 @@
         </p:nvSpPr>
         <p:spPr>
           <a:xfrm>
-            <a:off x="-830732" y="1188720"/>
+            <a:off x="3527983" y="1188720"/>
             <a:ext cx="384048" cy="384048"/>
           </a:xfrm>
           <a:prstGeom prst="rect">
@@ -30010,8 +30010,8 @@
         </p:nvSpPr>
         <p:spPr>
           <a:xfrm>
-            <a:off x="-830732" y="1691640"/>
-            <a:ext cx="2331720" cy="320040"/>
+            <a:off x="3527983" y="1691640"/>
+            <a:ext cx="2293543" cy="274320"/>
           </a:xfrm>
           <a:prstGeom prst="rect">
             <a:avLst/>
@@ -30029,7 +30029,7 @@
               <a:spcAft>
                 <a:spcPts val="0"/>
               </a:spcAft>
-              <a:defRPr sz="1400" b="1">
+              <a:defRPr sz="1300" b="1">
                 <a:solidFill>
                   <a:srgbClr val="0D9488"/>
                 </a:solidFill>
@@ -30050,8 +30050,8 @@
         </p:nvSpPr>
         <p:spPr>
           <a:xfrm>
-            <a:off x="-830732" y="2075688"/>
-            <a:ext cx="2331720" cy="228600"/>
+            <a:off x="3527983" y="2011680"/>
+            <a:ext cx="2293543" cy="201168"/>
           </a:xfrm>
           <a:prstGeom prst="rect">
             <a:avLst/>
@@ -30069,7 +30069,7 @@
               <a:spcAft>
                 <a:spcPts val="0"/>
               </a:spcAft>
-              <a:defRPr sz="1000" b="0">
+              <a:defRPr sz="900" b="0">
                 <a:solidFill>
                   <a:srgbClr val="1A1A2E"/>
                 </a:solidFill>
@@ -30090,8 +30090,8 @@
         </p:nvSpPr>
         <p:spPr>
           <a:xfrm>
-            <a:off x="1912467" y="1051560"/>
-            <a:ext cx="2606040" cy="5166360"/>
+            <a:off x="6233007" y="1051560"/>
+            <a:ext cx="2567863" cy="2514600"/>
           </a:xfrm>
           <a:prstGeom prst="roundRect">
             <a:avLst>
@@ -30137,8 +30137,8 @@
         </p:nvSpPr>
         <p:spPr>
           <a:xfrm>
-            <a:off x="1912467" y="1051560"/>
-            <a:ext cx="45720" cy="5166360"/>
+            <a:off x="6233007" y="1051560"/>
+            <a:ext cx="45720" cy="2514600"/>
           </a:xfrm>
           <a:prstGeom prst="rect">
             <a:avLst/>
@@ -30180,7 +30180,7 @@
         </p:nvSpPr>
         <p:spPr>
           <a:xfrm>
-            <a:off x="2049627" y="1188720"/>
+            <a:off x="6370167" y="1188720"/>
             <a:ext cx="384048" cy="384048"/>
           </a:xfrm>
           <a:prstGeom prst="ellipse">
@@ -30223,7 +30223,7 @@
         </p:nvSpPr>
         <p:spPr>
           <a:xfrm>
-            <a:off x="2049627" y="1188720"/>
+            <a:off x="6370167" y="1188720"/>
             <a:ext cx="384048" cy="384048"/>
           </a:xfrm>
           <a:prstGeom prst="rect">
@@ -30263,8 +30263,8 @@
         </p:nvSpPr>
         <p:spPr>
           <a:xfrm>
-            <a:off x="2049627" y="1691640"/>
-            <a:ext cx="2331720" cy="320040"/>
+            <a:off x="6370167" y="1691640"/>
+            <a:ext cx="2293543" cy="274320"/>
           </a:xfrm>
           <a:prstGeom prst="rect">
             <a:avLst/>
@@ -30282,7 +30282,7 @@
               <a:spcAft>
                 <a:spcPts val="0"/>
               </a:spcAft>
-              <a:defRPr sz="1400" b="1">
+              <a:defRPr sz="1300" b="1">
                 <a:solidFill>
                   <a:srgbClr val="B8860B"/>
                 </a:solidFill>
@@ -30303,8 +30303,8 @@
         </p:nvSpPr>
         <p:spPr>
           <a:xfrm>
-            <a:off x="2049627" y="2075688"/>
-            <a:ext cx="2331720" cy="228600"/>
+            <a:off x="6370167" y="2011680"/>
+            <a:ext cx="2293543" cy="201168"/>
           </a:xfrm>
           <a:prstGeom prst="rect">
             <a:avLst/>
@@ -30322,7 +30322,7 @@
               <a:spcAft>
                 <a:spcPts val="0"/>
               </a:spcAft>
-              <a:defRPr sz="1000" b="0">
+              <a:defRPr sz="900" b="0">
                 <a:solidFill>
                   <a:srgbClr val="1A1A2E"/>
                 </a:solidFill>
@@ -30343,8 +30343,8 @@
         </p:nvSpPr>
         <p:spPr>
           <a:xfrm>
-            <a:off x="4792827" y="1051560"/>
-            <a:ext cx="2606040" cy="5166360"/>
+            <a:off x="9075191" y="1051560"/>
+            <a:ext cx="2567863" cy="2514600"/>
           </a:xfrm>
           <a:prstGeom prst="roundRect">
             <a:avLst>
@@ -30390,8 +30390,8 @@
         </p:nvSpPr>
         <p:spPr>
           <a:xfrm>
-            <a:off x="4792827" y="1051560"/>
-            <a:ext cx="45720" cy="5166360"/>
+            <a:off x="9075191" y="1051560"/>
+            <a:ext cx="45720" cy="2514600"/>
           </a:xfrm>
           <a:prstGeom prst="rect">
             <a:avLst/>
@@ -30433,7 +30433,7 @@
         </p:nvSpPr>
         <p:spPr>
           <a:xfrm>
-            <a:off x="4929987" y="1188720"/>
+            <a:off x="9212351" y="1188720"/>
             <a:ext cx="384048" cy="384048"/>
           </a:xfrm>
           <a:prstGeom prst="ellipse">
@@ -30476,7 +30476,7 @@
         </p:nvSpPr>
         <p:spPr>
           <a:xfrm>
-            <a:off x="4929987" y="1188720"/>
+            <a:off x="9212351" y="1188720"/>
             <a:ext cx="384048" cy="384048"/>
           </a:xfrm>
           <a:prstGeom prst="rect">
@@ -30516,8 +30516,8 @@
         </p:nvSpPr>
         <p:spPr>
           <a:xfrm>
-            <a:off x="4929987" y="1691640"/>
-            <a:ext cx="2331720" cy="320040"/>
+            <a:off x="9212351" y="1691640"/>
+            <a:ext cx="2293543" cy="274320"/>
           </a:xfrm>
           <a:prstGeom prst="rect">
             <a:avLst/>
@@ -30535,7 +30535,7 @@
               <a:spcAft>
                 <a:spcPts val="0"/>
               </a:spcAft>
-              <a:defRPr sz="1400" b="1">
+              <a:defRPr sz="1300" b="1">
                 <a:solidFill>
                   <a:srgbClr val="1B3A6B"/>
                 </a:solidFill>
@@ -30556,8 +30556,8 @@
         </p:nvSpPr>
         <p:spPr>
           <a:xfrm>
-            <a:off x="4929987" y="2075688"/>
-            <a:ext cx="2331720" cy="228600"/>
+            <a:off x="9212351" y="2011680"/>
+            <a:ext cx="2293543" cy="201168"/>
           </a:xfrm>
           <a:prstGeom prst="rect">
             <a:avLst/>
@@ -30575,7 +30575,7 @@
               <a:spcAft>
                 <a:spcPts val="0"/>
               </a:spcAft>
-              <a:defRPr sz="1000" b="0">
+              <a:defRPr sz="900" b="0">
                 <a:solidFill>
                   <a:srgbClr val="1A1A2E"/>
                 </a:solidFill>
@@ -30596,8 +30596,8 @@
         </p:nvSpPr>
         <p:spPr>
           <a:xfrm>
-            <a:off x="7673187" y="1051560"/>
-            <a:ext cx="2606040" cy="5166360"/>
+            <a:off x="548640" y="3794760"/>
+            <a:ext cx="2567863" cy="2514600"/>
           </a:xfrm>
           <a:prstGeom prst="roundRect">
             <a:avLst>
@@ -30643,8 +30643,8 @@
         </p:nvSpPr>
         <p:spPr>
           <a:xfrm>
-            <a:off x="7673187" y="1051560"/>
-            <a:ext cx="45720" cy="5166360"/>
+            <a:off x="548640" y="3794760"/>
+            <a:ext cx="45720" cy="2514600"/>
           </a:xfrm>
           <a:prstGeom prst="rect">
             <a:avLst/>
@@ -30686,7 +30686,7 @@
         </p:nvSpPr>
         <p:spPr>
           <a:xfrm>
-            <a:off x="7810347" y="1188720"/>
+            <a:off x="685800" y="3931920"/>
             <a:ext cx="384048" cy="384048"/>
           </a:xfrm>
           <a:prstGeom prst="ellipse">
@@ -30729,7 +30729,7 @@
         </p:nvSpPr>
         <p:spPr>
           <a:xfrm>
-            <a:off x="7810347" y="1188720"/>
+            <a:off x="685800" y="3931920"/>
             <a:ext cx="384048" cy="384048"/>
           </a:xfrm>
           <a:prstGeom prst="rect">
@@ -30769,8 +30769,8 @@
         </p:nvSpPr>
         <p:spPr>
           <a:xfrm>
-            <a:off x="7810347" y="1691640"/>
-            <a:ext cx="2331720" cy="320040"/>
+            <a:off x="685800" y="4434840"/>
+            <a:ext cx="2293543" cy="274320"/>
           </a:xfrm>
           <a:prstGeom prst="rect">
             <a:avLst/>
@@ -30788,7 +30788,7 @@
               <a:spcAft>
                 <a:spcPts val="0"/>
               </a:spcAft>
-              <a:defRPr sz="1400" b="1">
+              <a:defRPr sz="1300" b="1">
                 <a:solidFill>
                   <a:srgbClr val="2563EB"/>
                 </a:solidFill>
@@ -30809,8 +30809,8 @@
         </p:nvSpPr>
         <p:spPr>
           <a:xfrm>
-            <a:off x="7810347" y="2075688"/>
-            <a:ext cx="2331720" cy="228600"/>
+            <a:off x="685800" y="4754880"/>
+            <a:ext cx="2293543" cy="201168"/>
           </a:xfrm>
           <a:prstGeom prst="rect">
             <a:avLst/>
@@ -30828,7 +30828,7 @@
               <a:spcAft>
                 <a:spcPts val="0"/>
               </a:spcAft>
-              <a:defRPr sz="1000" b="0">
+              <a:defRPr sz="900" b="0">
                 <a:solidFill>
                   <a:srgbClr val="1A1A2E"/>
                 </a:solidFill>
@@ -30849,8 +30849,8 @@
         </p:nvSpPr>
         <p:spPr>
           <a:xfrm>
-            <a:off x="10553547" y="1051560"/>
-            <a:ext cx="2606040" cy="5166360"/>
+            <a:off x="3390823" y="3794760"/>
+            <a:ext cx="2567863" cy="2514600"/>
           </a:xfrm>
           <a:prstGeom prst="roundRect">
             <a:avLst>
@@ -30896,8 +30896,8 @@
         </p:nvSpPr>
         <p:spPr>
           <a:xfrm>
-            <a:off x="10553547" y="1051560"/>
-            <a:ext cx="45720" cy="5166360"/>
+            <a:off x="3390823" y="3794760"/>
+            <a:ext cx="45720" cy="2514600"/>
           </a:xfrm>
           <a:prstGeom prst="rect">
             <a:avLst/>
@@ -30939,7 +30939,7 @@
         </p:nvSpPr>
         <p:spPr>
           <a:xfrm>
-            <a:off x="10690707" y="1188720"/>
+            <a:off x="3527983" y="3931920"/>
             <a:ext cx="384048" cy="384048"/>
           </a:xfrm>
           <a:prstGeom prst="ellipse">
@@ -30982,7 +30982,7 @@
         </p:nvSpPr>
         <p:spPr>
           <a:xfrm>
-            <a:off x="10690707" y="1188720"/>
+            <a:off x="3527983" y="3931920"/>
             <a:ext cx="384048" cy="384048"/>
           </a:xfrm>
           <a:prstGeom prst="rect">
@@ -31022,8 +31022,8 @@
         </p:nvSpPr>
         <p:spPr>
           <a:xfrm>
-            <a:off x="10690707" y="1691640"/>
-            <a:ext cx="2331720" cy="320040"/>
+            <a:off x="3527983" y="4434840"/>
+            <a:ext cx="2293543" cy="274320"/>
           </a:xfrm>
           <a:prstGeom prst="rect">
             <a:avLst/>
@@ -31041,7 +31041,7 @@
               <a:spcAft>
                 <a:spcPts val="0"/>
               </a:spcAft>
-              <a:defRPr sz="1400" b="1">
+              <a:defRPr sz="1300" b="1">
                 <a:solidFill>
                   <a:srgbClr val="0D9488"/>
                 </a:solidFill>
@@ -31062,8 +31062,8 @@
         </p:nvSpPr>
         <p:spPr>
           <a:xfrm>
-            <a:off x="10690707" y="2075688"/>
-            <a:ext cx="2331720" cy="228600"/>
+            <a:off x="3527983" y="4754880"/>
+            <a:ext cx="2293543" cy="201168"/>
           </a:xfrm>
           <a:prstGeom prst="rect">
             <a:avLst/>
@@ -31081,7 +31081,7 @@
               <a:spcAft>
                 <a:spcPts val="0"/>
               </a:spcAft>
-              <a:defRPr sz="1000" b="0">
+              <a:defRPr sz="900" b="0">
                 <a:solidFill>
                   <a:srgbClr val="1A1A2E"/>
                 </a:solidFill>
@@ -31102,8 +31102,8 @@
         </p:nvSpPr>
         <p:spPr>
           <a:xfrm>
-            <a:off x="13433907" y="1051560"/>
-            <a:ext cx="2606040" cy="5166360"/>
+            <a:off x="6233007" y="3794760"/>
+            <a:ext cx="2567863" cy="2514600"/>
           </a:xfrm>
           <a:prstGeom prst="roundRect">
             <a:avLst>
@@ -31149,8 +31149,8 @@
         </p:nvSpPr>
         <p:spPr>
           <a:xfrm>
-            <a:off x="13433907" y="1051560"/>
-            <a:ext cx="45720" cy="5166360"/>
+            <a:off x="6233007" y="3794760"/>
+            <a:ext cx="45720" cy="2514600"/>
           </a:xfrm>
           <a:prstGeom prst="rect">
             <a:avLst/>
@@ -31192,7 +31192,7 @@
         </p:nvSpPr>
         <p:spPr>
           <a:xfrm>
-            <a:off x="13571067" y="1188720"/>
+            <a:off x="6370167" y="3931920"/>
             <a:ext cx="384048" cy="384048"/>
           </a:xfrm>
           <a:prstGeom prst="ellipse">
@@ -31235,7 +31235,7 @@
         </p:nvSpPr>
         <p:spPr>
           <a:xfrm>
-            <a:off x="13571067" y="1188720"/>
+            <a:off x="6370167" y="3931920"/>
             <a:ext cx="384048" cy="384048"/>
           </a:xfrm>
           <a:prstGeom prst="rect">
@@ -31275,8 +31275,8 @@
         </p:nvSpPr>
         <p:spPr>
           <a:xfrm>
-            <a:off x="13571067" y="1691640"/>
-            <a:ext cx="2331720" cy="320040"/>
+            <a:off x="6370167" y="4434840"/>
+            <a:ext cx="2293543" cy="274320"/>
           </a:xfrm>
           <a:prstGeom prst="rect">
             <a:avLst/>
@@ -31294,7 +31294,7 @@
               <a:spcAft>
                 <a:spcPts val="0"/>
               </a:spcAft>
-              <a:defRPr sz="1400" b="1">
+              <a:defRPr sz="1300" b="1">
                 <a:solidFill>
                   <a:srgbClr val="B8860B"/>
                 </a:solidFill>
@@ -31315,8 +31315,8 @@
         </p:nvSpPr>
         <p:spPr>
           <a:xfrm>
-            <a:off x="13571067" y="2075688"/>
-            <a:ext cx="2331720" cy="228600"/>
+            <a:off x="6370167" y="4754880"/>
+            <a:ext cx="2293543" cy="201168"/>
           </a:xfrm>
           <a:prstGeom prst="rect">
             <a:avLst/>
@@ -31334,7 +31334,7 @@
               <a:spcAft>
                 <a:spcPts val="0"/>
               </a:spcAft>
-              <a:defRPr sz="1000" b="0">
+              <a:defRPr sz="900" b="0">
                 <a:solidFill>
                   <a:srgbClr val="1A1A2E"/>
                 </a:solidFill>
@@ -32161,8 +32161,8 @@
         </p:nvSpPr>
         <p:spPr>
           <a:xfrm>
-            <a:off x="655167" y="1051560"/>
-            <a:ext cx="5303520" cy="5166360"/>
+            <a:off x="548640" y="1051560"/>
+            <a:ext cx="5410047" cy="5257800"/>
           </a:xfrm>
           <a:prstGeom prst="roundRect">
             <a:avLst>
@@ -32208,8 +32208,8 @@
         </p:nvSpPr>
         <p:spPr>
           <a:xfrm>
-            <a:off x="655167" y="1051560"/>
-            <a:ext cx="45720" cy="5166360"/>
+            <a:off x="548640" y="1051560"/>
+            <a:ext cx="45720" cy="5257800"/>
           </a:xfrm>
           <a:prstGeom prst="rect">
             <a:avLst/>
@@ -32251,7 +32251,7 @@
         </p:nvSpPr>
         <p:spPr>
           <a:xfrm>
-            <a:off x="792327" y="1188720"/>
+            <a:off x="685800" y="1188720"/>
             <a:ext cx="384048" cy="384048"/>
           </a:xfrm>
           <a:prstGeom prst="ellipse">
@@ -32294,7 +32294,7 @@
         </p:nvSpPr>
         <p:spPr>
           <a:xfrm>
-            <a:off x="792327" y="1188720"/>
+            <a:off x="685800" y="1188720"/>
             <a:ext cx="384048" cy="384048"/>
           </a:xfrm>
           <a:prstGeom prst="rect">
@@ -32334,8 +32334,8 @@
         </p:nvSpPr>
         <p:spPr>
           <a:xfrm>
-            <a:off x="792327" y="1691640"/>
-            <a:ext cx="5029200" cy="320040"/>
+            <a:off x="685800" y="1691640"/>
+            <a:ext cx="5135727" cy="274320"/>
           </a:xfrm>
           <a:prstGeom prst="rect">
             <a:avLst/>
@@ -32353,7 +32353,7 @@
               <a:spcAft>
                 <a:spcPts val="0"/>
               </a:spcAft>
-              <a:defRPr sz="1400" b="1">
+              <a:defRPr sz="1300" b="1">
                 <a:solidFill>
                   <a:srgbClr val="2563EB"/>
                 </a:solidFill>
@@ -32374,8 +32374,8 @@
         </p:nvSpPr>
         <p:spPr>
           <a:xfrm>
-            <a:off x="792327" y="2075688"/>
-            <a:ext cx="5029200" cy="228600"/>
+            <a:off x="685800" y="2011680"/>
+            <a:ext cx="5135727" cy="201168"/>
           </a:xfrm>
           <a:prstGeom prst="rect">
             <a:avLst/>
@@ -32393,7 +32393,7 @@
               <a:spcAft>
                 <a:spcPts val="0"/>
               </a:spcAft>
-              <a:defRPr sz="1000" b="0">
+              <a:defRPr sz="900" b="0">
                 <a:solidFill>
                   <a:srgbClr val="1A1A2E"/>
                 </a:solidFill>
@@ -32414,8 +32414,8 @@
         </p:nvSpPr>
         <p:spPr>
           <a:xfrm>
-            <a:off x="792327" y="2295144"/>
-            <a:ext cx="5029200" cy="228600"/>
+            <a:off x="685800" y="2212848"/>
+            <a:ext cx="5135727" cy="201168"/>
           </a:xfrm>
           <a:prstGeom prst="rect">
             <a:avLst/>
@@ -32433,7 +32433,7 @@
               <a:spcAft>
                 <a:spcPts val="0"/>
               </a:spcAft>
-              <a:defRPr sz="1000" b="0">
+              <a:defRPr sz="900" b="0">
                 <a:solidFill>
                   <a:srgbClr val="1A1A2E"/>
                 </a:solidFill>
@@ -32454,8 +32454,8 @@
         </p:nvSpPr>
         <p:spPr>
           <a:xfrm>
-            <a:off x="792327" y="2514600"/>
-            <a:ext cx="5029200" cy="228600"/>
+            <a:off x="685800" y="2414016"/>
+            <a:ext cx="5135727" cy="201168"/>
           </a:xfrm>
           <a:prstGeom prst="rect">
             <a:avLst/>
@@ -32473,7 +32473,7 @@
               <a:spcAft>
                 <a:spcPts val="0"/>
               </a:spcAft>
-              <a:defRPr sz="1000" b="0">
+              <a:defRPr sz="900" b="0">
                 <a:solidFill>
                   <a:srgbClr val="1A1A2E"/>
                 </a:solidFill>
@@ -32494,8 +32494,8 @@
         </p:nvSpPr>
         <p:spPr>
           <a:xfrm>
-            <a:off x="792327" y="2734056"/>
-            <a:ext cx="5029200" cy="228600"/>
+            <a:off x="685800" y="2615184"/>
+            <a:ext cx="5135727" cy="201168"/>
           </a:xfrm>
           <a:prstGeom prst="rect">
             <a:avLst/>
@@ -32513,7 +32513,7 @@
               <a:spcAft>
                 <a:spcPts val="0"/>
               </a:spcAft>
-              <a:defRPr sz="1000" b="0">
+              <a:defRPr sz="900" b="0">
                 <a:solidFill>
                   <a:srgbClr val="1A1A2E"/>
                 </a:solidFill>
@@ -32534,8 +32534,8 @@
         </p:nvSpPr>
         <p:spPr>
           <a:xfrm>
-            <a:off x="792327" y="2953512"/>
-            <a:ext cx="5029200" cy="228600"/>
+            <a:off x="685800" y="2816352"/>
+            <a:ext cx="5135727" cy="201168"/>
           </a:xfrm>
           <a:prstGeom prst="rect">
             <a:avLst/>
@@ -32553,7 +32553,7 @@
               <a:spcAft>
                 <a:spcPts val="0"/>
               </a:spcAft>
-              <a:defRPr sz="1000" b="0">
+              <a:defRPr sz="900" b="0">
                 <a:solidFill>
                   <a:srgbClr val="1A1A2E"/>
                 </a:solidFill>
@@ -32574,8 +32574,8 @@
         </p:nvSpPr>
         <p:spPr>
           <a:xfrm>
-            <a:off x="792327" y="3172968"/>
-            <a:ext cx="5029200" cy="228600"/>
+            <a:off x="685800" y="3017520"/>
+            <a:ext cx="5135727" cy="201168"/>
           </a:xfrm>
           <a:prstGeom prst="rect">
             <a:avLst/>
@@ -32593,7 +32593,7 @@
               <a:spcAft>
                 <a:spcPts val="0"/>
               </a:spcAft>
-              <a:defRPr sz="1000" b="0">
+              <a:defRPr sz="900" b="0">
                 <a:solidFill>
                   <a:srgbClr val="1A1A2E"/>
                 </a:solidFill>
@@ -32614,8 +32614,8 @@
         </p:nvSpPr>
         <p:spPr>
           <a:xfrm>
-            <a:off x="792327" y="3392424"/>
-            <a:ext cx="5029200" cy="228600"/>
+            <a:off x="685800" y="3218688"/>
+            <a:ext cx="5135727" cy="201168"/>
           </a:xfrm>
           <a:prstGeom prst="rect">
             <a:avLst/>
@@ -32633,7 +32633,7 @@
               <a:spcAft>
                 <a:spcPts val="0"/>
               </a:spcAft>
-              <a:defRPr sz="1000" b="0">
+              <a:defRPr sz="900" b="0">
                 <a:solidFill>
                   <a:srgbClr val="1A1A2E"/>
                 </a:solidFill>
@@ -32654,8 +32654,8 @@
         </p:nvSpPr>
         <p:spPr>
           <a:xfrm>
-            <a:off x="792327" y="3611880"/>
-            <a:ext cx="5029200" cy="228600"/>
+            <a:off x="685800" y="3419856"/>
+            <a:ext cx="5135727" cy="201168"/>
           </a:xfrm>
           <a:prstGeom prst="rect">
             <a:avLst/>
@@ -32673,7 +32673,7 @@
               <a:spcAft>
                 <a:spcPts val="0"/>
               </a:spcAft>
-              <a:defRPr sz="1000" b="0">
+              <a:defRPr sz="900" b="0">
                 <a:solidFill>
                   <a:srgbClr val="1A1A2E"/>
                 </a:solidFill>
@@ -32694,8 +32694,8 @@
         </p:nvSpPr>
         <p:spPr>
           <a:xfrm>
-            <a:off x="792327" y="3831336"/>
-            <a:ext cx="5029200" cy="228600"/>
+            <a:off x="685800" y="3621024"/>
+            <a:ext cx="5135727" cy="201168"/>
           </a:xfrm>
           <a:prstGeom prst="rect">
             <a:avLst/>
@@ -32713,7 +32713,7 @@
               <a:spcAft>
                 <a:spcPts val="0"/>
               </a:spcAft>
-              <a:defRPr sz="1000" b="0">
+              <a:defRPr sz="900" b="0">
                 <a:solidFill>
                   <a:srgbClr val="1A1A2E"/>
                 </a:solidFill>
@@ -32734,8 +32734,8 @@
         </p:nvSpPr>
         <p:spPr>
           <a:xfrm>
-            <a:off x="792327" y="4050792"/>
-            <a:ext cx="5029200" cy="228600"/>
+            <a:off x="685800" y="3822192"/>
+            <a:ext cx="5135727" cy="201168"/>
           </a:xfrm>
           <a:prstGeom prst="rect">
             <a:avLst/>
@@ -32753,7 +32753,7 @@
               <a:spcAft>
                 <a:spcPts val="0"/>
               </a:spcAft>
-              <a:defRPr sz="1000" b="0">
+              <a:defRPr sz="900" b="0">
                 <a:solidFill>
                   <a:srgbClr val="1A1A2E"/>
                 </a:solidFill>
@@ -32775,7 +32775,7 @@
         <p:spPr>
           <a:xfrm>
             <a:off x="6233007" y="1051560"/>
-            <a:ext cx="5303520" cy="5166360"/>
+            <a:ext cx="5410047" cy="5257800"/>
           </a:xfrm>
           <a:prstGeom prst="roundRect">
             <a:avLst>
@@ -32822,7 +32822,7 @@
         <p:spPr>
           <a:xfrm>
             <a:off x="6233007" y="1051560"/>
-            <a:ext cx="45720" cy="5166360"/>
+            <a:ext cx="45720" cy="5257800"/>
           </a:xfrm>
           <a:prstGeom prst="rect">
             <a:avLst/>
@@ -32948,7 +32948,7 @@
         <p:spPr>
           <a:xfrm>
             <a:off x="6370167" y="1691640"/>
-            <a:ext cx="5029200" cy="320040"/>
+            <a:ext cx="5135727" cy="274320"/>
           </a:xfrm>
           <a:prstGeom prst="rect">
             <a:avLst/>
@@ -32966,7 +32966,7 @@
               <a:spcAft>
                 <a:spcPts val="0"/>
               </a:spcAft>
-              <a:defRPr sz="1400" b="1">
+              <a:defRPr sz="1300" b="1">
                 <a:solidFill>
                   <a:srgbClr val="0D9488"/>
                 </a:solidFill>
@@ -32987,8 +32987,8 @@
         </p:nvSpPr>
         <p:spPr>
           <a:xfrm>
-            <a:off x="6370167" y="2075688"/>
-            <a:ext cx="5029200" cy="228600"/>
+            <a:off x="6370167" y="2011680"/>
+            <a:ext cx="5135727" cy="201168"/>
           </a:xfrm>
           <a:prstGeom prst="rect">
             <a:avLst/>
@@ -33006,7 +33006,7 @@
               <a:spcAft>
                 <a:spcPts val="0"/>
               </a:spcAft>
-              <a:defRPr sz="1000" b="0">
+              <a:defRPr sz="900" b="0">
                 <a:solidFill>
                   <a:srgbClr val="1A1A2E"/>
                 </a:solidFill>
@@ -33027,8 +33027,8 @@
         </p:nvSpPr>
         <p:spPr>
           <a:xfrm>
-            <a:off x="6370167" y="2295144"/>
-            <a:ext cx="5029200" cy="228600"/>
+            <a:off x="6370167" y="2212848"/>
+            <a:ext cx="5135727" cy="201168"/>
           </a:xfrm>
           <a:prstGeom prst="rect">
             <a:avLst/>
@@ -33046,7 +33046,7 @@
               <a:spcAft>
                 <a:spcPts val="0"/>
               </a:spcAft>
-              <a:defRPr sz="1000" b="0">
+              <a:defRPr sz="900" b="0">
                 <a:solidFill>
                   <a:srgbClr val="1A1A2E"/>
                 </a:solidFill>
@@ -33067,8 +33067,8 @@
         </p:nvSpPr>
         <p:spPr>
           <a:xfrm>
-            <a:off x="6370167" y="2514600"/>
-            <a:ext cx="5029200" cy="228600"/>
+            <a:off x="6370167" y="2414016"/>
+            <a:ext cx="5135727" cy="201168"/>
           </a:xfrm>
           <a:prstGeom prst="rect">
             <a:avLst/>
@@ -33086,7 +33086,7 @@
               <a:spcAft>
                 <a:spcPts val="0"/>
               </a:spcAft>
-              <a:defRPr sz="1000" b="0">
+              <a:defRPr sz="900" b="0">
                 <a:solidFill>
                   <a:srgbClr val="1A1A2E"/>
                 </a:solidFill>
@@ -33107,8 +33107,8 @@
         </p:nvSpPr>
         <p:spPr>
           <a:xfrm>
-            <a:off x="6370167" y="2734056"/>
-            <a:ext cx="5029200" cy="228600"/>
+            <a:off x="6370167" y="2615184"/>
+            <a:ext cx="5135727" cy="201168"/>
           </a:xfrm>
           <a:prstGeom prst="rect">
             <a:avLst/>
@@ -33126,7 +33126,7 @@
               <a:spcAft>
                 <a:spcPts val="0"/>
               </a:spcAft>
-              <a:defRPr sz="1000" b="0">
+              <a:defRPr sz="900" b="0">
                 <a:solidFill>
                   <a:srgbClr val="1A1A2E"/>
                 </a:solidFill>
@@ -33147,8 +33147,8 @@
         </p:nvSpPr>
         <p:spPr>
           <a:xfrm>
-            <a:off x="6370167" y="2953512"/>
-            <a:ext cx="5029200" cy="228600"/>
+            <a:off x="6370167" y="2816352"/>
+            <a:ext cx="5135727" cy="201168"/>
           </a:xfrm>
           <a:prstGeom prst="rect">
             <a:avLst/>
@@ -33166,7 +33166,7 @@
               <a:spcAft>
                 <a:spcPts val="0"/>
               </a:spcAft>
-              <a:defRPr sz="1000" b="0">
+              <a:defRPr sz="900" b="0">
                 <a:solidFill>
                   <a:srgbClr val="1A1A2E"/>
                 </a:solidFill>
@@ -33187,8 +33187,8 @@
         </p:nvSpPr>
         <p:spPr>
           <a:xfrm>
-            <a:off x="6370167" y="3172968"/>
-            <a:ext cx="5029200" cy="228600"/>
+            <a:off x="6370167" y="3017520"/>
+            <a:ext cx="5135727" cy="201168"/>
           </a:xfrm>
           <a:prstGeom prst="rect">
             <a:avLst/>
@@ -33206,7 +33206,7 @@
               <a:spcAft>
                 <a:spcPts val="0"/>
               </a:spcAft>
-              <a:defRPr sz="1000" b="0">
+              <a:defRPr sz="900" b="0">
                 <a:solidFill>
                   <a:srgbClr val="1A1A2E"/>
                 </a:solidFill>
@@ -33227,8 +33227,8 @@
         </p:nvSpPr>
         <p:spPr>
           <a:xfrm>
-            <a:off x="6370167" y="3392424"/>
-            <a:ext cx="5029200" cy="228600"/>
+            <a:off x="6370167" y="3218688"/>
+            <a:ext cx="5135727" cy="201168"/>
           </a:xfrm>
           <a:prstGeom prst="rect">
             <a:avLst/>
@@ -33246,7 +33246,7 @@
               <a:spcAft>
                 <a:spcPts val="0"/>
               </a:spcAft>
-              <a:defRPr sz="1000" b="0">
+              <a:defRPr sz="900" b="0">
                 <a:solidFill>
                   <a:srgbClr val="1A1A2E"/>
                 </a:solidFill>
@@ -33267,8 +33267,8 @@
         </p:nvSpPr>
         <p:spPr>
           <a:xfrm>
-            <a:off x="6370167" y="3611880"/>
-            <a:ext cx="5029200" cy="228600"/>
+            <a:off x="6370167" y="3419856"/>
+            <a:ext cx="5135727" cy="201168"/>
           </a:xfrm>
           <a:prstGeom prst="rect">
             <a:avLst/>
@@ -33286,7 +33286,7 @@
               <a:spcAft>
                 <a:spcPts val="0"/>
               </a:spcAft>
-              <a:defRPr sz="1000" b="0">
+              <a:defRPr sz="900" b="0">
                 <a:solidFill>
                   <a:srgbClr val="1A1A2E"/>
                 </a:solidFill>
@@ -33665,8 +33665,8 @@
         </p:nvSpPr>
         <p:spPr>
           <a:xfrm>
-            <a:off x="655167" y="1051560"/>
-            <a:ext cx="5303520" cy="5166360"/>
+            <a:off x="548640" y="1051560"/>
+            <a:ext cx="5410047" cy="5257800"/>
           </a:xfrm>
           <a:prstGeom prst="roundRect">
             <a:avLst>
@@ -33712,8 +33712,8 @@
         </p:nvSpPr>
         <p:spPr>
           <a:xfrm>
-            <a:off x="655167" y="1051560"/>
-            <a:ext cx="45720" cy="5166360"/>
+            <a:off x="548640" y="1051560"/>
+            <a:ext cx="45720" cy="5257800"/>
           </a:xfrm>
           <a:prstGeom prst="rect">
             <a:avLst/>
@@ -33755,7 +33755,7 @@
         </p:nvSpPr>
         <p:spPr>
           <a:xfrm>
-            <a:off x="792327" y="1188720"/>
+            <a:off x="685800" y="1188720"/>
             <a:ext cx="384048" cy="384048"/>
           </a:xfrm>
           <a:prstGeom prst="ellipse">
@@ -33798,7 +33798,7 @@
         </p:nvSpPr>
         <p:spPr>
           <a:xfrm>
-            <a:off x="792327" y="1188720"/>
+            <a:off x="685800" y="1188720"/>
             <a:ext cx="384048" cy="384048"/>
           </a:xfrm>
           <a:prstGeom prst="rect">
@@ -33838,8 +33838,8 @@
         </p:nvSpPr>
         <p:spPr>
           <a:xfrm>
-            <a:off x="792327" y="1691640"/>
-            <a:ext cx="5029200" cy="320040"/>
+            <a:off x="685800" y="1691640"/>
+            <a:ext cx="5135727" cy="274320"/>
           </a:xfrm>
           <a:prstGeom prst="rect">
             <a:avLst/>
@@ -33857,7 +33857,7 @@
               <a:spcAft>
                 <a:spcPts val="0"/>
               </a:spcAft>
-              <a:defRPr sz="1400" b="1">
+              <a:defRPr sz="1300" b="1">
                 <a:solidFill>
                   <a:srgbClr val="2563EB"/>
                 </a:solidFill>
@@ -33878,8 +33878,8 @@
         </p:nvSpPr>
         <p:spPr>
           <a:xfrm>
-            <a:off x="792327" y="2075688"/>
-            <a:ext cx="5029200" cy="228600"/>
+            <a:off x="685800" y="2011680"/>
+            <a:ext cx="5135727" cy="201168"/>
           </a:xfrm>
           <a:prstGeom prst="rect">
             <a:avLst/>
@@ -33897,7 +33897,7 @@
               <a:spcAft>
                 <a:spcPts val="0"/>
               </a:spcAft>
-              <a:defRPr sz="1000" b="0">
+              <a:defRPr sz="900" b="0">
                 <a:solidFill>
                   <a:srgbClr val="1A1A2E"/>
                 </a:solidFill>
@@ -33918,8 +33918,8 @@
         </p:nvSpPr>
         <p:spPr>
           <a:xfrm>
-            <a:off x="792327" y="2295144"/>
-            <a:ext cx="5029200" cy="228600"/>
+            <a:off x="685800" y="2212848"/>
+            <a:ext cx="5135727" cy="201168"/>
           </a:xfrm>
           <a:prstGeom prst="rect">
             <a:avLst/>
@@ -33937,7 +33937,7 @@
               <a:spcAft>
                 <a:spcPts val="0"/>
               </a:spcAft>
-              <a:defRPr sz="1000" b="0">
+              <a:defRPr sz="900" b="0">
                 <a:solidFill>
                   <a:srgbClr val="1A1A2E"/>
                 </a:solidFill>
@@ -33959,7 +33959,7 @@
         <p:spPr>
           <a:xfrm>
             <a:off x="6233007" y="1051560"/>
-            <a:ext cx="5303520" cy="5166360"/>
+            <a:ext cx="5410047" cy="5257800"/>
           </a:xfrm>
           <a:prstGeom prst="roundRect">
             <a:avLst>
@@ -34006,7 +34006,7 @@
         <p:spPr>
           <a:xfrm>
             <a:off x="6233007" y="1051560"/>
-            <a:ext cx="45720" cy="5166360"/>
+            <a:ext cx="45720" cy="5257800"/>
           </a:xfrm>
           <a:prstGeom prst="rect">
             <a:avLst/>
@@ -34132,7 +34132,7 @@
         <p:spPr>
           <a:xfrm>
             <a:off x="6370167" y="1691640"/>
-            <a:ext cx="5029200" cy="320040"/>
+            <a:ext cx="5135727" cy="274320"/>
           </a:xfrm>
           <a:prstGeom prst="rect">
             <a:avLst/>
@@ -34150,7 +34150,7 @@
               <a:spcAft>
                 <a:spcPts val="0"/>
               </a:spcAft>
-              <a:defRPr sz="1400" b="1">
+              <a:defRPr sz="1300" b="1">
                 <a:solidFill>
                   <a:srgbClr val="0D9488"/>
                 </a:solidFill>
@@ -34171,8 +34171,8 @@
         </p:nvSpPr>
         <p:spPr>
           <a:xfrm>
-            <a:off x="6370167" y="2075688"/>
-            <a:ext cx="5029200" cy="228600"/>
+            <a:off x="6370167" y="2011680"/>
+            <a:ext cx="5135727" cy="201168"/>
           </a:xfrm>
           <a:prstGeom prst="rect">
             <a:avLst/>
@@ -34190,7 +34190,7 @@
               <a:spcAft>
                 <a:spcPts val="0"/>
               </a:spcAft>
-              <a:defRPr sz="1000" b="0">
+              <a:defRPr sz="900" b="0">
                 <a:solidFill>
                   <a:srgbClr val="1A1A2E"/>
                 </a:solidFill>
@@ -34211,8 +34211,8 @@
         </p:nvSpPr>
         <p:spPr>
           <a:xfrm>
-            <a:off x="6370167" y="2295144"/>
-            <a:ext cx="5029200" cy="228600"/>
+            <a:off x="6370167" y="2212848"/>
+            <a:ext cx="5135727" cy="201168"/>
           </a:xfrm>
           <a:prstGeom prst="rect">
             <a:avLst/>
@@ -34230,7 +34230,7 @@
               <a:spcAft>
                 <a:spcPts val="0"/>
               </a:spcAft>
-              <a:defRPr sz="1000" b="0">
+              <a:defRPr sz="900" b="0">
                 <a:solidFill>
                   <a:srgbClr val="1A1A2E"/>
                 </a:solidFill>
@@ -34251,8 +34251,8 @@
         </p:nvSpPr>
         <p:spPr>
           <a:xfrm>
-            <a:off x="6370167" y="2514600"/>
-            <a:ext cx="5029200" cy="228600"/>
+            <a:off x="6370167" y="2414016"/>
+            <a:ext cx="5135727" cy="201168"/>
           </a:xfrm>
           <a:prstGeom prst="rect">
             <a:avLst/>
@@ -34270,7 +34270,7 @@
               <a:spcAft>
                 <a:spcPts val="0"/>
               </a:spcAft>
-              <a:defRPr sz="1000" b="0">
+              <a:defRPr sz="900" b="0">
                 <a:solidFill>
                   <a:srgbClr val="1A1A2E"/>
                 </a:solidFill>
@@ -34291,8 +34291,8 @@
         </p:nvSpPr>
         <p:spPr>
           <a:xfrm>
-            <a:off x="6370167" y="2734056"/>
-            <a:ext cx="5029200" cy="228600"/>
+            <a:off x="6370167" y="2615184"/>
+            <a:ext cx="5135727" cy="201168"/>
           </a:xfrm>
           <a:prstGeom prst="rect">
             <a:avLst/>
@@ -34310,7 +34310,7 @@
               <a:spcAft>
                 <a:spcPts val="0"/>
               </a:spcAft>
-              <a:defRPr sz="1000" b="0">
+              <a:defRPr sz="900" b="0">
                 <a:solidFill>
                   <a:srgbClr val="1A1A2E"/>
                 </a:solidFill>
@@ -35137,8 +35137,8 @@
         </p:nvSpPr>
         <p:spPr>
           <a:xfrm>
-            <a:off x="495147" y="1051560"/>
-            <a:ext cx="2560320" cy="2011680"/>
+            <a:off x="548640" y="1051560"/>
+            <a:ext cx="2567863" cy="2011680"/>
           </a:xfrm>
           <a:prstGeom prst="roundRect">
             <a:avLst>
@@ -35184,8 +35184,8 @@
         </p:nvSpPr>
         <p:spPr>
           <a:xfrm>
-            <a:off x="495147" y="1051560"/>
-            <a:ext cx="2560320" cy="45720"/>
+            <a:off x="548640" y="1051560"/>
+            <a:ext cx="2567863" cy="45720"/>
           </a:xfrm>
           <a:prstGeom prst="rect">
             <a:avLst/>
@@ -35227,8 +35227,8 @@
         </p:nvSpPr>
         <p:spPr>
           <a:xfrm>
-            <a:off x="495147" y="1280160"/>
-            <a:ext cx="2560320" cy="640080"/>
+            <a:off x="548640" y="1280160"/>
+            <a:ext cx="2567863" cy="640080"/>
           </a:xfrm>
           <a:prstGeom prst="rect">
             <a:avLst/>
@@ -35267,8 +35267,8 @@
         </p:nvSpPr>
         <p:spPr>
           <a:xfrm>
-            <a:off x="586587" y="1965960"/>
-            <a:ext cx="2377440" cy="640080"/>
+            <a:off x="640080" y="1965960"/>
+            <a:ext cx="2384983" cy="640080"/>
           </a:xfrm>
           <a:prstGeom prst="rect">
             <a:avLst/>
@@ -35311,8 +35311,8 @@
         </p:nvSpPr>
         <p:spPr>
           <a:xfrm>
-            <a:off x="3375507" y="1051560"/>
-            <a:ext cx="2560320" cy="2011680"/>
+            <a:off x="3390823" y="1051560"/>
+            <a:ext cx="2567863" cy="2011680"/>
           </a:xfrm>
           <a:prstGeom prst="roundRect">
             <a:avLst>
@@ -35358,8 +35358,8 @@
         </p:nvSpPr>
         <p:spPr>
           <a:xfrm>
-            <a:off x="3375507" y="1051560"/>
-            <a:ext cx="2560320" cy="45720"/>
+            <a:off x="3390823" y="1051560"/>
+            <a:ext cx="2567863" cy="45720"/>
           </a:xfrm>
           <a:prstGeom prst="rect">
             <a:avLst/>
@@ -35401,8 +35401,8 @@
         </p:nvSpPr>
         <p:spPr>
           <a:xfrm>
-            <a:off x="3375507" y="1280160"/>
-            <a:ext cx="2560320" cy="640080"/>
+            <a:off x="3390823" y="1280160"/>
+            <a:ext cx="2567863" cy="640080"/>
           </a:xfrm>
           <a:prstGeom prst="rect">
             <a:avLst/>
@@ -35441,8 +35441,8 @@
         </p:nvSpPr>
         <p:spPr>
           <a:xfrm>
-            <a:off x="3466947" y="1965960"/>
-            <a:ext cx="2377440" cy="640080"/>
+            <a:off x="3482263" y="1965960"/>
+            <a:ext cx="2384983" cy="640080"/>
           </a:xfrm>
           <a:prstGeom prst="rect">
             <a:avLst/>
@@ -35485,8 +35485,8 @@
         </p:nvSpPr>
         <p:spPr>
           <a:xfrm>
-            <a:off x="6255867" y="1051560"/>
-            <a:ext cx="2560320" cy="2011680"/>
+            <a:off x="6233007" y="1051560"/>
+            <a:ext cx="2567863" cy="2011680"/>
           </a:xfrm>
           <a:prstGeom prst="roundRect">
             <a:avLst>
@@ -35532,8 +35532,8 @@
         </p:nvSpPr>
         <p:spPr>
           <a:xfrm>
-            <a:off x="6255867" y="1051560"/>
-            <a:ext cx="2560320" cy="45720"/>
+            <a:off x="6233007" y="1051560"/>
+            <a:ext cx="2567863" cy="45720"/>
           </a:xfrm>
           <a:prstGeom prst="rect">
             <a:avLst/>
@@ -35575,8 +35575,8 @@
         </p:nvSpPr>
         <p:spPr>
           <a:xfrm>
-            <a:off x="6255867" y="1280160"/>
-            <a:ext cx="2560320" cy="640080"/>
+            <a:off x="6233007" y="1280160"/>
+            <a:ext cx="2567863" cy="640080"/>
           </a:xfrm>
           <a:prstGeom prst="rect">
             <a:avLst/>
@@ -35615,8 +35615,8 @@
         </p:nvSpPr>
         <p:spPr>
           <a:xfrm>
-            <a:off x="6347307" y="1965960"/>
-            <a:ext cx="2377440" cy="640080"/>
+            <a:off x="6324447" y="1965960"/>
+            <a:ext cx="2384983" cy="640080"/>
           </a:xfrm>
           <a:prstGeom prst="rect">
             <a:avLst/>
@@ -35659,8 +35659,8 @@
         </p:nvSpPr>
         <p:spPr>
           <a:xfrm>
-            <a:off x="9136227" y="1051560"/>
-            <a:ext cx="2560320" cy="2011680"/>
+            <a:off x="9075191" y="1051560"/>
+            <a:ext cx="2567863" cy="2011680"/>
           </a:xfrm>
           <a:prstGeom prst="roundRect">
             <a:avLst>
@@ -35706,8 +35706,8 @@
         </p:nvSpPr>
         <p:spPr>
           <a:xfrm>
-            <a:off x="9136227" y="1051560"/>
-            <a:ext cx="2560320" cy="45720"/>
+            <a:off x="9075191" y="1051560"/>
+            <a:ext cx="2567863" cy="45720"/>
           </a:xfrm>
           <a:prstGeom prst="rect">
             <a:avLst/>
@@ -35749,8 +35749,8 @@
         </p:nvSpPr>
         <p:spPr>
           <a:xfrm>
-            <a:off x="9136227" y="1280160"/>
-            <a:ext cx="2560320" cy="640080"/>
+            <a:off x="9075191" y="1280160"/>
+            <a:ext cx="2567863" cy="640080"/>
           </a:xfrm>
           <a:prstGeom prst="rect">
             <a:avLst/>
@@ -35789,8 +35789,8 @@
         </p:nvSpPr>
         <p:spPr>
           <a:xfrm>
-            <a:off x="9227667" y="1965960"/>
-            <a:ext cx="2377440" cy="640080"/>
+            <a:off x="9166631" y="1965960"/>
+            <a:ext cx="2384983" cy="640080"/>
           </a:xfrm>
           <a:prstGeom prst="rect">
             <a:avLst/>

</xml_diff>

<commit_message>
fix: card_grid item height 0.35" for wrapped text — no more text overflow
</commit_message>
<xml_diff>
--- a/Perwal_Bekasi_51_2024_Pajak_Reklame.pptx
+++ b/Perwal_Bekasi_51_2024_Pajak_Reklame.pptx
@@ -11972,7 +11972,7 @@
         <p:spPr>
           <a:xfrm>
             <a:off x="548640" y="1051560"/>
-            <a:ext cx="2567863" cy="5257800"/>
+            <a:ext cx="2567863" cy="5349240"/>
           </a:xfrm>
           <a:prstGeom prst="roundRect">
             <a:avLst>
@@ -12019,7 +12019,7 @@
         <p:spPr>
           <a:xfrm>
             <a:off x="548640" y="1051560"/>
-            <a:ext cx="45720" cy="5257800"/>
+            <a:ext cx="45720" cy="5349240"/>
           </a:xfrm>
           <a:prstGeom prst="rect">
             <a:avLst/>
@@ -12184,8 +12184,8 @@
         </p:nvSpPr>
         <p:spPr>
           <a:xfrm>
-            <a:off x="685800" y="2011680"/>
-            <a:ext cx="2293543" cy="201168"/>
+            <a:off x="685800" y="2039112"/>
+            <a:ext cx="2293543" cy="320040"/>
           </a:xfrm>
           <a:prstGeom prst="rect">
             <a:avLst/>
@@ -12224,8 +12224,8 @@
         </p:nvSpPr>
         <p:spPr>
           <a:xfrm>
-            <a:off x="685800" y="2212848"/>
-            <a:ext cx="2293543" cy="201168"/>
+            <a:off x="685800" y="2377440"/>
+            <a:ext cx="2293543" cy="320040"/>
           </a:xfrm>
           <a:prstGeom prst="rect">
             <a:avLst/>
@@ -12265,7 +12265,7 @@
         <p:spPr>
           <a:xfrm>
             <a:off x="3390823" y="1051560"/>
-            <a:ext cx="2567863" cy="5257800"/>
+            <a:ext cx="2567863" cy="5349240"/>
           </a:xfrm>
           <a:prstGeom prst="roundRect">
             <a:avLst>
@@ -12312,7 +12312,7 @@
         <p:spPr>
           <a:xfrm>
             <a:off x="3390823" y="1051560"/>
-            <a:ext cx="45720" cy="5257800"/>
+            <a:ext cx="45720" cy="5349240"/>
           </a:xfrm>
           <a:prstGeom prst="rect">
             <a:avLst/>
@@ -12477,8 +12477,8 @@
         </p:nvSpPr>
         <p:spPr>
           <a:xfrm>
-            <a:off x="3527983" y="2011680"/>
-            <a:ext cx="2293543" cy="201168"/>
+            <a:off x="3527983" y="2039112"/>
+            <a:ext cx="2293543" cy="320040"/>
           </a:xfrm>
           <a:prstGeom prst="rect">
             <a:avLst/>
@@ -12518,7 +12518,7 @@
         <p:spPr>
           <a:xfrm>
             <a:off x="6233007" y="1051560"/>
-            <a:ext cx="2567863" cy="5257800"/>
+            <a:ext cx="2567863" cy="5349240"/>
           </a:xfrm>
           <a:prstGeom prst="roundRect">
             <a:avLst>
@@ -12565,7 +12565,7 @@
         <p:spPr>
           <a:xfrm>
             <a:off x="6233007" y="1051560"/>
-            <a:ext cx="45720" cy="5257800"/>
+            <a:ext cx="45720" cy="5349240"/>
           </a:xfrm>
           <a:prstGeom prst="rect">
             <a:avLst/>
@@ -12730,8 +12730,8 @@
         </p:nvSpPr>
         <p:spPr>
           <a:xfrm>
-            <a:off x="6370167" y="2011680"/>
-            <a:ext cx="2293543" cy="201168"/>
+            <a:off x="6370167" y="2039112"/>
+            <a:ext cx="2293543" cy="320040"/>
           </a:xfrm>
           <a:prstGeom prst="rect">
             <a:avLst/>
@@ -12770,8 +12770,8 @@
         </p:nvSpPr>
         <p:spPr>
           <a:xfrm>
-            <a:off x="6370167" y="2212848"/>
-            <a:ext cx="2293543" cy="201168"/>
+            <a:off x="6370167" y="2377440"/>
+            <a:ext cx="2293543" cy="320040"/>
           </a:xfrm>
           <a:prstGeom prst="rect">
             <a:avLst/>
@@ -12811,7 +12811,7 @@
         <p:spPr>
           <a:xfrm>
             <a:off x="9075191" y="1051560"/>
-            <a:ext cx="2567863" cy="5257800"/>
+            <a:ext cx="2567863" cy="5349240"/>
           </a:xfrm>
           <a:prstGeom prst="roundRect">
             <a:avLst>
@@ -12858,7 +12858,7 @@
         <p:spPr>
           <a:xfrm>
             <a:off x="9075191" y="1051560"/>
-            <a:ext cx="45720" cy="5257800"/>
+            <a:ext cx="45720" cy="5349240"/>
           </a:xfrm>
           <a:prstGeom prst="rect">
             <a:avLst/>
@@ -13023,8 +13023,8 @@
         </p:nvSpPr>
         <p:spPr>
           <a:xfrm>
-            <a:off x="9212351" y="2011680"/>
-            <a:ext cx="2293543" cy="201168"/>
+            <a:off x="9212351" y="2039112"/>
+            <a:ext cx="2293543" cy="320040"/>
           </a:xfrm>
           <a:prstGeom prst="rect">
             <a:avLst/>
@@ -13063,8 +13063,8 @@
         </p:nvSpPr>
         <p:spPr>
           <a:xfrm>
-            <a:off x="9212351" y="2212848"/>
-            <a:ext cx="2293543" cy="201168"/>
+            <a:off x="9212351" y="2377440"/>
+            <a:ext cx="2293543" cy="320040"/>
           </a:xfrm>
           <a:prstGeom prst="rect">
             <a:avLst/>
@@ -15360,7 +15360,7 @@
         <p:spPr>
           <a:xfrm>
             <a:off x="548640" y="1051560"/>
-            <a:ext cx="2567863" cy="5257800"/>
+            <a:ext cx="2567863" cy="5349240"/>
           </a:xfrm>
           <a:prstGeom prst="roundRect">
             <a:avLst>
@@ -15407,7 +15407,7 @@
         <p:spPr>
           <a:xfrm>
             <a:off x="548640" y="1051560"/>
-            <a:ext cx="45720" cy="5257800"/>
+            <a:ext cx="45720" cy="5349240"/>
           </a:xfrm>
           <a:prstGeom prst="rect">
             <a:avLst/>
@@ -15572,8 +15572,8 @@
         </p:nvSpPr>
         <p:spPr>
           <a:xfrm>
-            <a:off x="685800" y="2011680"/>
-            <a:ext cx="2293543" cy="201168"/>
+            <a:off x="685800" y="2039112"/>
+            <a:ext cx="2293543" cy="320040"/>
           </a:xfrm>
           <a:prstGeom prst="rect">
             <a:avLst/>
@@ -15612,8 +15612,8 @@
         </p:nvSpPr>
         <p:spPr>
           <a:xfrm>
-            <a:off x="685800" y="2212848"/>
-            <a:ext cx="2293543" cy="201168"/>
+            <a:off x="685800" y="2377440"/>
+            <a:ext cx="2293543" cy="320040"/>
           </a:xfrm>
           <a:prstGeom prst="rect">
             <a:avLst/>
@@ -15653,7 +15653,7 @@
         <p:spPr>
           <a:xfrm>
             <a:off x="3390823" y="1051560"/>
-            <a:ext cx="2567863" cy="5257800"/>
+            <a:ext cx="2567863" cy="5349240"/>
           </a:xfrm>
           <a:prstGeom prst="roundRect">
             <a:avLst>
@@ -15700,7 +15700,7 @@
         <p:spPr>
           <a:xfrm>
             <a:off x="3390823" y="1051560"/>
-            <a:ext cx="45720" cy="5257800"/>
+            <a:ext cx="45720" cy="5349240"/>
           </a:xfrm>
           <a:prstGeom prst="rect">
             <a:avLst/>
@@ -15865,8 +15865,8 @@
         </p:nvSpPr>
         <p:spPr>
           <a:xfrm>
-            <a:off x="3527983" y="2011680"/>
-            <a:ext cx="2293543" cy="201168"/>
+            <a:off x="3527983" y="2039112"/>
+            <a:ext cx="2293543" cy="320040"/>
           </a:xfrm>
           <a:prstGeom prst="rect">
             <a:avLst/>
@@ -15905,8 +15905,8 @@
         </p:nvSpPr>
         <p:spPr>
           <a:xfrm>
-            <a:off x="3527983" y="2212848"/>
-            <a:ext cx="2293543" cy="201168"/>
+            <a:off x="3527983" y="2377440"/>
+            <a:ext cx="2293543" cy="320040"/>
           </a:xfrm>
           <a:prstGeom prst="rect">
             <a:avLst/>
@@ -15946,7 +15946,7 @@
         <p:spPr>
           <a:xfrm>
             <a:off x="6233007" y="1051560"/>
-            <a:ext cx="2567863" cy="5257800"/>
+            <a:ext cx="2567863" cy="5349240"/>
           </a:xfrm>
           <a:prstGeom prst="roundRect">
             <a:avLst>
@@ -15993,7 +15993,7 @@
         <p:spPr>
           <a:xfrm>
             <a:off x="6233007" y="1051560"/>
-            <a:ext cx="45720" cy="5257800"/>
+            <a:ext cx="45720" cy="5349240"/>
           </a:xfrm>
           <a:prstGeom prst="rect">
             <a:avLst/>
@@ -16158,8 +16158,8 @@
         </p:nvSpPr>
         <p:spPr>
           <a:xfrm>
-            <a:off x="6370167" y="2011680"/>
-            <a:ext cx="2293543" cy="201168"/>
+            <a:off x="6370167" y="2039112"/>
+            <a:ext cx="2293543" cy="320040"/>
           </a:xfrm>
           <a:prstGeom prst="rect">
             <a:avLst/>
@@ -16199,7 +16199,7 @@
         <p:spPr>
           <a:xfrm>
             <a:off x="9075191" y="1051560"/>
-            <a:ext cx="2567863" cy="5257800"/>
+            <a:ext cx="2567863" cy="5349240"/>
           </a:xfrm>
           <a:prstGeom prst="roundRect">
             <a:avLst>
@@ -16246,7 +16246,7 @@
         <p:spPr>
           <a:xfrm>
             <a:off x="9075191" y="1051560"/>
-            <a:ext cx="45720" cy="5257800"/>
+            <a:ext cx="45720" cy="5349240"/>
           </a:xfrm>
           <a:prstGeom prst="rect">
             <a:avLst/>
@@ -16411,8 +16411,8 @@
         </p:nvSpPr>
         <p:spPr>
           <a:xfrm>
-            <a:off x="9212351" y="2011680"/>
-            <a:ext cx="2293543" cy="201168"/>
+            <a:off x="9212351" y="2039112"/>
+            <a:ext cx="2293543" cy="320040"/>
           </a:xfrm>
           <a:prstGeom prst="rect">
             <a:avLst/>
@@ -22155,7 +22155,7 @@
         <p:spPr>
           <a:xfrm>
             <a:off x="548640" y="1051560"/>
-            <a:ext cx="3515258" cy="5257800"/>
+            <a:ext cx="3515258" cy="5349240"/>
           </a:xfrm>
           <a:prstGeom prst="roundRect">
             <a:avLst>
@@ -22202,7 +22202,7 @@
         <p:spPr>
           <a:xfrm>
             <a:off x="548640" y="1051560"/>
-            <a:ext cx="45720" cy="5257800"/>
+            <a:ext cx="45720" cy="5349240"/>
           </a:xfrm>
           <a:prstGeom prst="rect">
             <a:avLst/>
@@ -22367,8 +22367,8 @@
         </p:nvSpPr>
         <p:spPr>
           <a:xfrm>
-            <a:off x="685800" y="2011680"/>
-            <a:ext cx="3240938" cy="201168"/>
+            <a:off x="685800" y="2039112"/>
+            <a:ext cx="3240938" cy="320040"/>
           </a:xfrm>
           <a:prstGeom prst="rect">
             <a:avLst/>
@@ -22407,8 +22407,8 @@
         </p:nvSpPr>
         <p:spPr>
           <a:xfrm>
-            <a:off x="685800" y="2212848"/>
-            <a:ext cx="3240938" cy="201168"/>
+            <a:off x="685800" y="2377440"/>
+            <a:ext cx="3240938" cy="320040"/>
           </a:xfrm>
           <a:prstGeom prst="rect">
             <a:avLst/>
@@ -22447,8 +22447,8 @@
         </p:nvSpPr>
         <p:spPr>
           <a:xfrm>
-            <a:off x="685800" y="2414016"/>
-            <a:ext cx="3240938" cy="201168"/>
+            <a:off x="685800" y="2715768"/>
+            <a:ext cx="3240938" cy="320040"/>
           </a:xfrm>
           <a:prstGeom prst="rect">
             <a:avLst/>
@@ -22487,8 +22487,8 @@
         </p:nvSpPr>
         <p:spPr>
           <a:xfrm>
-            <a:off x="685800" y="2615184"/>
-            <a:ext cx="3240938" cy="201168"/>
+            <a:off x="685800" y="3054096"/>
+            <a:ext cx="3240938" cy="320040"/>
           </a:xfrm>
           <a:prstGeom prst="rect">
             <a:avLst/>
@@ -22527,8 +22527,8 @@
         </p:nvSpPr>
         <p:spPr>
           <a:xfrm>
-            <a:off x="685800" y="2816352"/>
-            <a:ext cx="3240938" cy="201168"/>
+            <a:off x="685800" y="3392424"/>
+            <a:ext cx="3240938" cy="320040"/>
           </a:xfrm>
           <a:prstGeom prst="rect">
             <a:avLst/>
@@ -22568,7 +22568,7 @@
         <p:spPr>
           <a:xfrm>
             <a:off x="4338218" y="1051560"/>
-            <a:ext cx="3515258" cy="5257800"/>
+            <a:ext cx="3515258" cy="5349240"/>
           </a:xfrm>
           <a:prstGeom prst="roundRect">
             <a:avLst>
@@ -22615,7 +22615,7 @@
         <p:spPr>
           <a:xfrm>
             <a:off x="4338218" y="1051560"/>
-            <a:ext cx="45720" cy="5257800"/>
+            <a:ext cx="45720" cy="5349240"/>
           </a:xfrm>
           <a:prstGeom prst="rect">
             <a:avLst/>
@@ -22780,8 +22780,8 @@
         </p:nvSpPr>
         <p:spPr>
           <a:xfrm>
-            <a:off x="4475378" y="2011680"/>
-            <a:ext cx="3240938" cy="201168"/>
+            <a:off x="4475378" y="2039112"/>
+            <a:ext cx="3240938" cy="320040"/>
           </a:xfrm>
           <a:prstGeom prst="rect">
             <a:avLst/>
@@ -22820,8 +22820,8 @@
         </p:nvSpPr>
         <p:spPr>
           <a:xfrm>
-            <a:off x="4475378" y="2212848"/>
-            <a:ext cx="3240938" cy="201168"/>
+            <a:off x="4475378" y="2377440"/>
+            <a:ext cx="3240938" cy="320040"/>
           </a:xfrm>
           <a:prstGeom prst="rect">
             <a:avLst/>
@@ -22860,8 +22860,8 @@
         </p:nvSpPr>
         <p:spPr>
           <a:xfrm>
-            <a:off x="4475378" y="2414016"/>
-            <a:ext cx="3240938" cy="201168"/>
+            <a:off x="4475378" y="2715768"/>
+            <a:ext cx="3240938" cy="320040"/>
           </a:xfrm>
           <a:prstGeom prst="rect">
             <a:avLst/>
@@ -22901,7 +22901,7 @@
         <p:spPr>
           <a:xfrm>
             <a:off x="8127796" y="1051560"/>
-            <a:ext cx="3515258" cy="5257800"/>
+            <a:ext cx="3515258" cy="5349240"/>
           </a:xfrm>
           <a:prstGeom prst="roundRect">
             <a:avLst>
@@ -22948,7 +22948,7 @@
         <p:spPr>
           <a:xfrm>
             <a:off x="8127796" y="1051560"/>
-            <a:ext cx="45720" cy="5257800"/>
+            <a:ext cx="45720" cy="5349240"/>
           </a:xfrm>
           <a:prstGeom prst="rect">
             <a:avLst/>
@@ -23113,8 +23113,8 @@
         </p:nvSpPr>
         <p:spPr>
           <a:xfrm>
-            <a:off x="8264956" y="2011680"/>
-            <a:ext cx="3240938" cy="201168"/>
+            <a:off x="8264956" y="2039112"/>
+            <a:ext cx="3240938" cy="320040"/>
           </a:xfrm>
           <a:prstGeom prst="rect">
             <a:avLst/>
@@ -23153,8 +23153,8 @@
         </p:nvSpPr>
         <p:spPr>
           <a:xfrm>
-            <a:off x="8264956" y="2212848"/>
-            <a:ext cx="3240938" cy="201168"/>
+            <a:off x="8264956" y="2377440"/>
+            <a:ext cx="3240938" cy="320040"/>
           </a:xfrm>
           <a:prstGeom prst="rect">
             <a:avLst/>
@@ -23193,8 +23193,8 @@
         </p:nvSpPr>
         <p:spPr>
           <a:xfrm>
-            <a:off x="8264956" y="2414016"/>
-            <a:ext cx="3240938" cy="201168"/>
+            <a:off x="8264956" y="2715768"/>
+            <a:ext cx="3240938" cy="320040"/>
           </a:xfrm>
           <a:prstGeom prst="rect">
             <a:avLst/>
@@ -23233,8 +23233,8 @@
         </p:nvSpPr>
         <p:spPr>
           <a:xfrm>
-            <a:off x="8264956" y="2615184"/>
-            <a:ext cx="3240938" cy="201168"/>
+            <a:off x="8264956" y="3054096"/>
+            <a:ext cx="3240938" cy="320040"/>
           </a:xfrm>
           <a:prstGeom prst="rect">
             <a:avLst/>
@@ -26117,7 +26117,7 @@
         <p:spPr>
           <a:xfrm>
             <a:off x="548640" y="1051560"/>
-            <a:ext cx="3515258" cy="5257800"/>
+            <a:ext cx="3515258" cy="5349240"/>
           </a:xfrm>
           <a:prstGeom prst="roundRect">
             <a:avLst>
@@ -26164,7 +26164,7 @@
         <p:spPr>
           <a:xfrm>
             <a:off x="548640" y="1051560"/>
-            <a:ext cx="45720" cy="5257800"/>
+            <a:ext cx="45720" cy="5349240"/>
           </a:xfrm>
           <a:prstGeom prst="rect">
             <a:avLst/>
@@ -26329,8 +26329,8 @@
         </p:nvSpPr>
         <p:spPr>
           <a:xfrm>
-            <a:off x="685800" y="2011680"/>
-            <a:ext cx="3240938" cy="201168"/>
+            <a:off x="685800" y="2039112"/>
+            <a:ext cx="3240938" cy="320040"/>
           </a:xfrm>
           <a:prstGeom prst="rect">
             <a:avLst/>
@@ -26369,8 +26369,8 @@
         </p:nvSpPr>
         <p:spPr>
           <a:xfrm>
-            <a:off x="685800" y="2212848"/>
-            <a:ext cx="3240938" cy="201168"/>
+            <a:off x="685800" y="2377440"/>
+            <a:ext cx="3240938" cy="320040"/>
           </a:xfrm>
           <a:prstGeom prst="rect">
             <a:avLst/>
@@ -26409,8 +26409,8 @@
         </p:nvSpPr>
         <p:spPr>
           <a:xfrm>
-            <a:off x="685800" y="2414016"/>
-            <a:ext cx="3240938" cy="201168"/>
+            <a:off x="685800" y="2715768"/>
+            <a:ext cx="3240938" cy="320040"/>
           </a:xfrm>
           <a:prstGeom prst="rect">
             <a:avLst/>
@@ -26449,8 +26449,8 @@
         </p:nvSpPr>
         <p:spPr>
           <a:xfrm>
-            <a:off x="685800" y="2615184"/>
-            <a:ext cx="3240938" cy="201168"/>
+            <a:off x="685800" y="3054096"/>
+            <a:ext cx="3240938" cy="320040"/>
           </a:xfrm>
           <a:prstGeom prst="rect">
             <a:avLst/>
@@ -26489,8 +26489,8 @@
         </p:nvSpPr>
         <p:spPr>
           <a:xfrm>
-            <a:off x="685800" y="2816352"/>
-            <a:ext cx="3240938" cy="201168"/>
+            <a:off x="685800" y="3392424"/>
+            <a:ext cx="3240938" cy="320040"/>
           </a:xfrm>
           <a:prstGeom prst="rect">
             <a:avLst/>
@@ -26530,7 +26530,7 @@
         <p:spPr>
           <a:xfrm>
             <a:off x="4338218" y="1051560"/>
-            <a:ext cx="3515258" cy="5257800"/>
+            <a:ext cx="3515258" cy="5349240"/>
           </a:xfrm>
           <a:prstGeom prst="roundRect">
             <a:avLst>
@@ -26577,7 +26577,7 @@
         <p:spPr>
           <a:xfrm>
             <a:off x="4338218" y="1051560"/>
-            <a:ext cx="45720" cy="5257800"/>
+            <a:ext cx="45720" cy="5349240"/>
           </a:xfrm>
           <a:prstGeom prst="rect">
             <a:avLst/>
@@ -26742,8 +26742,8 @@
         </p:nvSpPr>
         <p:spPr>
           <a:xfrm>
-            <a:off x="4475378" y="2011680"/>
-            <a:ext cx="3240938" cy="201168"/>
+            <a:off x="4475378" y="2039112"/>
+            <a:ext cx="3240938" cy="320040"/>
           </a:xfrm>
           <a:prstGeom prst="rect">
             <a:avLst/>
@@ -26782,8 +26782,8 @@
         </p:nvSpPr>
         <p:spPr>
           <a:xfrm>
-            <a:off x="4475378" y="2212848"/>
-            <a:ext cx="3240938" cy="201168"/>
+            <a:off x="4475378" y="2377440"/>
+            <a:ext cx="3240938" cy="320040"/>
           </a:xfrm>
           <a:prstGeom prst="rect">
             <a:avLst/>
@@ -26822,8 +26822,8 @@
         </p:nvSpPr>
         <p:spPr>
           <a:xfrm>
-            <a:off x="4475378" y="2414016"/>
-            <a:ext cx="3240938" cy="201168"/>
+            <a:off x="4475378" y="2715768"/>
+            <a:ext cx="3240938" cy="320040"/>
           </a:xfrm>
           <a:prstGeom prst="rect">
             <a:avLst/>
@@ -26862,8 +26862,8 @@
         </p:nvSpPr>
         <p:spPr>
           <a:xfrm>
-            <a:off x="4475378" y="2615184"/>
-            <a:ext cx="3240938" cy="201168"/>
+            <a:off x="4475378" y="3054096"/>
+            <a:ext cx="3240938" cy="320040"/>
           </a:xfrm>
           <a:prstGeom prst="rect">
             <a:avLst/>
@@ -26903,7 +26903,7 @@
         <p:spPr>
           <a:xfrm>
             <a:off x="8127796" y="1051560"/>
-            <a:ext cx="3515258" cy="5257800"/>
+            <a:ext cx="3515258" cy="5349240"/>
           </a:xfrm>
           <a:prstGeom prst="roundRect">
             <a:avLst>
@@ -26950,7 +26950,7 @@
         <p:spPr>
           <a:xfrm>
             <a:off x="8127796" y="1051560"/>
-            <a:ext cx="45720" cy="5257800"/>
+            <a:ext cx="45720" cy="5349240"/>
           </a:xfrm>
           <a:prstGeom prst="rect">
             <a:avLst/>
@@ -27115,8 +27115,8 @@
         </p:nvSpPr>
         <p:spPr>
           <a:xfrm>
-            <a:off x="8264956" y="2011680"/>
-            <a:ext cx="3240938" cy="201168"/>
+            <a:off x="8264956" y="2039112"/>
+            <a:ext cx="3240938" cy="320040"/>
           </a:xfrm>
           <a:prstGeom prst="rect">
             <a:avLst/>
@@ -27155,8 +27155,8 @@
         </p:nvSpPr>
         <p:spPr>
           <a:xfrm>
-            <a:off x="8264956" y="2212848"/>
-            <a:ext cx="3240938" cy="201168"/>
+            <a:off x="8264956" y="2377440"/>
+            <a:ext cx="3240938" cy="320040"/>
           </a:xfrm>
           <a:prstGeom prst="rect">
             <a:avLst/>
@@ -27195,8 +27195,8 @@
         </p:nvSpPr>
         <p:spPr>
           <a:xfrm>
-            <a:off x="8264956" y="2414016"/>
-            <a:ext cx="3240938" cy="201168"/>
+            <a:off x="8264956" y="2715768"/>
+            <a:ext cx="3240938" cy="320040"/>
           </a:xfrm>
           <a:prstGeom prst="rect">
             <a:avLst/>
@@ -27235,8 +27235,8 @@
         </p:nvSpPr>
         <p:spPr>
           <a:xfrm>
-            <a:off x="8264956" y="2615184"/>
-            <a:ext cx="3240938" cy="201168"/>
+            <a:off x="8264956" y="3054096"/>
+            <a:ext cx="3240938" cy="320040"/>
           </a:xfrm>
           <a:prstGeom prst="rect">
             <a:avLst/>
@@ -27275,8 +27275,8 @@
         </p:nvSpPr>
         <p:spPr>
           <a:xfrm>
-            <a:off x="8264956" y="2816352"/>
-            <a:ext cx="3240938" cy="201168"/>
+            <a:off x="8264956" y="3392424"/>
+            <a:ext cx="3240938" cy="320040"/>
           </a:xfrm>
           <a:prstGeom prst="rect">
             <a:avLst/>
@@ -29585,7 +29585,7 @@
         <p:spPr>
           <a:xfrm>
             <a:off x="548640" y="1051560"/>
-            <a:ext cx="2567863" cy="2514600"/>
+            <a:ext cx="2567863" cy="2537460"/>
           </a:xfrm>
           <a:prstGeom prst="roundRect">
             <a:avLst>
@@ -29632,7 +29632,7 @@
         <p:spPr>
           <a:xfrm>
             <a:off x="548640" y="1051560"/>
-            <a:ext cx="45720" cy="2514600"/>
+            <a:ext cx="45720" cy="2537460"/>
           </a:xfrm>
           <a:prstGeom prst="rect">
             <a:avLst/>
@@ -29797,8 +29797,8 @@
         </p:nvSpPr>
         <p:spPr>
           <a:xfrm>
-            <a:off x="685800" y="2011680"/>
-            <a:ext cx="2293543" cy="201168"/>
+            <a:off x="685800" y="2039112"/>
+            <a:ext cx="2293543" cy="320040"/>
           </a:xfrm>
           <a:prstGeom prst="rect">
             <a:avLst/>
@@ -29838,7 +29838,7 @@
         <p:spPr>
           <a:xfrm>
             <a:off x="3390823" y="1051560"/>
-            <a:ext cx="2567863" cy="2514600"/>
+            <a:ext cx="2567863" cy="2537460"/>
           </a:xfrm>
           <a:prstGeom prst="roundRect">
             <a:avLst>
@@ -29885,7 +29885,7 @@
         <p:spPr>
           <a:xfrm>
             <a:off x="3390823" y="1051560"/>
-            <a:ext cx="45720" cy="2514600"/>
+            <a:ext cx="45720" cy="2537460"/>
           </a:xfrm>
           <a:prstGeom prst="rect">
             <a:avLst/>
@@ -30050,8 +30050,8 @@
         </p:nvSpPr>
         <p:spPr>
           <a:xfrm>
-            <a:off x="3527983" y="2011680"/>
-            <a:ext cx="2293543" cy="201168"/>
+            <a:off x="3527983" y="2039112"/>
+            <a:ext cx="2293543" cy="320040"/>
           </a:xfrm>
           <a:prstGeom prst="rect">
             <a:avLst/>
@@ -30091,7 +30091,7 @@
         <p:spPr>
           <a:xfrm>
             <a:off x="6233007" y="1051560"/>
-            <a:ext cx="2567863" cy="2514600"/>
+            <a:ext cx="2567863" cy="2537460"/>
           </a:xfrm>
           <a:prstGeom prst="roundRect">
             <a:avLst>
@@ -30138,7 +30138,7 @@
         <p:spPr>
           <a:xfrm>
             <a:off x="6233007" y="1051560"/>
-            <a:ext cx="45720" cy="2514600"/>
+            <a:ext cx="45720" cy="2537460"/>
           </a:xfrm>
           <a:prstGeom prst="rect">
             <a:avLst/>
@@ -30303,8 +30303,8 @@
         </p:nvSpPr>
         <p:spPr>
           <a:xfrm>
-            <a:off x="6370167" y="2011680"/>
-            <a:ext cx="2293543" cy="201168"/>
+            <a:off x="6370167" y="2039112"/>
+            <a:ext cx="2293543" cy="320040"/>
           </a:xfrm>
           <a:prstGeom prst="rect">
             <a:avLst/>
@@ -30344,7 +30344,7 @@
         <p:spPr>
           <a:xfrm>
             <a:off x="9075191" y="1051560"/>
-            <a:ext cx="2567863" cy="2514600"/>
+            <a:ext cx="2567863" cy="2537460"/>
           </a:xfrm>
           <a:prstGeom prst="roundRect">
             <a:avLst>
@@ -30391,7 +30391,7 @@
         <p:spPr>
           <a:xfrm>
             <a:off x="9075191" y="1051560"/>
-            <a:ext cx="45720" cy="2514600"/>
+            <a:ext cx="45720" cy="2537460"/>
           </a:xfrm>
           <a:prstGeom prst="rect">
             <a:avLst/>
@@ -30556,8 +30556,8 @@
         </p:nvSpPr>
         <p:spPr>
           <a:xfrm>
-            <a:off x="9212351" y="2011680"/>
-            <a:ext cx="2293543" cy="201168"/>
+            <a:off x="9212351" y="2039112"/>
+            <a:ext cx="2293543" cy="320040"/>
           </a:xfrm>
           <a:prstGeom prst="rect">
             <a:avLst/>
@@ -30596,8 +30596,8 @@
         </p:nvSpPr>
         <p:spPr>
           <a:xfrm>
-            <a:off x="548640" y="3794760"/>
-            <a:ext cx="2567863" cy="2514600"/>
+            <a:off x="548640" y="3863340"/>
+            <a:ext cx="2567863" cy="2537460"/>
           </a:xfrm>
           <a:prstGeom prst="roundRect">
             <a:avLst>
@@ -30643,8 +30643,8 @@
         </p:nvSpPr>
         <p:spPr>
           <a:xfrm>
-            <a:off x="548640" y="3794760"/>
-            <a:ext cx="45720" cy="2514600"/>
+            <a:off x="548640" y="3863340"/>
+            <a:ext cx="45720" cy="2537460"/>
           </a:xfrm>
           <a:prstGeom prst="rect">
             <a:avLst/>
@@ -30686,7 +30686,7 @@
         </p:nvSpPr>
         <p:spPr>
           <a:xfrm>
-            <a:off x="685800" y="3931920"/>
+            <a:off x="685800" y="4000500"/>
             <a:ext cx="384048" cy="384048"/>
           </a:xfrm>
           <a:prstGeom prst="ellipse">
@@ -30729,7 +30729,7 @@
         </p:nvSpPr>
         <p:spPr>
           <a:xfrm>
-            <a:off x="685800" y="3931920"/>
+            <a:off x="685800" y="4000500"/>
             <a:ext cx="384048" cy="384048"/>
           </a:xfrm>
           <a:prstGeom prst="rect">
@@ -30769,7 +30769,7 @@
         </p:nvSpPr>
         <p:spPr>
           <a:xfrm>
-            <a:off x="685800" y="4434840"/>
+            <a:off x="685800" y="4503420"/>
             <a:ext cx="2293543" cy="274320"/>
           </a:xfrm>
           <a:prstGeom prst="rect">
@@ -30809,8 +30809,8 @@
         </p:nvSpPr>
         <p:spPr>
           <a:xfrm>
-            <a:off x="685800" y="4754880"/>
-            <a:ext cx="2293543" cy="201168"/>
+            <a:off x="685800" y="4850892"/>
+            <a:ext cx="2293543" cy="320040"/>
           </a:xfrm>
           <a:prstGeom prst="rect">
             <a:avLst/>
@@ -30849,8 +30849,8 @@
         </p:nvSpPr>
         <p:spPr>
           <a:xfrm>
-            <a:off x="3390823" y="3794760"/>
-            <a:ext cx="2567863" cy="2514600"/>
+            <a:off x="3390823" y="3863340"/>
+            <a:ext cx="2567863" cy="2537460"/>
           </a:xfrm>
           <a:prstGeom prst="roundRect">
             <a:avLst>
@@ -30896,8 +30896,8 @@
         </p:nvSpPr>
         <p:spPr>
           <a:xfrm>
-            <a:off x="3390823" y="3794760"/>
-            <a:ext cx="45720" cy="2514600"/>
+            <a:off x="3390823" y="3863340"/>
+            <a:ext cx="45720" cy="2537460"/>
           </a:xfrm>
           <a:prstGeom prst="rect">
             <a:avLst/>
@@ -30939,7 +30939,7 @@
         </p:nvSpPr>
         <p:spPr>
           <a:xfrm>
-            <a:off x="3527983" y="3931920"/>
+            <a:off x="3527983" y="4000500"/>
             <a:ext cx="384048" cy="384048"/>
           </a:xfrm>
           <a:prstGeom prst="ellipse">
@@ -30982,7 +30982,7 @@
         </p:nvSpPr>
         <p:spPr>
           <a:xfrm>
-            <a:off x="3527983" y="3931920"/>
+            <a:off x="3527983" y="4000500"/>
             <a:ext cx="384048" cy="384048"/>
           </a:xfrm>
           <a:prstGeom prst="rect">
@@ -31022,7 +31022,7 @@
         </p:nvSpPr>
         <p:spPr>
           <a:xfrm>
-            <a:off x="3527983" y="4434840"/>
+            <a:off x="3527983" y="4503420"/>
             <a:ext cx="2293543" cy="274320"/>
           </a:xfrm>
           <a:prstGeom prst="rect">
@@ -31062,8 +31062,8 @@
         </p:nvSpPr>
         <p:spPr>
           <a:xfrm>
-            <a:off x="3527983" y="4754880"/>
-            <a:ext cx="2293543" cy="201168"/>
+            <a:off x="3527983" y="4850892"/>
+            <a:ext cx="2293543" cy="320040"/>
           </a:xfrm>
           <a:prstGeom prst="rect">
             <a:avLst/>
@@ -31102,8 +31102,8 @@
         </p:nvSpPr>
         <p:spPr>
           <a:xfrm>
-            <a:off x="6233007" y="3794760"/>
-            <a:ext cx="2567863" cy="2514600"/>
+            <a:off x="6233007" y="3863340"/>
+            <a:ext cx="2567863" cy="2537460"/>
           </a:xfrm>
           <a:prstGeom prst="roundRect">
             <a:avLst>
@@ -31149,8 +31149,8 @@
         </p:nvSpPr>
         <p:spPr>
           <a:xfrm>
-            <a:off x="6233007" y="3794760"/>
-            <a:ext cx="45720" cy="2514600"/>
+            <a:off x="6233007" y="3863340"/>
+            <a:ext cx="45720" cy="2537460"/>
           </a:xfrm>
           <a:prstGeom prst="rect">
             <a:avLst/>
@@ -31192,7 +31192,7 @@
         </p:nvSpPr>
         <p:spPr>
           <a:xfrm>
-            <a:off x="6370167" y="3931920"/>
+            <a:off x="6370167" y="4000500"/>
             <a:ext cx="384048" cy="384048"/>
           </a:xfrm>
           <a:prstGeom prst="ellipse">
@@ -31235,7 +31235,7 @@
         </p:nvSpPr>
         <p:spPr>
           <a:xfrm>
-            <a:off x="6370167" y="3931920"/>
+            <a:off x="6370167" y="4000500"/>
             <a:ext cx="384048" cy="384048"/>
           </a:xfrm>
           <a:prstGeom prst="rect">
@@ -31275,7 +31275,7 @@
         </p:nvSpPr>
         <p:spPr>
           <a:xfrm>
-            <a:off x="6370167" y="4434840"/>
+            <a:off x="6370167" y="4503420"/>
             <a:ext cx="2293543" cy="274320"/>
           </a:xfrm>
           <a:prstGeom prst="rect">
@@ -31315,8 +31315,8 @@
         </p:nvSpPr>
         <p:spPr>
           <a:xfrm>
-            <a:off x="6370167" y="4754880"/>
-            <a:ext cx="2293543" cy="201168"/>
+            <a:off x="6370167" y="4850892"/>
+            <a:ext cx="2293543" cy="320040"/>
           </a:xfrm>
           <a:prstGeom prst="rect">
             <a:avLst/>
@@ -32162,7 +32162,7 @@
         <p:spPr>
           <a:xfrm>
             <a:off x="548640" y="1051560"/>
-            <a:ext cx="5410047" cy="5257800"/>
+            <a:ext cx="5410047" cy="5349240"/>
           </a:xfrm>
           <a:prstGeom prst="roundRect">
             <a:avLst>
@@ -32209,7 +32209,7 @@
         <p:spPr>
           <a:xfrm>
             <a:off x="548640" y="1051560"/>
-            <a:ext cx="45720" cy="5257800"/>
+            <a:ext cx="45720" cy="5349240"/>
           </a:xfrm>
           <a:prstGeom prst="rect">
             <a:avLst/>
@@ -32374,8 +32374,8 @@
         </p:nvSpPr>
         <p:spPr>
           <a:xfrm>
-            <a:off x="685800" y="2011680"/>
-            <a:ext cx="5135727" cy="201168"/>
+            <a:off x="685800" y="2039112"/>
+            <a:ext cx="5135727" cy="320040"/>
           </a:xfrm>
           <a:prstGeom prst="rect">
             <a:avLst/>
@@ -32414,8 +32414,8 @@
         </p:nvSpPr>
         <p:spPr>
           <a:xfrm>
-            <a:off x="685800" y="2212848"/>
-            <a:ext cx="5135727" cy="201168"/>
+            <a:off x="685800" y="2377440"/>
+            <a:ext cx="5135727" cy="320040"/>
           </a:xfrm>
           <a:prstGeom prst="rect">
             <a:avLst/>
@@ -32454,8 +32454,8 @@
         </p:nvSpPr>
         <p:spPr>
           <a:xfrm>
-            <a:off x="685800" y="2414016"/>
-            <a:ext cx="5135727" cy="201168"/>
+            <a:off x="685800" y="2715768"/>
+            <a:ext cx="5135727" cy="320040"/>
           </a:xfrm>
           <a:prstGeom prst="rect">
             <a:avLst/>
@@ -32494,8 +32494,8 @@
         </p:nvSpPr>
         <p:spPr>
           <a:xfrm>
-            <a:off x="685800" y="2615184"/>
-            <a:ext cx="5135727" cy="201168"/>
+            <a:off x="685800" y="3054096"/>
+            <a:ext cx="5135727" cy="320040"/>
           </a:xfrm>
           <a:prstGeom prst="rect">
             <a:avLst/>
@@ -32534,8 +32534,8 @@
         </p:nvSpPr>
         <p:spPr>
           <a:xfrm>
-            <a:off x="685800" y="2816352"/>
-            <a:ext cx="5135727" cy="201168"/>
+            <a:off x="685800" y="3392424"/>
+            <a:ext cx="5135727" cy="320040"/>
           </a:xfrm>
           <a:prstGeom prst="rect">
             <a:avLst/>
@@ -32574,8 +32574,8 @@
         </p:nvSpPr>
         <p:spPr>
           <a:xfrm>
-            <a:off x="685800" y="3017520"/>
-            <a:ext cx="5135727" cy="201168"/>
+            <a:off x="685800" y="3730752"/>
+            <a:ext cx="5135727" cy="320040"/>
           </a:xfrm>
           <a:prstGeom prst="rect">
             <a:avLst/>
@@ -32614,8 +32614,8 @@
         </p:nvSpPr>
         <p:spPr>
           <a:xfrm>
-            <a:off x="685800" y="3218688"/>
-            <a:ext cx="5135727" cy="201168"/>
+            <a:off x="685800" y="4069080"/>
+            <a:ext cx="5135727" cy="320040"/>
           </a:xfrm>
           <a:prstGeom prst="rect">
             <a:avLst/>
@@ -32654,8 +32654,8 @@
         </p:nvSpPr>
         <p:spPr>
           <a:xfrm>
-            <a:off x="685800" y="3419856"/>
-            <a:ext cx="5135727" cy="201168"/>
+            <a:off x="685800" y="4407408"/>
+            <a:ext cx="5135727" cy="320040"/>
           </a:xfrm>
           <a:prstGeom prst="rect">
             <a:avLst/>
@@ -32694,8 +32694,8 @@
         </p:nvSpPr>
         <p:spPr>
           <a:xfrm>
-            <a:off x="685800" y="3621024"/>
-            <a:ext cx="5135727" cy="201168"/>
+            <a:off x="685800" y="4745736"/>
+            <a:ext cx="5135727" cy="320040"/>
           </a:xfrm>
           <a:prstGeom prst="rect">
             <a:avLst/>
@@ -32734,8 +32734,8 @@
         </p:nvSpPr>
         <p:spPr>
           <a:xfrm>
-            <a:off x="685800" y="3822192"/>
-            <a:ext cx="5135727" cy="201168"/>
+            <a:off x="685800" y="5084064"/>
+            <a:ext cx="5135727" cy="320040"/>
           </a:xfrm>
           <a:prstGeom prst="rect">
             <a:avLst/>
@@ -32775,7 +32775,7 @@
         <p:spPr>
           <a:xfrm>
             <a:off x="6233007" y="1051560"/>
-            <a:ext cx="5410047" cy="5257800"/>
+            <a:ext cx="5410047" cy="5349240"/>
           </a:xfrm>
           <a:prstGeom prst="roundRect">
             <a:avLst>
@@ -32822,7 +32822,7 @@
         <p:spPr>
           <a:xfrm>
             <a:off x="6233007" y="1051560"/>
-            <a:ext cx="45720" cy="5257800"/>
+            <a:ext cx="45720" cy="5349240"/>
           </a:xfrm>
           <a:prstGeom prst="rect">
             <a:avLst/>
@@ -32987,8 +32987,8 @@
         </p:nvSpPr>
         <p:spPr>
           <a:xfrm>
-            <a:off x="6370167" y="2011680"/>
-            <a:ext cx="5135727" cy="201168"/>
+            <a:off x="6370167" y="2039112"/>
+            <a:ext cx="5135727" cy="320040"/>
           </a:xfrm>
           <a:prstGeom prst="rect">
             <a:avLst/>
@@ -33027,8 +33027,8 @@
         </p:nvSpPr>
         <p:spPr>
           <a:xfrm>
-            <a:off x="6370167" y="2212848"/>
-            <a:ext cx="5135727" cy="201168"/>
+            <a:off x="6370167" y="2377440"/>
+            <a:ext cx="5135727" cy="320040"/>
           </a:xfrm>
           <a:prstGeom prst="rect">
             <a:avLst/>
@@ -33067,8 +33067,8 @@
         </p:nvSpPr>
         <p:spPr>
           <a:xfrm>
-            <a:off x="6370167" y="2414016"/>
-            <a:ext cx="5135727" cy="201168"/>
+            <a:off x="6370167" y="2715768"/>
+            <a:ext cx="5135727" cy="320040"/>
           </a:xfrm>
           <a:prstGeom prst="rect">
             <a:avLst/>
@@ -33107,8 +33107,8 @@
         </p:nvSpPr>
         <p:spPr>
           <a:xfrm>
-            <a:off x="6370167" y="2615184"/>
-            <a:ext cx="5135727" cy="201168"/>
+            <a:off x="6370167" y="3054096"/>
+            <a:ext cx="5135727" cy="320040"/>
           </a:xfrm>
           <a:prstGeom prst="rect">
             <a:avLst/>
@@ -33147,8 +33147,8 @@
         </p:nvSpPr>
         <p:spPr>
           <a:xfrm>
-            <a:off x="6370167" y="2816352"/>
-            <a:ext cx="5135727" cy="201168"/>
+            <a:off x="6370167" y="3392424"/>
+            <a:ext cx="5135727" cy="320040"/>
           </a:xfrm>
           <a:prstGeom prst="rect">
             <a:avLst/>
@@ -33187,8 +33187,8 @@
         </p:nvSpPr>
         <p:spPr>
           <a:xfrm>
-            <a:off x="6370167" y="3017520"/>
-            <a:ext cx="5135727" cy="201168"/>
+            <a:off x="6370167" y="3730752"/>
+            <a:ext cx="5135727" cy="320040"/>
           </a:xfrm>
           <a:prstGeom prst="rect">
             <a:avLst/>
@@ -33227,8 +33227,8 @@
         </p:nvSpPr>
         <p:spPr>
           <a:xfrm>
-            <a:off x="6370167" y="3218688"/>
-            <a:ext cx="5135727" cy="201168"/>
+            <a:off x="6370167" y="4069080"/>
+            <a:ext cx="5135727" cy="320040"/>
           </a:xfrm>
           <a:prstGeom prst="rect">
             <a:avLst/>
@@ -33267,8 +33267,8 @@
         </p:nvSpPr>
         <p:spPr>
           <a:xfrm>
-            <a:off x="6370167" y="3419856"/>
-            <a:ext cx="5135727" cy="201168"/>
+            <a:off x="6370167" y="4407408"/>
+            <a:ext cx="5135727" cy="320040"/>
           </a:xfrm>
           <a:prstGeom prst="rect">
             <a:avLst/>
@@ -33666,7 +33666,7 @@
         <p:spPr>
           <a:xfrm>
             <a:off x="548640" y="1051560"/>
-            <a:ext cx="5410047" cy="5257800"/>
+            <a:ext cx="5410047" cy="5349240"/>
           </a:xfrm>
           <a:prstGeom prst="roundRect">
             <a:avLst>
@@ -33713,7 +33713,7 @@
         <p:spPr>
           <a:xfrm>
             <a:off x="548640" y="1051560"/>
-            <a:ext cx="45720" cy="5257800"/>
+            <a:ext cx="45720" cy="5349240"/>
           </a:xfrm>
           <a:prstGeom prst="rect">
             <a:avLst/>
@@ -33878,8 +33878,8 @@
         </p:nvSpPr>
         <p:spPr>
           <a:xfrm>
-            <a:off x="685800" y="2011680"/>
-            <a:ext cx="5135727" cy="201168"/>
+            <a:off x="685800" y="2039112"/>
+            <a:ext cx="5135727" cy="320040"/>
           </a:xfrm>
           <a:prstGeom prst="rect">
             <a:avLst/>
@@ -33918,8 +33918,8 @@
         </p:nvSpPr>
         <p:spPr>
           <a:xfrm>
-            <a:off x="685800" y="2212848"/>
-            <a:ext cx="5135727" cy="201168"/>
+            <a:off x="685800" y="2377440"/>
+            <a:ext cx="5135727" cy="320040"/>
           </a:xfrm>
           <a:prstGeom prst="rect">
             <a:avLst/>
@@ -33959,7 +33959,7 @@
         <p:spPr>
           <a:xfrm>
             <a:off x="6233007" y="1051560"/>
-            <a:ext cx="5410047" cy="5257800"/>
+            <a:ext cx="5410047" cy="5349240"/>
           </a:xfrm>
           <a:prstGeom prst="roundRect">
             <a:avLst>
@@ -34006,7 +34006,7 @@
         <p:spPr>
           <a:xfrm>
             <a:off x="6233007" y="1051560"/>
-            <a:ext cx="45720" cy="5257800"/>
+            <a:ext cx="45720" cy="5349240"/>
           </a:xfrm>
           <a:prstGeom prst="rect">
             <a:avLst/>
@@ -34171,8 +34171,8 @@
         </p:nvSpPr>
         <p:spPr>
           <a:xfrm>
-            <a:off x="6370167" y="2011680"/>
-            <a:ext cx="5135727" cy="201168"/>
+            <a:off x="6370167" y="2039112"/>
+            <a:ext cx="5135727" cy="320040"/>
           </a:xfrm>
           <a:prstGeom prst="rect">
             <a:avLst/>
@@ -34211,8 +34211,8 @@
         </p:nvSpPr>
         <p:spPr>
           <a:xfrm>
-            <a:off x="6370167" y="2212848"/>
-            <a:ext cx="5135727" cy="201168"/>
+            <a:off x="6370167" y="2377440"/>
+            <a:ext cx="5135727" cy="320040"/>
           </a:xfrm>
           <a:prstGeom prst="rect">
             <a:avLst/>
@@ -34251,8 +34251,8 @@
         </p:nvSpPr>
         <p:spPr>
           <a:xfrm>
-            <a:off x="6370167" y="2414016"/>
-            <a:ext cx="5135727" cy="201168"/>
+            <a:off x="6370167" y="2715768"/>
+            <a:ext cx="5135727" cy="320040"/>
           </a:xfrm>
           <a:prstGeom prst="rect">
             <a:avLst/>
@@ -34291,8 +34291,8 @@
         </p:nvSpPr>
         <p:spPr>
           <a:xfrm>
-            <a:off x="6370167" y="2615184"/>
-            <a:ext cx="5135727" cy="201168"/>
+            <a:off x="6370167" y="3054096"/>
+            <a:ext cx="5135727" cy="320040"/>
           </a:xfrm>
           <a:prstGeom prst="rect">
             <a:avLst/>

</xml_diff>